<commit_message>
Revise final OCR wording and evaluation readiness
</commit_message>
<xml_diff>
--- a/Report and PPT/Final_COOP2_External_Presentation.pptx
+++ b/Report and PPT/Final_COOP2_External_Presentation.pptx
@@ -22,6 +22,7 @@
     <p:sldId id="264" r:id="rId19"/>
     <p:sldId id="265" r:id="rId20"/>
     <p:sldId id="266" r:id="rId21"/>
+    <p:sldId id="267" r:id="rId22"/>
   </p:sldIdLst>
   <p:sldSz cx="12191695" cy="6858000" type="screen4x3"/>
   <p:notesSz cx="7559675" cy="10691813"/>
@@ -3817,7 +3818,7 @@
                 </a:solidFill>
                 <a:latin typeface="Aptos"/>
               </a:rPr>
-              <a:t>Synthetic OCR Accuracy</a:t>
+              <a:t>Submission Status</a:t>
             </a:r>
           </a:p>
         </p:txBody>
@@ -3851,7 +3852,7 @@
                 </a:solidFill>
                 <a:latin typeface="Aptos"/>
               </a:rPr>
-              <a:t>91.5%</a:t>
+              <a:t>GitHub Ready</a:t>
             </a:r>
           </a:p>
         </p:txBody>
@@ -3979,14 +3980,48 @@
                 </a:solidFill>
                 <a:latin typeface="Aptos"/>
               </a:rPr>
-              <a:t>Conclusion And Future Scope</a:t>
-            </a:r>
-          </a:p>
-        </p:txBody>
-      </p:sp>
-      <p:sp>
-        <p:nvSpPr>
-          <p:cNvPr id="7" name="Rectangle 6"/>
+              <a:t>Evaluation Readiness</a:t>
+            </a:r>
+          </a:p>
+        </p:txBody>
+      </p:sp>
+      <p:sp>
+        <p:nvSpPr>
+          <p:cNvPr id="7" name="TextBox 6"/>
+          <p:cNvSpPr txBox="1"/>
+          <p:nvPr/>
+        </p:nvSpPr>
+        <p:spPr>
+          <a:xfrm>
+            <a:off x="530352" y="786384"/>
+            <a:ext cx="10607040" cy="292608"/>
+          </a:xfrm>
+          <a:prstGeom prst="rect">
+            <a:avLst/>
+          </a:prstGeom>
+          <a:noFill/>
+        </p:spPr>
+        <p:txBody>
+          <a:bodyPr wrap="square">
+            <a:normAutofit/>
+          </a:bodyPr>
+          <a:lstStyle/>
+          <a:p>
+            <a:r>
+              <a:rPr sz="1100" b="0">
+                <a:solidFill>
+                  <a:srgbClr val="566573"/>
+                </a:solidFill>
+                <a:latin typeface="Aptos"/>
+              </a:rPr>
+              <a:t>Mapped directly to the final marking areas.</a:t>
+            </a:r>
+          </a:p>
+        </p:txBody>
+      </p:sp>
+      <p:sp>
+        <p:nvSpPr>
+          <p:cNvPr id="8" name="Rectangle 7"/>
           <p:cNvSpPr/>
           <p:nvPr/>
         </p:nvSpPr>
@@ -4031,14 +4066,59 @@
       </p:sp>
       <p:sp>
         <p:nvSpPr>
-          <p:cNvPr id="8" name="TextBox 7"/>
+          <p:cNvPr id="9" name="Rounded Rectangle 8"/>
+          <p:cNvSpPr/>
+          <p:nvPr/>
+        </p:nvSpPr>
+        <p:spPr>
+          <a:xfrm>
+            <a:off x="685800" y="1371600"/>
+            <a:ext cx="5120640" cy="960120"/>
+          </a:xfrm>
+          <a:prstGeom prst="roundRect">
+            <a:avLst/>
+          </a:prstGeom>
+          <a:solidFill>
+            <a:srgbClr val="FEF9E7"/>
+          </a:solidFill>
+          <a:ln>
+            <a:solidFill>
+              <a:srgbClr val="CCD1D1"/>
+            </a:solidFill>
+          </a:ln>
+        </p:spPr>
+        <p:style>
+          <a:lnRef idx="1">
+            <a:schemeClr val="accent1"/>
+          </a:lnRef>
+          <a:fillRef idx="3">
+            <a:schemeClr val="accent1"/>
+          </a:fillRef>
+          <a:effectRef idx="2">
+            <a:schemeClr val="accent1"/>
+          </a:effectRef>
+          <a:fontRef idx="minor">
+            <a:schemeClr val="lt1"/>
+          </a:fontRef>
+        </p:style>
+        <p:txBody>
+          <a:bodyPr rtlCol="0" anchor="ctr"/>
+          <a:lstStyle/>
+          <a:p>
+            <a:pPr algn="ctr"/>
+          </a:p>
+        </p:txBody>
+      </p:sp>
+      <p:sp>
+        <p:nvSpPr>
+          <p:cNvPr id="10" name="TextBox 9"/>
           <p:cNvSpPr txBox="1"/>
           <p:nvPr/>
         </p:nvSpPr>
         <p:spPr>
           <a:xfrm>
-            <a:off x="822960" y="1463040"/>
-            <a:ext cx="10241280" cy="4297680"/>
+            <a:off x="850392" y="1481328"/>
+            <a:ext cx="4791455" cy="256032"/>
           </a:xfrm>
           <a:prstGeom prst="rect">
             <a:avLst/>
@@ -4051,8 +4131,415 @@
           </a:bodyPr>
           <a:lstStyle/>
           <a:p>
+            <a:r>
+              <a:rPr sz="1000" b="1">
+                <a:solidFill>
+                  <a:srgbClr val="566573"/>
+                </a:solidFill>
+                <a:latin typeface="Aptos"/>
+              </a:rPr>
+              <a:t>Filing Status</a:t>
+            </a:r>
+          </a:p>
+        </p:txBody>
+      </p:sp>
+      <p:sp>
+        <p:nvSpPr>
+          <p:cNvPr id="11" name="TextBox 10"/>
+          <p:cNvSpPr txBox="1"/>
+          <p:nvPr/>
+        </p:nvSpPr>
+        <p:spPr>
+          <a:xfrm>
+            <a:off x="850392" y="1773936"/>
+            <a:ext cx="4791455" cy="484632"/>
+          </a:xfrm>
+          <a:prstGeom prst="rect">
+            <a:avLst/>
+          </a:prstGeom>
+          <a:noFill/>
+        </p:spPr>
+        <p:txBody>
+          <a:bodyPr wrap="square">
+            <a:normAutofit/>
+          </a:bodyPr>
+          <a:lstStyle/>
+          <a:p>
+            <a:r>
+              <a:rPr sz="2000" b="1">
+                <a:solidFill>
+                  <a:srgbClr val="0B3C5D"/>
+                </a:solidFill>
+                <a:latin typeface="Aptos"/>
+              </a:rPr>
+              <a:t>IPR proof folder and copyright placeholder</a:t>
+            </a:r>
+          </a:p>
+        </p:txBody>
+      </p:sp>
+      <p:sp>
+        <p:nvSpPr>
+          <p:cNvPr id="12" name="Rounded Rectangle 11"/>
+          <p:cNvSpPr/>
+          <p:nvPr/>
+        </p:nvSpPr>
+        <p:spPr>
+          <a:xfrm>
+            <a:off x="6400800" y="1371600"/>
+            <a:ext cx="5120640" cy="960120"/>
+          </a:xfrm>
+          <a:prstGeom prst="roundRect">
+            <a:avLst/>
+          </a:prstGeom>
+          <a:solidFill>
+            <a:srgbClr val="EAF2F8"/>
+          </a:solidFill>
+          <a:ln>
+            <a:solidFill>
+              <a:srgbClr val="CCD1D1"/>
+            </a:solidFill>
+          </a:ln>
+        </p:spPr>
+        <p:style>
+          <a:lnRef idx="1">
+            <a:schemeClr val="accent1"/>
+          </a:lnRef>
+          <a:fillRef idx="3">
+            <a:schemeClr val="accent1"/>
+          </a:fillRef>
+          <a:effectRef idx="2">
+            <a:schemeClr val="accent1"/>
+          </a:effectRef>
+          <a:fontRef idx="minor">
+            <a:schemeClr val="lt1"/>
+          </a:fontRef>
+        </p:style>
+        <p:txBody>
+          <a:bodyPr rtlCol="0" anchor="ctr"/>
+          <a:lstStyle/>
+          <a:p>
+            <a:pPr algn="ctr"/>
+          </a:p>
+        </p:txBody>
+      </p:sp>
+      <p:sp>
+        <p:nvSpPr>
+          <p:cNvPr id="13" name="TextBox 12"/>
+          <p:cNvSpPr txBox="1"/>
+          <p:nvPr/>
+        </p:nvSpPr>
+        <p:spPr>
+          <a:xfrm>
+            <a:off x="6565392" y="1481328"/>
+            <a:ext cx="4791455" cy="256032"/>
+          </a:xfrm>
+          <a:prstGeom prst="rect">
+            <a:avLst/>
+          </a:prstGeom>
+          <a:noFill/>
+        </p:spPr>
+        <p:txBody>
+          <a:bodyPr wrap="square">
+            <a:normAutofit/>
+          </a:bodyPr>
+          <a:lstStyle/>
+          <a:p>
+            <a:r>
+              <a:rPr sz="1000" b="1">
+                <a:solidFill>
+                  <a:srgbClr val="566573"/>
+                </a:solidFill>
+                <a:latin typeface="Aptos"/>
+              </a:rPr>
+              <a:t>Platform Compliance</a:t>
+            </a:r>
+          </a:p>
+        </p:txBody>
+      </p:sp>
+      <p:sp>
+        <p:nvSpPr>
+          <p:cNvPr id="14" name="TextBox 13"/>
+          <p:cNvSpPr txBox="1"/>
+          <p:nvPr/>
+        </p:nvSpPr>
+        <p:spPr>
+          <a:xfrm>
+            <a:off x="6565392" y="1773936"/>
+            <a:ext cx="4791455" cy="484632"/>
+          </a:xfrm>
+          <a:prstGeom prst="rect">
+            <a:avLst/>
+          </a:prstGeom>
+          <a:noFill/>
+        </p:spPr>
+        <p:txBody>
+          <a:bodyPr wrap="square">
+            <a:normAutofit/>
+          </a:bodyPr>
+          <a:lstStyle/>
+          <a:p>
+            <a:r>
+              <a:rPr sz="2000" b="1">
+                <a:solidFill>
+                  <a:srgbClr val="0B3C5D"/>
+                </a:solidFill>
+                <a:latin typeface="Aptos"/>
+              </a:rPr>
+              <a:t>Required GitHub folders and runnable code</a:t>
+            </a:r>
+          </a:p>
+        </p:txBody>
+      </p:sp>
+      <p:sp>
+        <p:nvSpPr>
+          <p:cNvPr id="15" name="Rounded Rectangle 14"/>
+          <p:cNvSpPr/>
+          <p:nvPr/>
+        </p:nvSpPr>
+        <p:spPr>
+          <a:xfrm>
+            <a:off x="685800" y="2788920"/>
+            <a:ext cx="5120640" cy="960120"/>
+          </a:xfrm>
+          <a:prstGeom prst="roundRect">
+            <a:avLst/>
+          </a:prstGeom>
+          <a:solidFill>
+            <a:srgbClr val="E8F8F5"/>
+          </a:solidFill>
+          <a:ln>
+            <a:solidFill>
+              <a:srgbClr val="CCD1D1"/>
+            </a:solidFill>
+          </a:ln>
+        </p:spPr>
+        <p:style>
+          <a:lnRef idx="1">
+            <a:schemeClr val="accent1"/>
+          </a:lnRef>
+          <a:fillRef idx="3">
+            <a:schemeClr val="accent1"/>
+          </a:fillRef>
+          <a:effectRef idx="2">
+            <a:schemeClr val="accent1"/>
+          </a:effectRef>
+          <a:fontRef idx="minor">
+            <a:schemeClr val="lt1"/>
+          </a:fontRef>
+        </p:style>
+        <p:txBody>
+          <a:bodyPr rtlCol="0" anchor="ctr"/>
+          <a:lstStyle/>
+          <a:p>
+            <a:pPr algn="ctr"/>
+          </a:p>
+        </p:txBody>
+      </p:sp>
+      <p:sp>
+        <p:nvSpPr>
+          <p:cNvPr id="16" name="TextBox 15"/>
+          <p:cNvSpPr txBox="1"/>
+          <p:nvPr/>
+        </p:nvSpPr>
+        <p:spPr>
+          <a:xfrm>
+            <a:off x="850392" y="2898648"/>
+            <a:ext cx="4791455" cy="256032"/>
+          </a:xfrm>
+          <a:prstGeom prst="rect">
+            <a:avLst/>
+          </a:prstGeom>
+          <a:noFill/>
+        </p:spPr>
+        <p:txBody>
+          <a:bodyPr wrap="square">
+            <a:normAutofit/>
+          </a:bodyPr>
+          <a:lstStyle/>
+          <a:p>
+            <a:r>
+              <a:rPr sz="1000" b="1">
+                <a:solidFill>
+                  <a:srgbClr val="566573"/>
+                </a:solidFill>
+                <a:latin typeface="Aptos"/>
+              </a:rPr>
+              <a:t>Revision Handling</a:t>
+            </a:r>
+          </a:p>
+        </p:txBody>
+      </p:sp>
+      <p:sp>
+        <p:nvSpPr>
+          <p:cNvPr id="17" name="TextBox 16"/>
+          <p:cNvSpPr txBox="1"/>
+          <p:nvPr/>
+        </p:nvSpPr>
+        <p:spPr>
+          <a:xfrm>
+            <a:off x="850392" y="3191256"/>
+            <a:ext cx="4791455" cy="484632"/>
+          </a:xfrm>
+          <a:prstGeom prst="rect">
+            <a:avLst/>
+          </a:prstGeom>
+          <a:noFill/>
+        </p:spPr>
+        <p:txBody>
+          <a:bodyPr wrap="square">
+            <a:normAutofit/>
+          </a:bodyPr>
+          <a:lstStyle/>
+          <a:p>
+            <a:r>
+              <a:rPr sz="2000" b="1">
+                <a:solidFill>
+                  <a:srgbClr val="0B3C5D"/>
+                </a:solidFill>
+                <a:latin typeface="Aptos"/>
+              </a:rPr>
+              <a:t>Report, PPT, README, figures, templates, generator</a:t>
+            </a:r>
+          </a:p>
+        </p:txBody>
+      </p:sp>
+      <p:sp>
+        <p:nvSpPr>
+          <p:cNvPr id="18" name="Rounded Rectangle 17"/>
+          <p:cNvSpPr/>
+          <p:nvPr/>
+        </p:nvSpPr>
+        <p:spPr>
+          <a:xfrm>
+            <a:off x="6400800" y="2788920"/>
+            <a:ext cx="5120640" cy="960120"/>
+          </a:xfrm>
+          <a:prstGeom prst="roundRect">
+            <a:avLst/>
+          </a:prstGeom>
+          <a:solidFill>
+            <a:srgbClr val="F4ECF7"/>
+          </a:solidFill>
+          <a:ln>
+            <a:solidFill>
+              <a:srgbClr val="CCD1D1"/>
+            </a:solidFill>
+          </a:ln>
+        </p:spPr>
+        <p:style>
+          <a:lnRef idx="1">
+            <a:schemeClr val="accent1"/>
+          </a:lnRef>
+          <a:fillRef idx="3">
+            <a:schemeClr val="accent1"/>
+          </a:fillRef>
+          <a:effectRef idx="2">
+            <a:schemeClr val="accent1"/>
+          </a:effectRef>
+          <a:fontRef idx="minor">
+            <a:schemeClr val="lt1"/>
+          </a:fontRef>
+        </p:style>
+        <p:txBody>
+          <a:bodyPr rtlCol="0" anchor="ctr"/>
+          <a:lstStyle/>
+          <a:p>
+            <a:pPr algn="ctr"/>
+          </a:p>
+        </p:txBody>
+      </p:sp>
+      <p:sp>
+        <p:nvSpPr>
+          <p:cNvPr id="19" name="TextBox 18"/>
+          <p:cNvSpPr txBox="1"/>
+          <p:nvPr/>
+        </p:nvSpPr>
+        <p:spPr>
+          <a:xfrm>
+            <a:off x="6565392" y="2898648"/>
+            <a:ext cx="4791455" cy="256032"/>
+          </a:xfrm>
+          <a:prstGeom prst="rect">
+            <a:avLst/>
+          </a:prstGeom>
+          <a:noFill/>
+        </p:spPr>
+        <p:txBody>
+          <a:bodyPr wrap="square">
+            <a:normAutofit/>
+          </a:bodyPr>
+          <a:lstStyle/>
+          <a:p>
+            <a:r>
+              <a:rPr sz="1000" b="1">
+                <a:solidFill>
+                  <a:srgbClr val="566573"/>
+                </a:solidFill>
+                <a:latin typeface="Aptos"/>
+              </a:rPr>
+              <a:t>Supervisor Updates</a:t>
+            </a:r>
+          </a:p>
+        </p:txBody>
+      </p:sp>
+      <p:sp>
+        <p:nvSpPr>
+          <p:cNvPr id="20" name="TextBox 19"/>
+          <p:cNvSpPr txBox="1"/>
+          <p:nvPr/>
+        </p:nvSpPr>
+        <p:spPr>
+          <a:xfrm>
+            <a:off x="6565392" y="3191256"/>
+            <a:ext cx="4791455" cy="484632"/>
+          </a:xfrm>
+          <a:prstGeom prst="rect">
+            <a:avLst/>
+          </a:prstGeom>
+          <a:noFill/>
+        </p:spPr>
+        <p:txBody>
+          <a:bodyPr wrap="square">
+            <a:normAutofit/>
+          </a:bodyPr>
+          <a:lstStyle/>
+          <a:p>
+            <a:r>
+              <a:rPr sz="2000" b="1">
+                <a:solidFill>
+                  <a:srgbClr val="0B3C5D"/>
+                </a:solidFill>
+                <a:latin typeface="Aptos"/>
+              </a:rPr>
+              <a:t>Progress and feedback reflected in final documentation</a:t>
+            </a:r>
+          </a:p>
+        </p:txBody>
+      </p:sp>
+      <p:sp>
+        <p:nvSpPr>
+          <p:cNvPr id="21" name="TextBox 20"/>
+          <p:cNvSpPr txBox="1"/>
+          <p:nvPr/>
+        </p:nvSpPr>
+        <p:spPr>
+          <a:xfrm>
+            <a:off x="914400" y="4572000"/>
+            <a:ext cx="10241280" cy="914400"/>
+          </a:xfrm>
+          <a:prstGeom prst="rect">
+            <a:avLst/>
+          </a:prstGeom>
+          <a:noFill/>
+        </p:spPr>
+        <p:txBody>
+          <a:bodyPr wrap="square">
+            <a:normAutofit/>
+          </a:bodyPr>
+          <a:lstStyle/>
+          <a:p>
             <a:pPr>
-              <a:defRPr sz="1800">
+              <a:defRPr sz="1600">
                 <a:solidFill>
                   <a:srgbClr val="1B2631"/>
                 </a:solidFill>
@@ -4060,12 +4547,12 @@
               </a:defRPr>
             </a:pPr>
             <a:r>
-              <a:t>Delivered a reproducible AI-based loan risk assessment package.</a:t>
+              <a:t>Repository is organized for external verification.</a:t>
             </a:r>
           </a:p>
           <a:p>
             <a:pPr>
-              <a:defRPr sz="1800">
+              <a:defRPr sz="1600">
                 <a:solidFill>
                   <a:srgbClr val="1B2631"/>
                 </a:solidFill>
@@ -4073,33 +4560,7 @@
               </a:defRPr>
             </a:pPr>
             <a:r>
-              <a:t>Credit-scoring benchmark identifies strong transparent baselines.</a:t>
-            </a:r>
-          </a:p>
-          <a:p>
-            <a:pPr>
-              <a:defRPr sz="1800">
-                <a:solidFill>
-                  <a:srgbClr val="1B2631"/>
-                </a:solidFill>
-                <a:latin typeface="Aptos"/>
-              </a:defRPr>
-            </a:pPr>
-            <a:r>
-              <a:t>OCR workflow shows practical document-intake extension potential.</a:t>
-            </a:r>
-          </a:p>
-          <a:p>
-            <a:pPr>
-              <a:defRPr sz="1800">
-                <a:solidFill>
-                  <a:srgbClr val="1B2631"/>
-                </a:solidFill>
-                <a:latin typeface="Aptos"/>
-              </a:defRPr>
-            </a:pPr>
-            <a:r>
-              <a:t>Future work: larger Lending Club experiments, SHAP explanations, scanned-form OCR evaluation, and API deployment.</a:t>
+              <a:t>Final documents explain the project, evidence, run commands, and submission status.</a:t>
             </a:r>
           </a:p>
         </p:txBody>
@@ -4206,6 +4667,254 @@
         </p:nvSpPr>
         <p:spPr>
           <a:xfrm>
+            <a:off x="502920" y="256032"/>
+            <a:ext cx="11155680" cy="502920"/>
+          </a:xfrm>
+          <a:prstGeom prst="rect">
+            <a:avLst/>
+          </a:prstGeom>
+          <a:noFill/>
+        </p:spPr>
+        <p:txBody>
+          <a:bodyPr wrap="square">
+            <a:normAutofit/>
+          </a:bodyPr>
+          <a:lstStyle/>
+          <a:p>
+            <a:r>
+              <a:rPr sz="2500" b="1">
+                <a:solidFill>
+                  <a:srgbClr val="0B3C5D"/>
+                </a:solidFill>
+                <a:latin typeface="Aptos"/>
+              </a:rPr>
+              <a:t>Conclusion And Future Scope</a:t>
+            </a:r>
+          </a:p>
+        </p:txBody>
+      </p:sp>
+      <p:sp>
+        <p:nvSpPr>
+          <p:cNvPr id="7" name="Rectangle 6"/>
+          <p:cNvSpPr/>
+          <p:nvPr/>
+        </p:nvSpPr>
+        <p:spPr>
+          <a:xfrm>
+            <a:off x="530352" y="1078992"/>
+            <a:ext cx="1920240" cy="27432"/>
+          </a:xfrm>
+          <a:prstGeom prst="rect">
+            <a:avLst/>
+          </a:prstGeom>
+          <a:solidFill>
+            <a:srgbClr val="D68910"/>
+          </a:solidFill>
+          <a:ln>
+            <a:solidFill>
+              <a:srgbClr val="D68910"/>
+            </a:solidFill>
+          </a:ln>
+        </p:spPr>
+        <p:style>
+          <a:lnRef idx="1">
+            <a:schemeClr val="accent1"/>
+          </a:lnRef>
+          <a:fillRef idx="3">
+            <a:schemeClr val="accent1"/>
+          </a:fillRef>
+          <a:effectRef idx="2">
+            <a:schemeClr val="accent1"/>
+          </a:effectRef>
+          <a:fontRef idx="minor">
+            <a:schemeClr val="lt1"/>
+          </a:fontRef>
+        </p:style>
+        <p:txBody>
+          <a:bodyPr rtlCol="0" anchor="ctr"/>
+          <a:lstStyle/>
+          <a:p>
+            <a:pPr algn="ctr"/>
+          </a:p>
+        </p:txBody>
+      </p:sp>
+      <p:sp>
+        <p:nvSpPr>
+          <p:cNvPr id="8" name="TextBox 7"/>
+          <p:cNvSpPr txBox="1"/>
+          <p:nvPr/>
+        </p:nvSpPr>
+        <p:spPr>
+          <a:xfrm>
+            <a:off x="822960" y="1463040"/>
+            <a:ext cx="10241280" cy="4297680"/>
+          </a:xfrm>
+          <a:prstGeom prst="rect">
+            <a:avLst/>
+          </a:prstGeom>
+          <a:noFill/>
+        </p:spPr>
+        <p:txBody>
+          <a:bodyPr wrap="square">
+            <a:normAutofit/>
+          </a:bodyPr>
+          <a:lstStyle/>
+          <a:p>
+            <a:pPr>
+              <a:defRPr sz="1800">
+                <a:solidFill>
+                  <a:srgbClr val="1B2631"/>
+                </a:solidFill>
+                <a:latin typeface="Aptos"/>
+              </a:defRPr>
+            </a:pPr>
+            <a:r>
+              <a:t>Delivered a reproducible AI-based loan risk assessment package.</a:t>
+            </a:r>
+          </a:p>
+          <a:p>
+            <a:pPr>
+              <a:defRPr sz="1800">
+                <a:solidFill>
+                  <a:srgbClr val="1B2631"/>
+                </a:solidFill>
+                <a:latin typeface="Aptos"/>
+              </a:defRPr>
+            </a:pPr>
+            <a:r>
+              <a:t>Credit-scoring benchmark identifies strong transparent baselines.</a:t>
+            </a:r>
+          </a:p>
+          <a:p>
+            <a:pPr>
+              <a:defRPr sz="1800">
+                <a:solidFill>
+                  <a:srgbClr val="1B2631"/>
+                </a:solidFill>
+                <a:latin typeface="Aptos"/>
+              </a:defRPr>
+            </a:pPr>
+            <a:r>
+              <a:t>OCR workflow shows practical document-intake extension potential.</a:t>
+            </a:r>
+          </a:p>
+          <a:p>
+            <a:pPr>
+              <a:defRPr sz="1800">
+                <a:solidFill>
+                  <a:srgbClr val="1B2631"/>
+                </a:solidFill>
+                <a:latin typeface="Aptos"/>
+              </a:defRPr>
+            </a:pPr>
+            <a:r>
+              <a:t>Future work: larger Lending Club experiments, SHAP explanations, scanned-form OCR evaluation, and API deployment.</a:t>
+            </a:r>
+          </a:p>
+        </p:txBody>
+      </p:sp>
+    </p:spTree>
+  </p:cSld>
+  <p:clrMapOvr>
+    <a:masterClrMapping/>
+  </p:clrMapOvr>
+</p:sld>
+</file>
+
+<file path=ppt/slides/slide12.xml><?xml version="1.0" encoding="utf-8"?>
+<p:sld xmlns:a="http://schemas.openxmlformats.org/drawingml/2006/main" xmlns:p="http://schemas.openxmlformats.org/presentationml/2006/main" xmlns:r="http://schemas.openxmlformats.org/officeDocument/2006/relationships">
+  <p:cSld>
+    <p:bg>
+      <p:bgPr>
+        <a:solidFill>
+          <a:srgbClr val="F7F9FB"/>
+        </a:solidFill>
+        <a:effectLst/>
+      </p:bgPr>
+    </p:bg>
+    <p:spTree>
+      <p:nvGrpSpPr>
+        <p:cNvPr id="1" name=""/>
+        <p:cNvGrpSpPr/>
+        <p:nvPr/>
+      </p:nvGrpSpPr>
+      <p:grpSpPr/>
+      <p:sp>
+        <p:nvSpPr>
+          <p:cNvPr id="2" name="Title 1"/>
+          <p:cNvSpPr>
+            <a:spLocks noGrp="1"/>
+          </p:cNvSpPr>
+          <p:nvPr>
+            <p:ph type="title"/>
+          </p:nvPr>
+        </p:nvSpPr>
+        <p:spPr/>
+        <p:txBody>
+          <a:bodyPr/>
+          <a:lstStyle/>
+          <a:p/>
+        </p:txBody>
+      </p:sp>
+      <p:sp>
+        <p:nvSpPr>
+          <p:cNvPr id="3" name="Text Placeholder 2"/>
+          <p:cNvSpPr>
+            <a:spLocks noGrp="1"/>
+          </p:cNvSpPr>
+          <p:nvPr>
+            <p:ph type="body"/>
+          </p:nvPr>
+        </p:nvSpPr>
+        <p:spPr/>
+        <p:txBody>
+          <a:bodyPr/>
+          <a:lstStyle/>
+          <a:p/>
+        </p:txBody>
+      </p:sp>
+      <p:sp>
+        <p:nvSpPr>
+          <p:cNvPr id="4" name="Text Placeholder 3"/>
+          <p:cNvSpPr>
+            <a:spLocks noGrp="1"/>
+          </p:cNvSpPr>
+          <p:nvPr>
+            <p:ph type="body"/>
+          </p:nvPr>
+        </p:nvSpPr>
+        <p:spPr/>
+        <p:txBody>
+          <a:bodyPr/>
+          <a:lstStyle/>
+          <a:p/>
+        </p:txBody>
+      </p:sp>
+      <p:sp>
+        <p:nvSpPr>
+          <p:cNvPr id="5" name="Text Placeholder 4"/>
+          <p:cNvSpPr>
+            <a:spLocks noGrp="1"/>
+          </p:cNvSpPr>
+          <p:nvPr>
+            <p:ph type="body"/>
+          </p:nvPr>
+        </p:nvSpPr>
+        <p:spPr/>
+        <p:txBody>
+          <a:bodyPr/>
+          <a:lstStyle/>
+          <a:p/>
+        </p:txBody>
+      </p:sp>
+      <p:sp>
+        <p:nvSpPr>
+          <p:cNvPr id="6" name="TextBox 5"/>
+          <p:cNvSpPr txBox="1"/>
+          <p:nvPr/>
+        </p:nvSpPr>
+        <p:spPr>
+          <a:xfrm>
             <a:off x="685800" y="1737360"/>
             <a:ext cx="10881360" cy="822960"/>
           </a:xfrm>
@@ -5185,7 +5894,7 @@
               </a:defRPr>
             </a:pPr>
             <a:r>
-              <a:t>Demonstrate PaddleOCR fine-tuning value through labeled synthetic benchmarking.</a:t>
+              <a:t>Implement PaddleOCR workflow for borrower-document intake and field extraction.</a:t>
             </a:r>
           </a:p>
           <a:p>
@@ -6280,7 +6989,7 @@
                 </a:solidFill>
                 <a:latin typeface="Aptos"/>
               </a:rPr>
-              <a:t>PaddleOCR Controlled Synthetic Benchmark</a:t>
+              <a:t>PaddleOCR Workflow Overview</a:t>
             </a:r>
           </a:p>
         </p:txBody>
@@ -6314,7 +7023,7 @@
                 </a:solidFill>
                 <a:latin typeface="Aptos"/>
               </a:rPr>
-              <a:t>Clearly disclosed synthetic benchmark for finance-document recognition.</a:t>
+              <a:t>Document-intake design for scanned borrower forms.</a:t>
             </a:r>
           </a:p>
         </p:txBody>
@@ -6366,7 +7075,7 @@
       </p:sp>
       <p:pic>
         <p:nvPicPr>
-          <p:cNvPr id="9" name="Picture 8" descr="ocr_synthetic_benchmark.png"/>
+          <p:cNvPr id="9" name="Picture 8" descr="ocr_workflow_overview.png"/>
           <p:cNvPicPr>
             <a:picLocks noChangeAspect="1"/>
           </p:cNvPicPr>
@@ -6381,7 +7090,7 @@
         <p:spPr>
           <a:xfrm>
             <a:off x="731520" y="1325880"/>
-            <a:ext cx="6035040" cy="2528969"/>
+            <a:ext cx="6035040" cy="2461272"/>
           </a:xfrm>
           <a:prstGeom prst="rect">
             <a:avLst/>
@@ -6419,7 +7128,7 @@
               </a:defRPr>
             </a:pPr>
             <a:r>
-              <a:t>Baseline PaddleOCR: CER 8.7%, field accuracy 81.0%.</a:t>
+              <a:t>Pipeline covers upload, preprocessing, OCR recognition, field extraction, and review queue.</a:t>
             </a:r>
           </a:p>
           <a:p>
@@ -6432,7 +7141,7 @@
               </a:defRPr>
             </a:pPr>
             <a:r>
-              <a:t>Fine-tuned PaddleOCR: CER 4.1%, field accuracy 91.5%.</a:t>
+              <a:t>Designed to connect document intake with credit-risk assessment.</a:t>
             </a:r>
           </a:p>
           <a:p>
@@ -6445,7 +7154,7 @@
               </a:defRPr>
             </a:pPr>
             <a:r>
-              <a:t>Values are deterministic controlled synthetic benchmark results, not production claims.</a:t>
+              <a:t>Ready for evaluation once real scanned borrower documents and verified labels are available.</a:t>
             </a:r>
           </a:p>
         </p:txBody>

</xml_diff>

<commit_message>
Add real OCR fine-tuning package
</commit_message>
<xml_diff>
--- a/Report and PPT/Final_COOP2_External_Presentation.pptx
+++ b/Report and PPT/Final_COOP2_External_Presentation.pptx
@@ -23,6 +23,7 @@
     <p:sldId id="265" r:id="rId20"/>
     <p:sldId id="266" r:id="rId21"/>
     <p:sldId id="267" r:id="rId22"/>
+    <p:sldId id="268" r:id="rId23"/>
   </p:sldIdLst>
   <p:sldSz cx="12191695" cy="6858000" type="screen4x3"/>
   <p:notesSz cx="7559675" cy="10691813"/>
@@ -3980,48 +3981,14 @@
                 </a:solidFill>
                 <a:latin typeface="Aptos"/>
               </a:rPr>
-              <a:t>Evaluation Readiness</a:t>
-            </a:r>
-          </a:p>
-        </p:txBody>
-      </p:sp>
-      <p:sp>
-        <p:nvSpPr>
-          <p:cNvPr id="7" name="TextBox 6"/>
-          <p:cNvSpPr txBox="1"/>
-          <p:nvPr/>
-        </p:nvSpPr>
-        <p:spPr>
-          <a:xfrm>
-            <a:off x="530352" y="786384"/>
-            <a:ext cx="10607040" cy="292608"/>
-          </a:xfrm>
-          <a:prstGeom prst="rect">
-            <a:avLst/>
-          </a:prstGeom>
-          <a:noFill/>
-        </p:spPr>
-        <p:txBody>
-          <a:bodyPr wrap="square">
-            <a:normAutofit/>
-          </a:bodyPr>
-          <a:lstStyle/>
-          <a:p>
-            <a:r>
-              <a:rPr sz="1100" b="0">
-                <a:solidFill>
-                  <a:srgbClr val="566573"/>
-                </a:solidFill>
-                <a:latin typeface="Aptos"/>
-              </a:rPr>
-              <a:t>Mapped directly to the final marking areas.</a:t>
-            </a:r>
-          </a:p>
-        </p:txBody>
-      </p:sp>
-      <p:sp>
-        <p:nvSpPr>
-          <p:cNvPr id="8" name="Rectangle 7"/>
+              <a:t>GitHub Submission Structure</a:t>
+            </a:r>
+          </a:p>
+        </p:txBody>
+      </p:sp>
+      <p:sp>
+        <p:nvSpPr>
+          <p:cNvPr id="7" name="Rectangle 6"/>
           <p:cNvSpPr/>
           <p:nvPr/>
         </p:nvSpPr>
@@ -4066,59 +4033,14 @@
       </p:sp>
       <p:sp>
         <p:nvSpPr>
-          <p:cNvPr id="9" name="Rounded Rectangle 8"/>
-          <p:cNvSpPr/>
-          <p:nvPr/>
-        </p:nvSpPr>
-        <p:spPr>
-          <a:xfrm>
-            <a:off x="685800" y="1371600"/>
-            <a:ext cx="5120640" cy="960120"/>
-          </a:xfrm>
-          <a:prstGeom prst="roundRect">
-            <a:avLst/>
-          </a:prstGeom>
-          <a:solidFill>
-            <a:srgbClr val="FEF9E7"/>
-          </a:solidFill>
-          <a:ln>
-            <a:solidFill>
-              <a:srgbClr val="CCD1D1"/>
-            </a:solidFill>
-          </a:ln>
-        </p:spPr>
-        <p:style>
-          <a:lnRef idx="1">
-            <a:schemeClr val="accent1"/>
-          </a:lnRef>
-          <a:fillRef idx="3">
-            <a:schemeClr val="accent1"/>
-          </a:fillRef>
-          <a:effectRef idx="2">
-            <a:schemeClr val="accent1"/>
-          </a:effectRef>
-          <a:fontRef idx="minor">
-            <a:schemeClr val="lt1"/>
-          </a:fontRef>
-        </p:style>
-        <p:txBody>
-          <a:bodyPr rtlCol="0" anchor="ctr"/>
-          <a:lstStyle/>
-          <a:p>
-            <a:pPr algn="ctr"/>
-          </a:p>
-        </p:txBody>
-      </p:sp>
-      <p:sp>
-        <p:nvSpPr>
-          <p:cNvPr id="10" name="TextBox 9"/>
+          <p:cNvPr id="8" name="TextBox 7"/>
           <p:cNvSpPr txBox="1"/>
           <p:nvPr/>
         </p:nvSpPr>
         <p:spPr>
           <a:xfrm>
-            <a:off x="850392" y="1481328"/>
-            <a:ext cx="4791455" cy="256032"/>
+            <a:off x="822960" y="1417320"/>
+            <a:ext cx="10241280" cy="4480560"/>
           </a:xfrm>
           <a:prstGeom prst="rect">
             <a:avLst/>
@@ -4131,415 +4053,8 @@
           </a:bodyPr>
           <a:lstStyle/>
           <a:p>
-            <a:r>
-              <a:rPr sz="1000" b="1">
-                <a:solidFill>
-                  <a:srgbClr val="566573"/>
-                </a:solidFill>
-                <a:latin typeface="Aptos"/>
-              </a:rPr>
-              <a:t>Filing Status</a:t>
-            </a:r>
-          </a:p>
-        </p:txBody>
-      </p:sp>
-      <p:sp>
-        <p:nvSpPr>
-          <p:cNvPr id="11" name="TextBox 10"/>
-          <p:cNvSpPr txBox="1"/>
-          <p:nvPr/>
-        </p:nvSpPr>
-        <p:spPr>
-          <a:xfrm>
-            <a:off x="850392" y="1773936"/>
-            <a:ext cx="4791455" cy="484632"/>
-          </a:xfrm>
-          <a:prstGeom prst="rect">
-            <a:avLst/>
-          </a:prstGeom>
-          <a:noFill/>
-        </p:spPr>
-        <p:txBody>
-          <a:bodyPr wrap="square">
-            <a:normAutofit/>
-          </a:bodyPr>
-          <a:lstStyle/>
-          <a:p>
-            <a:r>
-              <a:rPr sz="2000" b="1">
-                <a:solidFill>
-                  <a:srgbClr val="0B3C5D"/>
-                </a:solidFill>
-                <a:latin typeface="Aptos"/>
-              </a:rPr>
-              <a:t>IPR proof folder and copyright placeholder</a:t>
-            </a:r>
-          </a:p>
-        </p:txBody>
-      </p:sp>
-      <p:sp>
-        <p:nvSpPr>
-          <p:cNvPr id="12" name="Rounded Rectangle 11"/>
-          <p:cNvSpPr/>
-          <p:nvPr/>
-        </p:nvSpPr>
-        <p:spPr>
-          <a:xfrm>
-            <a:off x="6400800" y="1371600"/>
-            <a:ext cx="5120640" cy="960120"/>
-          </a:xfrm>
-          <a:prstGeom prst="roundRect">
-            <a:avLst/>
-          </a:prstGeom>
-          <a:solidFill>
-            <a:srgbClr val="EAF2F8"/>
-          </a:solidFill>
-          <a:ln>
-            <a:solidFill>
-              <a:srgbClr val="CCD1D1"/>
-            </a:solidFill>
-          </a:ln>
-        </p:spPr>
-        <p:style>
-          <a:lnRef idx="1">
-            <a:schemeClr val="accent1"/>
-          </a:lnRef>
-          <a:fillRef idx="3">
-            <a:schemeClr val="accent1"/>
-          </a:fillRef>
-          <a:effectRef idx="2">
-            <a:schemeClr val="accent1"/>
-          </a:effectRef>
-          <a:fontRef idx="minor">
-            <a:schemeClr val="lt1"/>
-          </a:fontRef>
-        </p:style>
-        <p:txBody>
-          <a:bodyPr rtlCol="0" anchor="ctr"/>
-          <a:lstStyle/>
-          <a:p>
-            <a:pPr algn="ctr"/>
-          </a:p>
-        </p:txBody>
-      </p:sp>
-      <p:sp>
-        <p:nvSpPr>
-          <p:cNvPr id="13" name="TextBox 12"/>
-          <p:cNvSpPr txBox="1"/>
-          <p:nvPr/>
-        </p:nvSpPr>
-        <p:spPr>
-          <a:xfrm>
-            <a:off x="6565392" y="1481328"/>
-            <a:ext cx="4791455" cy="256032"/>
-          </a:xfrm>
-          <a:prstGeom prst="rect">
-            <a:avLst/>
-          </a:prstGeom>
-          <a:noFill/>
-        </p:spPr>
-        <p:txBody>
-          <a:bodyPr wrap="square">
-            <a:normAutofit/>
-          </a:bodyPr>
-          <a:lstStyle/>
-          <a:p>
-            <a:r>
-              <a:rPr sz="1000" b="1">
-                <a:solidFill>
-                  <a:srgbClr val="566573"/>
-                </a:solidFill>
-                <a:latin typeface="Aptos"/>
-              </a:rPr>
-              <a:t>Platform Compliance</a:t>
-            </a:r>
-          </a:p>
-        </p:txBody>
-      </p:sp>
-      <p:sp>
-        <p:nvSpPr>
-          <p:cNvPr id="14" name="TextBox 13"/>
-          <p:cNvSpPr txBox="1"/>
-          <p:nvPr/>
-        </p:nvSpPr>
-        <p:spPr>
-          <a:xfrm>
-            <a:off x="6565392" y="1773936"/>
-            <a:ext cx="4791455" cy="484632"/>
-          </a:xfrm>
-          <a:prstGeom prst="rect">
-            <a:avLst/>
-          </a:prstGeom>
-          <a:noFill/>
-        </p:spPr>
-        <p:txBody>
-          <a:bodyPr wrap="square">
-            <a:normAutofit/>
-          </a:bodyPr>
-          <a:lstStyle/>
-          <a:p>
-            <a:r>
-              <a:rPr sz="2000" b="1">
-                <a:solidFill>
-                  <a:srgbClr val="0B3C5D"/>
-                </a:solidFill>
-                <a:latin typeface="Aptos"/>
-              </a:rPr>
-              <a:t>Required GitHub folders and runnable code</a:t>
-            </a:r>
-          </a:p>
-        </p:txBody>
-      </p:sp>
-      <p:sp>
-        <p:nvSpPr>
-          <p:cNvPr id="15" name="Rounded Rectangle 14"/>
-          <p:cNvSpPr/>
-          <p:nvPr/>
-        </p:nvSpPr>
-        <p:spPr>
-          <a:xfrm>
-            <a:off x="685800" y="2788920"/>
-            <a:ext cx="5120640" cy="960120"/>
-          </a:xfrm>
-          <a:prstGeom prst="roundRect">
-            <a:avLst/>
-          </a:prstGeom>
-          <a:solidFill>
-            <a:srgbClr val="E8F8F5"/>
-          </a:solidFill>
-          <a:ln>
-            <a:solidFill>
-              <a:srgbClr val="CCD1D1"/>
-            </a:solidFill>
-          </a:ln>
-        </p:spPr>
-        <p:style>
-          <a:lnRef idx="1">
-            <a:schemeClr val="accent1"/>
-          </a:lnRef>
-          <a:fillRef idx="3">
-            <a:schemeClr val="accent1"/>
-          </a:fillRef>
-          <a:effectRef idx="2">
-            <a:schemeClr val="accent1"/>
-          </a:effectRef>
-          <a:fontRef idx="minor">
-            <a:schemeClr val="lt1"/>
-          </a:fontRef>
-        </p:style>
-        <p:txBody>
-          <a:bodyPr rtlCol="0" anchor="ctr"/>
-          <a:lstStyle/>
-          <a:p>
-            <a:pPr algn="ctr"/>
-          </a:p>
-        </p:txBody>
-      </p:sp>
-      <p:sp>
-        <p:nvSpPr>
-          <p:cNvPr id="16" name="TextBox 15"/>
-          <p:cNvSpPr txBox="1"/>
-          <p:nvPr/>
-        </p:nvSpPr>
-        <p:spPr>
-          <a:xfrm>
-            <a:off x="850392" y="2898648"/>
-            <a:ext cx="4791455" cy="256032"/>
-          </a:xfrm>
-          <a:prstGeom prst="rect">
-            <a:avLst/>
-          </a:prstGeom>
-          <a:noFill/>
-        </p:spPr>
-        <p:txBody>
-          <a:bodyPr wrap="square">
-            <a:normAutofit/>
-          </a:bodyPr>
-          <a:lstStyle/>
-          <a:p>
-            <a:r>
-              <a:rPr sz="1000" b="1">
-                <a:solidFill>
-                  <a:srgbClr val="566573"/>
-                </a:solidFill>
-                <a:latin typeface="Aptos"/>
-              </a:rPr>
-              <a:t>Revision Handling</a:t>
-            </a:r>
-          </a:p>
-        </p:txBody>
-      </p:sp>
-      <p:sp>
-        <p:nvSpPr>
-          <p:cNvPr id="17" name="TextBox 16"/>
-          <p:cNvSpPr txBox="1"/>
-          <p:nvPr/>
-        </p:nvSpPr>
-        <p:spPr>
-          <a:xfrm>
-            <a:off x="850392" y="3191256"/>
-            <a:ext cx="4791455" cy="484632"/>
-          </a:xfrm>
-          <a:prstGeom prst="rect">
-            <a:avLst/>
-          </a:prstGeom>
-          <a:noFill/>
-        </p:spPr>
-        <p:txBody>
-          <a:bodyPr wrap="square">
-            <a:normAutofit/>
-          </a:bodyPr>
-          <a:lstStyle/>
-          <a:p>
-            <a:r>
-              <a:rPr sz="2000" b="1">
-                <a:solidFill>
-                  <a:srgbClr val="0B3C5D"/>
-                </a:solidFill>
-                <a:latin typeface="Aptos"/>
-              </a:rPr>
-              <a:t>Report, PPT, README, figures, templates, generator</a:t>
-            </a:r>
-          </a:p>
-        </p:txBody>
-      </p:sp>
-      <p:sp>
-        <p:nvSpPr>
-          <p:cNvPr id="18" name="Rounded Rectangle 17"/>
-          <p:cNvSpPr/>
-          <p:nvPr/>
-        </p:nvSpPr>
-        <p:spPr>
-          <a:xfrm>
-            <a:off x="6400800" y="2788920"/>
-            <a:ext cx="5120640" cy="960120"/>
-          </a:xfrm>
-          <a:prstGeom prst="roundRect">
-            <a:avLst/>
-          </a:prstGeom>
-          <a:solidFill>
-            <a:srgbClr val="F4ECF7"/>
-          </a:solidFill>
-          <a:ln>
-            <a:solidFill>
-              <a:srgbClr val="CCD1D1"/>
-            </a:solidFill>
-          </a:ln>
-        </p:spPr>
-        <p:style>
-          <a:lnRef idx="1">
-            <a:schemeClr val="accent1"/>
-          </a:lnRef>
-          <a:fillRef idx="3">
-            <a:schemeClr val="accent1"/>
-          </a:fillRef>
-          <a:effectRef idx="2">
-            <a:schemeClr val="accent1"/>
-          </a:effectRef>
-          <a:fontRef idx="minor">
-            <a:schemeClr val="lt1"/>
-          </a:fontRef>
-        </p:style>
-        <p:txBody>
-          <a:bodyPr rtlCol="0" anchor="ctr"/>
-          <a:lstStyle/>
-          <a:p>
-            <a:pPr algn="ctr"/>
-          </a:p>
-        </p:txBody>
-      </p:sp>
-      <p:sp>
-        <p:nvSpPr>
-          <p:cNvPr id="19" name="TextBox 18"/>
-          <p:cNvSpPr txBox="1"/>
-          <p:nvPr/>
-        </p:nvSpPr>
-        <p:spPr>
-          <a:xfrm>
-            <a:off x="6565392" y="2898648"/>
-            <a:ext cx="4791455" cy="256032"/>
-          </a:xfrm>
-          <a:prstGeom prst="rect">
-            <a:avLst/>
-          </a:prstGeom>
-          <a:noFill/>
-        </p:spPr>
-        <p:txBody>
-          <a:bodyPr wrap="square">
-            <a:normAutofit/>
-          </a:bodyPr>
-          <a:lstStyle/>
-          <a:p>
-            <a:r>
-              <a:rPr sz="1000" b="1">
-                <a:solidFill>
-                  <a:srgbClr val="566573"/>
-                </a:solidFill>
-                <a:latin typeface="Aptos"/>
-              </a:rPr>
-              <a:t>Supervisor Updates</a:t>
-            </a:r>
-          </a:p>
-        </p:txBody>
-      </p:sp>
-      <p:sp>
-        <p:nvSpPr>
-          <p:cNvPr id="20" name="TextBox 19"/>
-          <p:cNvSpPr txBox="1"/>
-          <p:nvPr/>
-        </p:nvSpPr>
-        <p:spPr>
-          <a:xfrm>
-            <a:off x="6565392" y="3191256"/>
-            <a:ext cx="4791455" cy="484632"/>
-          </a:xfrm>
-          <a:prstGeom prst="rect">
-            <a:avLst/>
-          </a:prstGeom>
-          <a:noFill/>
-        </p:spPr>
-        <p:txBody>
-          <a:bodyPr wrap="square">
-            <a:normAutofit/>
-          </a:bodyPr>
-          <a:lstStyle/>
-          <a:p>
-            <a:r>
-              <a:rPr sz="2000" b="1">
-                <a:solidFill>
-                  <a:srgbClr val="0B3C5D"/>
-                </a:solidFill>
-                <a:latin typeface="Aptos"/>
-              </a:rPr>
-              <a:t>Progress and feedback reflected in final documentation</a:t>
-            </a:r>
-          </a:p>
-        </p:txBody>
-      </p:sp>
-      <p:sp>
-        <p:nvSpPr>
-          <p:cNvPr id="21" name="TextBox 20"/>
-          <p:cNvSpPr txBox="1"/>
-          <p:nvPr/>
-        </p:nvSpPr>
-        <p:spPr>
-          <a:xfrm>
-            <a:off x="914400" y="4572000"/>
-            <a:ext cx="10241280" cy="914400"/>
-          </a:xfrm>
-          <a:prstGeom prst="rect">
-            <a:avLst/>
-          </a:prstGeom>
-          <a:noFill/>
-        </p:spPr>
-        <p:txBody>
-          <a:bodyPr wrap="square">
-            <a:normAutofit/>
-          </a:bodyPr>
-          <a:lstStyle/>
-          <a:p>
             <a:pPr>
-              <a:defRPr sz="1600">
+              <a:defRPr sz="1800">
                 <a:solidFill>
                   <a:srgbClr val="1B2631"/>
                 </a:solidFill>
@@ -4547,12 +4062,12 @@
               </a:defRPr>
             </a:pPr>
             <a:r>
-              <a:t>Repository is organized for external verification.</a:t>
+              <a:t>IPR Submission Proof: placeholder for copyright form and screenshot.</a:t>
             </a:r>
           </a:p>
           <a:p>
             <a:pPr>
-              <a:defRPr sz="1600">
+              <a:defRPr sz="1800">
                 <a:solidFill>
                   <a:srgbClr val="1B2631"/>
                 </a:solidFill>
@@ -4560,7 +4075,33 @@
               </a:defRPr>
             </a:pPr>
             <a:r>
-              <a:t>Final documents explain the project, evidence, run commands, and submission status.</a:t>
+              <a:t>Report and PPT: final DOCX, PPTX, templates, markdown, and figures.</a:t>
+            </a:r>
+          </a:p>
+          <a:p>
+            <a:pPr>
+              <a:defRPr sz="1800">
+                <a:solidFill>
+                  <a:srgbClr val="1B2631"/>
+                </a:solidFill>
+                <a:latin typeface="Aptos"/>
+              </a:defRPr>
+            </a:pPr>
+            <a:r>
+              <a:t>Source code: runnable code, configs, tests, data samples, and artifacts.</a:t>
+            </a:r>
+          </a:p>
+          <a:p>
+            <a:pPr>
+              <a:defRPr sz="1800">
+                <a:solidFill>
+                  <a:srgbClr val="1B2631"/>
+                </a:solidFill>
+                <a:latin typeface="Aptos"/>
+              </a:defRPr>
+            </a:pPr>
+            <a:r>
+              <a:t>README.md: team details, project type, status, and run instructions.</a:t>
             </a:r>
           </a:p>
         </p:txBody>
@@ -4688,14 +4229,48 @@
                 </a:solidFill>
                 <a:latin typeface="Aptos"/>
               </a:rPr>
-              <a:t>Conclusion And Future Scope</a:t>
-            </a:r>
-          </a:p>
-        </p:txBody>
-      </p:sp>
-      <p:sp>
-        <p:nvSpPr>
-          <p:cNvPr id="7" name="Rectangle 6"/>
+              <a:t>Evaluation Readiness</a:t>
+            </a:r>
+          </a:p>
+        </p:txBody>
+      </p:sp>
+      <p:sp>
+        <p:nvSpPr>
+          <p:cNvPr id="7" name="TextBox 6"/>
+          <p:cNvSpPr txBox="1"/>
+          <p:nvPr/>
+        </p:nvSpPr>
+        <p:spPr>
+          <a:xfrm>
+            <a:off x="530352" y="786384"/>
+            <a:ext cx="10607040" cy="292608"/>
+          </a:xfrm>
+          <a:prstGeom prst="rect">
+            <a:avLst/>
+          </a:prstGeom>
+          <a:noFill/>
+        </p:spPr>
+        <p:txBody>
+          <a:bodyPr wrap="square">
+            <a:normAutofit/>
+          </a:bodyPr>
+          <a:lstStyle/>
+          <a:p>
+            <a:r>
+              <a:rPr sz="1100" b="0">
+                <a:solidFill>
+                  <a:srgbClr val="566573"/>
+                </a:solidFill>
+                <a:latin typeface="Aptos"/>
+              </a:rPr>
+              <a:t>Mapped directly to the final marking areas.</a:t>
+            </a:r>
+          </a:p>
+        </p:txBody>
+      </p:sp>
+      <p:sp>
+        <p:nvSpPr>
+          <p:cNvPr id="8" name="Rectangle 7"/>
           <p:cNvSpPr/>
           <p:nvPr/>
         </p:nvSpPr>
@@ -4740,14 +4315,59 @@
       </p:sp>
       <p:sp>
         <p:nvSpPr>
-          <p:cNvPr id="8" name="TextBox 7"/>
+          <p:cNvPr id="9" name="Rounded Rectangle 8"/>
+          <p:cNvSpPr/>
+          <p:nvPr/>
+        </p:nvSpPr>
+        <p:spPr>
+          <a:xfrm>
+            <a:off x="685800" y="1371600"/>
+            <a:ext cx="5120640" cy="960120"/>
+          </a:xfrm>
+          <a:prstGeom prst="roundRect">
+            <a:avLst/>
+          </a:prstGeom>
+          <a:solidFill>
+            <a:srgbClr val="FEF9E7"/>
+          </a:solidFill>
+          <a:ln>
+            <a:solidFill>
+              <a:srgbClr val="CCD1D1"/>
+            </a:solidFill>
+          </a:ln>
+        </p:spPr>
+        <p:style>
+          <a:lnRef idx="1">
+            <a:schemeClr val="accent1"/>
+          </a:lnRef>
+          <a:fillRef idx="3">
+            <a:schemeClr val="accent1"/>
+          </a:fillRef>
+          <a:effectRef idx="2">
+            <a:schemeClr val="accent1"/>
+          </a:effectRef>
+          <a:fontRef idx="minor">
+            <a:schemeClr val="lt1"/>
+          </a:fontRef>
+        </p:style>
+        <p:txBody>
+          <a:bodyPr rtlCol="0" anchor="ctr"/>
+          <a:lstStyle/>
+          <a:p>
+            <a:pPr algn="ctr"/>
+          </a:p>
+        </p:txBody>
+      </p:sp>
+      <p:sp>
+        <p:nvSpPr>
+          <p:cNvPr id="10" name="TextBox 9"/>
           <p:cNvSpPr txBox="1"/>
           <p:nvPr/>
         </p:nvSpPr>
         <p:spPr>
           <a:xfrm>
-            <a:off x="822960" y="1463040"/>
-            <a:ext cx="10241280" cy="4297680"/>
+            <a:off x="850392" y="1481328"/>
+            <a:ext cx="4791455" cy="256032"/>
           </a:xfrm>
           <a:prstGeom prst="rect">
             <a:avLst/>
@@ -4760,8 +4380,415 @@
           </a:bodyPr>
           <a:lstStyle/>
           <a:p>
+            <a:r>
+              <a:rPr sz="1000" b="1">
+                <a:solidFill>
+                  <a:srgbClr val="566573"/>
+                </a:solidFill>
+                <a:latin typeface="Aptos"/>
+              </a:rPr>
+              <a:t>Filing Status</a:t>
+            </a:r>
+          </a:p>
+        </p:txBody>
+      </p:sp>
+      <p:sp>
+        <p:nvSpPr>
+          <p:cNvPr id="11" name="TextBox 10"/>
+          <p:cNvSpPr txBox="1"/>
+          <p:nvPr/>
+        </p:nvSpPr>
+        <p:spPr>
+          <a:xfrm>
+            <a:off x="850392" y="1773936"/>
+            <a:ext cx="4791455" cy="484632"/>
+          </a:xfrm>
+          <a:prstGeom prst="rect">
+            <a:avLst/>
+          </a:prstGeom>
+          <a:noFill/>
+        </p:spPr>
+        <p:txBody>
+          <a:bodyPr wrap="square">
+            <a:normAutofit/>
+          </a:bodyPr>
+          <a:lstStyle/>
+          <a:p>
+            <a:r>
+              <a:rPr sz="2000" b="1">
+                <a:solidFill>
+                  <a:srgbClr val="0B3C5D"/>
+                </a:solidFill>
+                <a:latin typeface="Aptos"/>
+              </a:rPr>
+              <a:t>IPR proof folder and copyright placeholder</a:t>
+            </a:r>
+          </a:p>
+        </p:txBody>
+      </p:sp>
+      <p:sp>
+        <p:nvSpPr>
+          <p:cNvPr id="12" name="Rounded Rectangle 11"/>
+          <p:cNvSpPr/>
+          <p:nvPr/>
+        </p:nvSpPr>
+        <p:spPr>
+          <a:xfrm>
+            <a:off x="6400800" y="1371600"/>
+            <a:ext cx="5120640" cy="960120"/>
+          </a:xfrm>
+          <a:prstGeom prst="roundRect">
+            <a:avLst/>
+          </a:prstGeom>
+          <a:solidFill>
+            <a:srgbClr val="EAF2F8"/>
+          </a:solidFill>
+          <a:ln>
+            <a:solidFill>
+              <a:srgbClr val="CCD1D1"/>
+            </a:solidFill>
+          </a:ln>
+        </p:spPr>
+        <p:style>
+          <a:lnRef idx="1">
+            <a:schemeClr val="accent1"/>
+          </a:lnRef>
+          <a:fillRef idx="3">
+            <a:schemeClr val="accent1"/>
+          </a:fillRef>
+          <a:effectRef idx="2">
+            <a:schemeClr val="accent1"/>
+          </a:effectRef>
+          <a:fontRef idx="minor">
+            <a:schemeClr val="lt1"/>
+          </a:fontRef>
+        </p:style>
+        <p:txBody>
+          <a:bodyPr rtlCol="0" anchor="ctr"/>
+          <a:lstStyle/>
+          <a:p>
+            <a:pPr algn="ctr"/>
+          </a:p>
+        </p:txBody>
+      </p:sp>
+      <p:sp>
+        <p:nvSpPr>
+          <p:cNvPr id="13" name="TextBox 12"/>
+          <p:cNvSpPr txBox="1"/>
+          <p:nvPr/>
+        </p:nvSpPr>
+        <p:spPr>
+          <a:xfrm>
+            <a:off x="6565392" y="1481328"/>
+            <a:ext cx="4791455" cy="256032"/>
+          </a:xfrm>
+          <a:prstGeom prst="rect">
+            <a:avLst/>
+          </a:prstGeom>
+          <a:noFill/>
+        </p:spPr>
+        <p:txBody>
+          <a:bodyPr wrap="square">
+            <a:normAutofit/>
+          </a:bodyPr>
+          <a:lstStyle/>
+          <a:p>
+            <a:r>
+              <a:rPr sz="1000" b="1">
+                <a:solidFill>
+                  <a:srgbClr val="566573"/>
+                </a:solidFill>
+                <a:latin typeface="Aptos"/>
+              </a:rPr>
+              <a:t>Platform Compliance</a:t>
+            </a:r>
+          </a:p>
+        </p:txBody>
+      </p:sp>
+      <p:sp>
+        <p:nvSpPr>
+          <p:cNvPr id="14" name="TextBox 13"/>
+          <p:cNvSpPr txBox="1"/>
+          <p:nvPr/>
+        </p:nvSpPr>
+        <p:spPr>
+          <a:xfrm>
+            <a:off x="6565392" y="1773936"/>
+            <a:ext cx="4791455" cy="484632"/>
+          </a:xfrm>
+          <a:prstGeom prst="rect">
+            <a:avLst/>
+          </a:prstGeom>
+          <a:noFill/>
+        </p:spPr>
+        <p:txBody>
+          <a:bodyPr wrap="square">
+            <a:normAutofit/>
+          </a:bodyPr>
+          <a:lstStyle/>
+          <a:p>
+            <a:r>
+              <a:rPr sz="2000" b="1">
+                <a:solidFill>
+                  <a:srgbClr val="0B3C5D"/>
+                </a:solidFill>
+                <a:latin typeface="Aptos"/>
+              </a:rPr>
+              <a:t>Required GitHub folders and runnable code</a:t>
+            </a:r>
+          </a:p>
+        </p:txBody>
+      </p:sp>
+      <p:sp>
+        <p:nvSpPr>
+          <p:cNvPr id="15" name="Rounded Rectangle 14"/>
+          <p:cNvSpPr/>
+          <p:nvPr/>
+        </p:nvSpPr>
+        <p:spPr>
+          <a:xfrm>
+            <a:off x="685800" y="2788920"/>
+            <a:ext cx="5120640" cy="960120"/>
+          </a:xfrm>
+          <a:prstGeom prst="roundRect">
+            <a:avLst/>
+          </a:prstGeom>
+          <a:solidFill>
+            <a:srgbClr val="E8F8F5"/>
+          </a:solidFill>
+          <a:ln>
+            <a:solidFill>
+              <a:srgbClr val="CCD1D1"/>
+            </a:solidFill>
+          </a:ln>
+        </p:spPr>
+        <p:style>
+          <a:lnRef idx="1">
+            <a:schemeClr val="accent1"/>
+          </a:lnRef>
+          <a:fillRef idx="3">
+            <a:schemeClr val="accent1"/>
+          </a:fillRef>
+          <a:effectRef idx="2">
+            <a:schemeClr val="accent1"/>
+          </a:effectRef>
+          <a:fontRef idx="minor">
+            <a:schemeClr val="lt1"/>
+          </a:fontRef>
+        </p:style>
+        <p:txBody>
+          <a:bodyPr rtlCol="0" anchor="ctr"/>
+          <a:lstStyle/>
+          <a:p>
+            <a:pPr algn="ctr"/>
+          </a:p>
+        </p:txBody>
+      </p:sp>
+      <p:sp>
+        <p:nvSpPr>
+          <p:cNvPr id="16" name="TextBox 15"/>
+          <p:cNvSpPr txBox="1"/>
+          <p:nvPr/>
+        </p:nvSpPr>
+        <p:spPr>
+          <a:xfrm>
+            <a:off x="850392" y="2898648"/>
+            <a:ext cx="4791455" cy="256032"/>
+          </a:xfrm>
+          <a:prstGeom prst="rect">
+            <a:avLst/>
+          </a:prstGeom>
+          <a:noFill/>
+        </p:spPr>
+        <p:txBody>
+          <a:bodyPr wrap="square">
+            <a:normAutofit/>
+          </a:bodyPr>
+          <a:lstStyle/>
+          <a:p>
+            <a:r>
+              <a:rPr sz="1000" b="1">
+                <a:solidFill>
+                  <a:srgbClr val="566573"/>
+                </a:solidFill>
+                <a:latin typeface="Aptos"/>
+              </a:rPr>
+              <a:t>Revision Handling</a:t>
+            </a:r>
+          </a:p>
+        </p:txBody>
+      </p:sp>
+      <p:sp>
+        <p:nvSpPr>
+          <p:cNvPr id="17" name="TextBox 16"/>
+          <p:cNvSpPr txBox="1"/>
+          <p:nvPr/>
+        </p:nvSpPr>
+        <p:spPr>
+          <a:xfrm>
+            <a:off x="850392" y="3191256"/>
+            <a:ext cx="4791455" cy="484632"/>
+          </a:xfrm>
+          <a:prstGeom prst="rect">
+            <a:avLst/>
+          </a:prstGeom>
+          <a:noFill/>
+        </p:spPr>
+        <p:txBody>
+          <a:bodyPr wrap="square">
+            <a:normAutofit/>
+          </a:bodyPr>
+          <a:lstStyle/>
+          <a:p>
+            <a:r>
+              <a:rPr sz="2000" b="1">
+                <a:solidFill>
+                  <a:srgbClr val="0B3C5D"/>
+                </a:solidFill>
+                <a:latin typeface="Aptos"/>
+              </a:rPr>
+              <a:t>Report, PPT, README, figures, templates, generator</a:t>
+            </a:r>
+          </a:p>
+        </p:txBody>
+      </p:sp>
+      <p:sp>
+        <p:nvSpPr>
+          <p:cNvPr id="18" name="Rounded Rectangle 17"/>
+          <p:cNvSpPr/>
+          <p:nvPr/>
+        </p:nvSpPr>
+        <p:spPr>
+          <a:xfrm>
+            <a:off x="6400800" y="2788920"/>
+            <a:ext cx="5120640" cy="960120"/>
+          </a:xfrm>
+          <a:prstGeom prst="roundRect">
+            <a:avLst/>
+          </a:prstGeom>
+          <a:solidFill>
+            <a:srgbClr val="F4ECF7"/>
+          </a:solidFill>
+          <a:ln>
+            <a:solidFill>
+              <a:srgbClr val="CCD1D1"/>
+            </a:solidFill>
+          </a:ln>
+        </p:spPr>
+        <p:style>
+          <a:lnRef idx="1">
+            <a:schemeClr val="accent1"/>
+          </a:lnRef>
+          <a:fillRef idx="3">
+            <a:schemeClr val="accent1"/>
+          </a:fillRef>
+          <a:effectRef idx="2">
+            <a:schemeClr val="accent1"/>
+          </a:effectRef>
+          <a:fontRef idx="minor">
+            <a:schemeClr val="lt1"/>
+          </a:fontRef>
+        </p:style>
+        <p:txBody>
+          <a:bodyPr rtlCol="0" anchor="ctr"/>
+          <a:lstStyle/>
+          <a:p>
+            <a:pPr algn="ctr"/>
+          </a:p>
+        </p:txBody>
+      </p:sp>
+      <p:sp>
+        <p:nvSpPr>
+          <p:cNvPr id="19" name="TextBox 18"/>
+          <p:cNvSpPr txBox="1"/>
+          <p:nvPr/>
+        </p:nvSpPr>
+        <p:spPr>
+          <a:xfrm>
+            <a:off x="6565392" y="2898648"/>
+            <a:ext cx="4791455" cy="256032"/>
+          </a:xfrm>
+          <a:prstGeom prst="rect">
+            <a:avLst/>
+          </a:prstGeom>
+          <a:noFill/>
+        </p:spPr>
+        <p:txBody>
+          <a:bodyPr wrap="square">
+            <a:normAutofit/>
+          </a:bodyPr>
+          <a:lstStyle/>
+          <a:p>
+            <a:r>
+              <a:rPr sz="1000" b="1">
+                <a:solidFill>
+                  <a:srgbClr val="566573"/>
+                </a:solidFill>
+                <a:latin typeface="Aptos"/>
+              </a:rPr>
+              <a:t>Supervisor Updates</a:t>
+            </a:r>
+          </a:p>
+        </p:txBody>
+      </p:sp>
+      <p:sp>
+        <p:nvSpPr>
+          <p:cNvPr id="20" name="TextBox 19"/>
+          <p:cNvSpPr txBox="1"/>
+          <p:nvPr/>
+        </p:nvSpPr>
+        <p:spPr>
+          <a:xfrm>
+            <a:off x="6565392" y="3191256"/>
+            <a:ext cx="4791455" cy="484632"/>
+          </a:xfrm>
+          <a:prstGeom prst="rect">
+            <a:avLst/>
+          </a:prstGeom>
+          <a:noFill/>
+        </p:spPr>
+        <p:txBody>
+          <a:bodyPr wrap="square">
+            <a:normAutofit/>
+          </a:bodyPr>
+          <a:lstStyle/>
+          <a:p>
+            <a:r>
+              <a:rPr sz="2000" b="1">
+                <a:solidFill>
+                  <a:srgbClr val="0B3C5D"/>
+                </a:solidFill>
+                <a:latin typeface="Aptos"/>
+              </a:rPr>
+              <a:t>Progress and feedback reflected in final documentation</a:t>
+            </a:r>
+          </a:p>
+        </p:txBody>
+      </p:sp>
+      <p:sp>
+        <p:nvSpPr>
+          <p:cNvPr id="21" name="TextBox 20"/>
+          <p:cNvSpPr txBox="1"/>
+          <p:nvPr/>
+        </p:nvSpPr>
+        <p:spPr>
+          <a:xfrm>
+            <a:off x="914400" y="4572000"/>
+            <a:ext cx="10241280" cy="914400"/>
+          </a:xfrm>
+          <a:prstGeom prst="rect">
+            <a:avLst/>
+          </a:prstGeom>
+          <a:noFill/>
+        </p:spPr>
+        <p:txBody>
+          <a:bodyPr wrap="square">
+            <a:normAutofit/>
+          </a:bodyPr>
+          <a:lstStyle/>
+          <a:p>
             <a:pPr>
-              <a:defRPr sz="1800">
+              <a:defRPr sz="1600">
                 <a:solidFill>
                   <a:srgbClr val="1B2631"/>
                 </a:solidFill>
@@ -4769,12 +4796,12 @@
               </a:defRPr>
             </a:pPr>
             <a:r>
-              <a:t>Delivered a reproducible AI-based loan risk assessment package.</a:t>
+              <a:t>Repository is organized for external verification.</a:t>
             </a:r>
           </a:p>
           <a:p>
             <a:pPr>
-              <a:defRPr sz="1800">
+              <a:defRPr sz="1600">
                 <a:solidFill>
                   <a:srgbClr val="1B2631"/>
                 </a:solidFill>
@@ -4782,33 +4809,7 @@
               </a:defRPr>
             </a:pPr>
             <a:r>
-              <a:t>Credit-scoring benchmark identifies strong transparent baselines.</a:t>
-            </a:r>
-          </a:p>
-          <a:p>
-            <a:pPr>
-              <a:defRPr sz="1800">
-                <a:solidFill>
-                  <a:srgbClr val="1B2631"/>
-                </a:solidFill>
-                <a:latin typeface="Aptos"/>
-              </a:defRPr>
-            </a:pPr>
-            <a:r>
-              <a:t>OCR workflow shows practical document-intake extension potential.</a:t>
-            </a:r>
-          </a:p>
-          <a:p>
-            <a:pPr>
-              <a:defRPr sz="1800">
-                <a:solidFill>
-                  <a:srgbClr val="1B2631"/>
-                </a:solidFill>
-                <a:latin typeface="Aptos"/>
-              </a:defRPr>
-            </a:pPr>
-            <a:r>
-              <a:t>Future work: larger Lending Club experiments, SHAP explanations, scanned-form OCR evaluation, and API deployment.</a:t>
+              <a:t>Final documents explain the project, evidence, run commands, and submission status.</a:t>
             </a:r>
           </a:p>
         </p:txBody>
@@ -4915,6 +4916,254 @@
         </p:nvSpPr>
         <p:spPr>
           <a:xfrm>
+            <a:off x="502920" y="256032"/>
+            <a:ext cx="11155680" cy="502920"/>
+          </a:xfrm>
+          <a:prstGeom prst="rect">
+            <a:avLst/>
+          </a:prstGeom>
+          <a:noFill/>
+        </p:spPr>
+        <p:txBody>
+          <a:bodyPr wrap="square">
+            <a:normAutofit/>
+          </a:bodyPr>
+          <a:lstStyle/>
+          <a:p>
+            <a:r>
+              <a:rPr sz="2500" b="1">
+                <a:solidFill>
+                  <a:srgbClr val="0B3C5D"/>
+                </a:solidFill>
+                <a:latin typeface="Aptos"/>
+              </a:rPr>
+              <a:t>Conclusion And Future Scope</a:t>
+            </a:r>
+          </a:p>
+        </p:txBody>
+      </p:sp>
+      <p:sp>
+        <p:nvSpPr>
+          <p:cNvPr id="7" name="Rectangle 6"/>
+          <p:cNvSpPr/>
+          <p:nvPr/>
+        </p:nvSpPr>
+        <p:spPr>
+          <a:xfrm>
+            <a:off x="530352" y="1078992"/>
+            <a:ext cx="1920240" cy="27432"/>
+          </a:xfrm>
+          <a:prstGeom prst="rect">
+            <a:avLst/>
+          </a:prstGeom>
+          <a:solidFill>
+            <a:srgbClr val="D68910"/>
+          </a:solidFill>
+          <a:ln>
+            <a:solidFill>
+              <a:srgbClr val="D68910"/>
+            </a:solidFill>
+          </a:ln>
+        </p:spPr>
+        <p:style>
+          <a:lnRef idx="1">
+            <a:schemeClr val="accent1"/>
+          </a:lnRef>
+          <a:fillRef idx="3">
+            <a:schemeClr val="accent1"/>
+          </a:fillRef>
+          <a:effectRef idx="2">
+            <a:schemeClr val="accent1"/>
+          </a:effectRef>
+          <a:fontRef idx="minor">
+            <a:schemeClr val="lt1"/>
+          </a:fontRef>
+        </p:style>
+        <p:txBody>
+          <a:bodyPr rtlCol="0" anchor="ctr"/>
+          <a:lstStyle/>
+          <a:p>
+            <a:pPr algn="ctr"/>
+          </a:p>
+        </p:txBody>
+      </p:sp>
+      <p:sp>
+        <p:nvSpPr>
+          <p:cNvPr id="8" name="TextBox 7"/>
+          <p:cNvSpPr txBox="1"/>
+          <p:nvPr/>
+        </p:nvSpPr>
+        <p:spPr>
+          <a:xfrm>
+            <a:off x="822960" y="1463040"/>
+            <a:ext cx="10241280" cy="4297680"/>
+          </a:xfrm>
+          <a:prstGeom prst="rect">
+            <a:avLst/>
+          </a:prstGeom>
+          <a:noFill/>
+        </p:spPr>
+        <p:txBody>
+          <a:bodyPr wrap="square">
+            <a:normAutofit/>
+          </a:bodyPr>
+          <a:lstStyle/>
+          <a:p>
+            <a:pPr>
+              <a:defRPr sz="1800">
+                <a:solidFill>
+                  <a:srgbClr val="1B2631"/>
+                </a:solidFill>
+                <a:latin typeface="Aptos"/>
+              </a:defRPr>
+            </a:pPr>
+            <a:r>
+              <a:t>Delivered a reproducible AI-based loan risk assessment package.</a:t>
+            </a:r>
+          </a:p>
+          <a:p>
+            <a:pPr>
+              <a:defRPr sz="1800">
+                <a:solidFill>
+                  <a:srgbClr val="1B2631"/>
+                </a:solidFill>
+                <a:latin typeface="Aptos"/>
+              </a:defRPr>
+            </a:pPr>
+            <a:r>
+              <a:t>Credit-scoring benchmark identifies strong transparent baselines.</a:t>
+            </a:r>
+          </a:p>
+          <a:p>
+            <a:pPr>
+              <a:defRPr sz="1800">
+                <a:solidFill>
+                  <a:srgbClr val="1B2631"/>
+                </a:solidFill>
+                <a:latin typeface="Aptos"/>
+              </a:defRPr>
+            </a:pPr>
+            <a:r>
+              <a:t>OCR workflow shows practical document-intake extension potential.</a:t>
+            </a:r>
+          </a:p>
+          <a:p>
+            <a:pPr>
+              <a:defRPr sz="1800">
+                <a:solidFill>
+                  <a:srgbClr val="1B2631"/>
+                </a:solidFill>
+                <a:latin typeface="Aptos"/>
+              </a:defRPr>
+            </a:pPr>
+            <a:r>
+              <a:t>Future work: larger Lending Club experiments, SHAP explanations, scanned-form OCR evaluation, and API deployment.</a:t>
+            </a:r>
+          </a:p>
+        </p:txBody>
+      </p:sp>
+    </p:spTree>
+  </p:cSld>
+  <p:clrMapOvr>
+    <a:masterClrMapping/>
+  </p:clrMapOvr>
+</p:sld>
+</file>
+
+<file path=ppt/slides/slide13.xml><?xml version="1.0" encoding="utf-8"?>
+<p:sld xmlns:a="http://schemas.openxmlformats.org/drawingml/2006/main" xmlns:p="http://schemas.openxmlformats.org/presentationml/2006/main" xmlns:r="http://schemas.openxmlformats.org/officeDocument/2006/relationships">
+  <p:cSld>
+    <p:bg>
+      <p:bgPr>
+        <a:solidFill>
+          <a:srgbClr val="F7F9FB"/>
+        </a:solidFill>
+        <a:effectLst/>
+      </p:bgPr>
+    </p:bg>
+    <p:spTree>
+      <p:nvGrpSpPr>
+        <p:cNvPr id="1" name=""/>
+        <p:cNvGrpSpPr/>
+        <p:nvPr/>
+      </p:nvGrpSpPr>
+      <p:grpSpPr/>
+      <p:sp>
+        <p:nvSpPr>
+          <p:cNvPr id="2" name="Title 1"/>
+          <p:cNvSpPr>
+            <a:spLocks noGrp="1"/>
+          </p:cNvSpPr>
+          <p:nvPr>
+            <p:ph type="title"/>
+          </p:nvPr>
+        </p:nvSpPr>
+        <p:spPr/>
+        <p:txBody>
+          <a:bodyPr/>
+          <a:lstStyle/>
+          <a:p/>
+        </p:txBody>
+      </p:sp>
+      <p:sp>
+        <p:nvSpPr>
+          <p:cNvPr id="3" name="Text Placeholder 2"/>
+          <p:cNvSpPr>
+            <a:spLocks noGrp="1"/>
+          </p:cNvSpPr>
+          <p:nvPr>
+            <p:ph type="body"/>
+          </p:nvPr>
+        </p:nvSpPr>
+        <p:spPr/>
+        <p:txBody>
+          <a:bodyPr/>
+          <a:lstStyle/>
+          <a:p/>
+        </p:txBody>
+      </p:sp>
+      <p:sp>
+        <p:nvSpPr>
+          <p:cNvPr id="4" name="Text Placeholder 3"/>
+          <p:cNvSpPr>
+            <a:spLocks noGrp="1"/>
+          </p:cNvSpPr>
+          <p:nvPr>
+            <p:ph type="body"/>
+          </p:nvPr>
+        </p:nvSpPr>
+        <p:spPr/>
+        <p:txBody>
+          <a:bodyPr/>
+          <a:lstStyle/>
+          <a:p/>
+        </p:txBody>
+      </p:sp>
+      <p:sp>
+        <p:nvSpPr>
+          <p:cNvPr id="5" name="Text Placeholder 4"/>
+          <p:cNvSpPr>
+            <a:spLocks noGrp="1"/>
+          </p:cNvSpPr>
+          <p:nvPr>
+            <p:ph type="body"/>
+          </p:nvPr>
+        </p:nvSpPr>
+        <p:spPr/>
+        <p:txBody>
+          <a:bodyPr/>
+          <a:lstStyle/>
+          <a:p/>
+        </p:txBody>
+      </p:sp>
+      <p:sp>
+        <p:nvSpPr>
+          <p:cNvPr id="6" name="TextBox 5"/>
+          <p:cNvSpPr txBox="1"/>
+          <p:nvPr/>
+        </p:nvSpPr>
+        <p:spPr>
+          <a:xfrm>
             <a:off x="685800" y="1737360"/>
             <a:ext cx="10881360" cy="822960"/>
           </a:xfrm>
@@ -5894,7 +6143,7 @@
               </a:defRPr>
             </a:pPr>
             <a:r>
-              <a:t>Implement PaddleOCR workflow for borrower-document intake and field extraction.</a:t>
+              <a:t>Prepare real SROIE/FUNSD scanned-document data for PaddleOCR evaluation and fine-tuning.</a:t>
             </a:r>
           </a:p>
           <a:p>
@@ -6138,7 +6387,7 @@
                 </a:solidFill>
                 <a:latin typeface="Aptos"/>
               </a:rPr>
-              <a:t>Credit scoring is the core decision pipeline. OCR is the document-intake extension for borrower forms.</a:t>
+              <a:t>Credit scoring is the core decision pipeline. OCR is the real-data document-intake extension for borrower forms.</a:t>
             </a:r>
           </a:p>
         </p:txBody>
@@ -6989,7 +7238,7 @@
                 </a:solidFill>
                 <a:latin typeface="Aptos"/>
               </a:rPr>
-              <a:t>PaddleOCR Workflow Overview</a:t>
+              <a:t>Real PaddleOCR Data Pipeline</a:t>
             </a:r>
           </a:p>
         </p:txBody>
@@ -7023,7 +7272,7 @@
                 </a:solidFill>
                 <a:latin typeface="Aptos"/>
               </a:rPr>
-              <a:t>Document-intake design for scanned borrower forms.</a:t>
+              <a:t>SROIE receipts + FUNSD forms converted into PaddleOCR recognition labels.</a:t>
             </a:r>
           </a:p>
         </p:txBody>
@@ -7090,7 +7339,7 @@
         <p:spPr>
           <a:xfrm>
             <a:off x="731520" y="1325880"/>
-            <a:ext cx="6035040" cy="2461272"/>
+            <a:ext cx="6035040" cy="2374130"/>
           </a:xfrm>
           <a:prstGeom prst="rect">
             <a:avLst/>
@@ -7120,7 +7369,7 @@
           <a:lstStyle/>
           <a:p>
             <a:pPr>
-              <a:defRPr sz="1700">
+              <a:defRPr sz="1400">
                 <a:solidFill>
                   <a:srgbClr val="1B2631"/>
                 </a:solidFill>
@@ -7128,12 +7377,12 @@
               </a:defRPr>
             </a:pPr>
             <a:r>
-              <a:t>Pipeline covers upload, preprocessing, OCR recognition, field extraction, and review queue.</a:t>
+              <a:t>Real scanned-document sources: ICDAR2019 SROIE and FUNSD.</a:t>
             </a:r>
           </a:p>
           <a:p>
             <a:pPr>
-              <a:defRPr sz="1700">
+              <a:defRPr sz="1400">
                 <a:solidFill>
                   <a:srgbClr val="1B2631"/>
                 </a:solidFill>
@@ -7141,12 +7390,12 @@
               </a:defRPr>
             </a:pPr>
             <a:r>
-              <a:t>Designed to connect document intake with credit-risk assessment.</a:t>
+              <a:t>Converter exports train/validation/test labels for PaddleOCR SimpleDataSet.</a:t>
             </a:r>
           </a:p>
           <a:p>
             <a:pPr>
-              <a:defRPr sz="1700">
+              <a:defRPr sz="1400">
                 <a:solidFill>
                   <a:srgbClr val="1B2631"/>
                 </a:solidFill>
@@ -7154,7 +7403,20 @@
               </a:defRPr>
             </a:pPr>
             <a:r>
-              <a:t>Ready for evaluation once real scanned borrower documents and verified labels are available.</a:t>
+              <a:t>Baseline metrics are included only when generated from saved evaluation artifacts.</a:t>
+            </a:r>
+          </a:p>
+          <a:p>
+            <a:pPr>
+              <a:defRPr sz="1400">
+                <a:solidFill>
+                  <a:srgbClr val="1B2631"/>
+                </a:solidFill>
+                <a:latin typeface="Aptos"/>
+              </a:defRPr>
+            </a:pPr>
+            <a:r>
+              <a:t>Real SROIE/FUNSD OCR pipeline status: prepared_real_dataset. Prepared recognition crops: train: 1200, val: 300, test: 300.</a:t>
             </a:r>
           </a:p>
         </p:txBody>
@@ -7282,14 +7544,48 @@
                 </a:solidFill>
                 <a:latin typeface="Aptos"/>
               </a:rPr>
-              <a:t>Explainability And Traceability</a:t>
-            </a:r>
-          </a:p>
-        </p:txBody>
-      </p:sp>
-      <p:sp>
-        <p:nvSpPr>
-          <p:cNvPr id="7" name="Rectangle 6"/>
+              <a:t>Measured OCR Baseline</a:t>
+            </a:r>
+          </a:p>
+        </p:txBody>
+      </p:sp>
+      <p:sp>
+        <p:nvSpPr>
+          <p:cNvPr id="7" name="TextBox 6"/>
+          <p:cNvSpPr txBox="1"/>
+          <p:nvPr/>
+        </p:nvSpPr>
+        <p:spPr>
+          <a:xfrm>
+            <a:off x="530352" y="786384"/>
+            <a:ext cx="10607040" cy="292608"/>
+          </a:xfrm>
+          <a:prstGeom prst="rect">
+            <a:avLst/>
+          </a:prstGeom>
+          <a:noFill/>
+        </p:spPr>
+        <p:txBody>
+          <a:bodyPr wrap="square">
+            <a:normAutofit/>
+          </a:bodyPr>
+          <a:lstStyle/>
+          <a:p>
+            <a:r>
+              <a:rPr sz="1100" b="0">
+                <a:solidFill>
+                  <a:srgbClr val="566573"/>
+                </a:solidFill>
+                <a:latin typeface="Aptos"/>
+              </a:rPr>
+              <a:t>Traceable to artifacts/ocr/real_ocr_finetune/baseline.</a:t>
+            </a:r>
+          </a:p>
+        </p:txBody>
+      </p:sp>
+      <p:sp>
+        <p:nvSpPr>
+          <p:cNvPr id="8" name="Rectangle 7"/>
           <p:cNvSpPr/>
           <p:nvPr/>
         </p:nvSpPr>
@@ -7332,40 +7628,468 @@
           </a:p>
         </p:txBody>
       </p:sp>
-      <p:pic>
-        <p:nvPicPr>
-          <p:cNvPr id="8" name="Picture 7" descr="german-credit_feature_importance.png"/>
-          <p:cNvPicPr>
-            <a:picLocks noChangeAspect="1"/>
-          </p:cNvPicPr>
-          <p:nvPr/>
-        </p:nvPicPr>
-        <p:blipFill>
-          <a:blip r:embed="rId2"/>
-          <a:stretch>
-            <a:fillRect/>
-          </a:stretch>
-        </p:blipFill>
-        <p:spPr>
-          <a:xfrm>
-            <a:off x="731520" y="1325880"/>
-            <a:ext cx="5212080" cy="3257550"/>
-          </a:xfrm>
-          <a:prstGeom prst="rect">
-            <a:avLst/>
-          </a:prstGeom>
-        </p:spPr>
-      </p:pic>
-      <p:sp>
-        <p:nvSpPr>
-          <p:cNvPr id="9" name="TextBox 8"/>
+      <p:sp>
+        <p:nvSpPr>
+          <p:cNvPr id="9" name="Rounded Rectangle 8"/>
+          <p:cNvSpPr/>
+          <p:nvPr/>
+        </p:nvSpPr>
+        <p:spPr>
+          <a:xfrm>
+            <a:off x="777240" y="1508760"/>
+            <a:ext cx="2468880" cy="1143000"/>
+          </a:xfrm>
+          <a:prstGeom prst="roundRect">
+            <a:avLst/>
+          </a:prstGeom>
+          <a:solidFill>
+            <a:srgbClr val="FFFFFF"/>
+          </a:solidFill>
+          <a:ln>
+            <a:solidFill>
+              <a:srgbClr val="CCD1D1"/>
+            </a:solidFill>
+          </a:ln>
+        </p:spPr>
+        <p:style>
+          <a:lnRef idx="1">
+            <a:schemeClr val="accent1"/>
+          </a:lnRef>
+          <a:fillRef idx="3">
+            <a:schemeClr val="accent1"/>
+          </a:fillRef>
+          <a:effectRef idx="2">
+            <a:schemeClr val="accent1"/>
+          </a:effectRef>
+          <a:fontRef idx="minor">
+            <a:schemeClr val="lt1"/>
+          </a:fontRef>
+        </p:style>
+        <p:txBody>
+          <a:bodyPr rtlCol="0" anchor="ctr"/>
+          <a:lstStyle/>
+          <a:p>
+            <a:pPr algn="ctr"/>
+          </a:p>
+        </p:txBody>
+      </p:sp>
+      <p:sp>
+        <p:nvSpPr>
+          <p:cNvPr id="10" name="TextBox 9"/>
           <p:cNvSpPr txBox="1"/>
           <p:nvPr/>
         </p:nvSpPr>
         <p:spPr>
           <a:xfrm>
-            <a:off x="6446520" y="1645920"/>
-            <a:ext cx="4754880" cy="3108960"/>
+            <a:off x="941832" y="1618488"/>
+            <a:ext cx="2139696" cy="256032"/>
+          </a:xfrm>
+          <a:prstGeom prst="rect">
+            <a:avLst/>
+          </a:prstGeom>
+          <a:noFill/>
+        </p:spPr>
+        <p:txBody>
+          <a:bodyPr wrap="square">
+            <a:normAutofit/>
+          </a:bodyPr>
+          <a:lstStyle/>
+          <a:p>
+            <a:r>
+              <a:rPr sz="1000" b="1">
+                <a:solidFill>
+                  <a:srgbClr val="566573"/>
+                </a:solidFill>
+                <a:latin typeface="Aptos"/>
+              </a:rPr>
+              <a:t>Samples</a:t>
+            </a:r>
+          </a:p>
+        </p:txBody>
+      </p:sp>
+      <p:sp>
+        <p:nvSpPr>
+          <p:cNvPr id="11" name="TextBox 10"/>
+          <p:cNvSpPr txBox="1"/>
+          <p:nvPr/>
+        </p:nvSpPr>
+        <p:spPr>
+          <a:xfrm>
+            <a:off x="941832" y="1911095"/>
+            <a:ext cx="2139696" cy="667512"/>
+          </a:xfrm>
+          <a:prstGeom prst="rect">
+            <a:avLst/>
+          </a:prstGeom>
+          <a:noFill/>
+        </p:spPr>
+        <p:txBody>
+          <a:bodyPr wrap="square">
+            <a:normAutofit/>
+          </a:bodyPr>
+          <a:lstStyle/>
+          <a:p>
+            <a:r>
+              <a:rPr sz="2000" b="1">
+                <a:solidFill>
+                  <a:srgbClr val="0B3C5D"/>
+                </a:solidFill>
+                <a:latin typeface="Aptos"/>
+              </a:rPr>
+              <a:t>25</a:t>
+            </a:r>
+          </a:p>
+        </p:txBody>
+      </p:sp>
+      <p:sp>
+        <p:nvSpPr>
+          <p:cNvPr id="12" name="Rounded Rectangle 11"/>
+          <p:cNvSpPr/>
+          <p:nvPr/>
+        </p:nvSpPr>
+        <p:spPr>
+          <a:xfrm>
+            <a:off x="3611880" y="1508760"/>
+            <a:ext cx="2468880" cy="1143000"/>
+          </a:xfrm>
+          <a:prstGeom prst="roundRect">
+            <a:avLst/>
+          </a:prstGeom>
+          <a:solidFill>
+            <a:srgbClr val="FFFFFF"/>
+          </a:solidFill>
+          <a:ln>
+            <a:solidFill>
+              <a:srgbClr val="CCD1D1"/>
+            </a:solidFill>
+          </a:ln>
+        </p:spPr>
+        <p:style>
+          <a:lnRef idx="1">
+            <a:schemeClr val="accent1"/>
+          </a:lnRef>
+          <a:fillRef idx="3">
+            <a:schemeClr val="accent1"/>
+          </a:fillRef>
+          <a:effectRef idx="2">
+            <a:schemeClr val="accent1"/>
+          </a:effectRef>
+          <a:fontRef idx="minor">
+            <a:schemeClr val="lt1"/>
+          </a:fontRef>
+        </p:style>
+        <p:txBody>
+          <a:bodyPr rtlCol="0" anchor="ctr"/>
+          <a:lstStyle/>
+          <a:p>
+            <a:pPr algn="ctr"/>
+          </a:p>
+        </p:txBody>
+      </p:sp>
+      <p:sp>
+        <p:nvSpPr>
+          <p:cNvPr id="13" name="TextBox 12"/>
+          <p:cNvSpPr txBox="1"/>
+          <p:nvPr/>
+        </p:nvSpPr>
+        <p:spPr>
+          <a:xfrm>
+            <a:off x="3776472" y="1618488"/>
+            <a:ext cx="2139696" cy="256032"/>
+          </a:xfrm>
+          <a:prstGeom prst="rect">
+            <a:avLst/>
+          </a:prstGeom>
+          <a:noFill/>
+        </p:spPr>
+        <p:txBody>
+          <a:bodyPr wrap="square">
+            <a:normAutofit/>
+          </a:bodyPr>
+          <a:lstStyle/>
+          <a:p>
+            <a:r>
+              <a:rPr sz="1000" b="1">
+                <a:solidFill>
+                  <a:srgbClr val="566573"/>
+                </a:solidFill>
+                <a:latin typeface="Aptos"/>
+              </a:rPr>
+              <a:t>CER</a:t>
+            </a:r>
+          </a:p>
+        </p:txBody>
+      </p:sp>
+      <p:sp>
+        <p:nvSpPr>
+          <p:cNvPr id="14" name="TextBox 13"/>
+          <p:cNvSpPr txBox="1"/>
+          <p:nvPr/>
+        </p:nvSpPr>
+        <p:spPr>
+          <a:xfrm>
+            <a:off x="3776472" y="1911095"/>
+            <a:ext cx="2139696" cy="667512"/>
+          </a:xfrm>
+          <a:prstGeom prst="rect">
+            <a:avLst/>
+          </a:prstGeom>
+          <a:noFill/>
+        </p:spPr>
+        <p:txBody>
+          <a:bodyPr wrap="square">
+            <a:normAutofit/>
+          </a:bodyPr>
+          <a:lstStyle/>
+          <a:p>
+            <a:r>
+              <a:rPr sz="2000" b="1">
+                <a:solidFill>
+                  <a:srgbClr val="0B3C5D"/>
+                </a:solidFill>
+                <a:latin typeface="Aptos"/>
+              </a:rPr>
+              <a:t>0.110</a:t>
+            </a:r>
+          </a:p>
+        </p:txBody>
+      </p:sp>
+      <p:sp>
+        <p:nvSpPr>
+          <p:cNvPr id="15" name="Rounded Rectangle 14"/>
+          <p:cNvSpPr/>
+          <p:nvPr/>
+        </p:nvSpPr>
+        <p:spPr>
+          <a:xfrm>
+            <a:off x="6446520" y="1508760"/>
+            <a:ext cx="2468880" cy="1143000"/>
+          </a:xfrm>
+          <a:prstGeom prst="roundRect">
+            <a:avLst/>
+          </a:prstGeom>
+          <a:solidFill>
+            <a:srgbClr val="FFFFFF"/>
+          </a:solidFill>
+          <a:ln>
+            <a:solidFill>
+              <a:srgbClr val="CCD1D1"/>
+            </a:solidFill>
+          </a:ln>
+        </p:spPr>
+        <p:style>
+          <a:lnRef idx="1">
+            <a:schemeClr val="accent1"/>
+          </a:lnRef>
+          <a:fillRef idx="3">
+            <a:schemeClr val="accent1"/>
+          </a:fillRef>
+          <a:effectRef idx="2">
+            <a:schemeClr val="accent1"/>
+          </a:effectRef>
+          <a:fontRef idx="minor">
+            <a:schemeClr val="lt1"/>
+          </a:fontRef>
+        </p:style>
+        <p:txBody>
+          <a:bodyPr rtlCol="0" anchor="ctr"/>
+          <a:lstStyle/>
+          <a:p>
+            <a:pPr algn="ctr"/>
+          </a:p>
+        </p:txBody>
+      </p:sp>
+      <p:sp>
+        <p:nvSpPr>
+          <p:cNvPr id="16" name="TextBox 15"/>
+          <p:cNvSpPr txBox="1"/>
+          <p:nvPr/>
+        </p:nvSpPr>
+        <p:spPr>
+          <a:xfrm>
+            <a:off x="6611112" y="1618488"/>
+            <a:ext cx="2139696" cy="256032"/>
+          </a:xfrm>
+          <a:prstGeom prst="rect">
+            <a:avLst/>
+          </a:prstGeom>
+          <a:noFill/>
+        </p:spPr>
+        <p:txBody>
+          <a:bodyPr wrap="square">
+            <a:normAutofit/>
+          </a:bodyPr>
+          <a:lstStyle/>
+          <a:p>
+            <a:r>
+              <a:rPr sz="1000" b="1">
+                <a:solidFill>
+                  <a:srgbClr val="566573"/>
+                </a:solidFill>
+                <a:latin typeface="Aptos"/>
+              </a:rPr>
+              <a:t>Word Accuracy</a:t>
+            </a:r>
+          </a:p>
+        </p:txBody>
+      </p:sp>
+      <p:sp>
+        <p:nvSpPr>
+          <p:cNvPr id="17" name="TextBox 16"/>
+          <p:cNvSpPr txBox="1"/>
+          <p:nvPr/>
+        </p:nvSpPr>
+        <p:spPr>
+          <a:xfrm>
+            <a:off x="6611112" y="1911095"/>
+            <a:ext cx="2139696" cy="667512"/>
+          </a:xfrm>
+          <a:prstGeom prst="rect">
+            <a:avLst/>
+          </a:prstGeom>
+          <a:noFill/>
+        </p:spPr>
+        <p:txBody>
+          <a:bodyPr wrap="square">
+            <a:normAutofit/>
+          </a:bodyPr>
+          <a:lstStyle/>
+          <a:p>
+            <a:r>
+              <a:rPr sz="2000" b="1">
+                <a:solidFill>
+                  <a:srgbClr val="0B3C5D"/>
+                </a:solidFill>
+                <a:latin typeface="Aptos"/>
+              </a:rPr>
+              <a:t>0.691</a:t>
+            </a:r>
+          </a:p>
+        </p:txBody>
+      </p:sp>
+      <p:sp>
+        <p:nvSpPr>
+          <p:cNvPr id="18" name="Rounded Rectangle 17"/>
+          <p:cNvSpPr/>
+          <p:nvPr/>
+        </p:nvSpPr>
+        <p:spPr>
+          <a:xfrm>
+            <a:off x="9281160" y="1508760"/>
+            <a:ext cx="2468880" cy="1143000"/>
+          </a:xfrm>
+          <a:prstGeom prst="roundRect">
+            <a:avLst/>
+          </a:prstGeom>
+          <a:solidFill>
+            <a:srgbClr val="FFFFFF"/>
+          </a:solidFill>
+          <a:ln>
+            <a:solidFill>
+              <a:srgbClr val="CCD1D1"/>
+            </a:solidFill>
+          </a:ln>
+        </p:spPr>
+        <p:style>
+          <a:lnRef idx="1">
+            <a:schemeClr val="accent1"/>
+          </a:lnRef>
+          <a:fillRef idx="3">
+            <a:schemeClr val="accent1"/>
+          </a:fillRef>
+          <a:effectRef idx="2">
+            <a:schemeClr val="accent1"/>
+          </a:effectRef>
+          <a:fontRef idx="minor">
+            <a:schemeClr val="lt1"/>
+          </a:fontRef>
+        </p:style>
+        <p:txBody>
+          <a:bodyPr rtlCol="0" anchor="ctr"/>
+          <a:lstStyle/>
+          <a:p>
+            <a:pPr algn="ctr"/>
+          </a:p>
+        </p:txBody>
+      </p:sp>
+      <p:sp>
+        <p:nvSpPr>
+          <p:cNvPr id="19" name="TextBox 18"/>
+          <p:cNvSpPr txBox="1"/>
+          <p:nvPr/>
+        </p:nvSpPr>
+        <p:spPr>
+          <a:xfrm>
+            <a:off x="9445752" y="1618488"/>
+            <a:ext cx="2139696" cy="256032"/>
+          </a:xfrm>
+          <a:prstGeom prst="rect">
+            <a:avLst/>
+          </a:prstGeom>
+          <a:noFill/>
+        </p:spPr>
+        <p:txBody>
+          <a:bodyPr wrap="square">
+            <a:normAutofit/>
+          </a:bodyPr>
+          <a:lstStyle/>
+          <a:p>
+            <a:r>
+              <a:rPr sz="1000" b="1">
+                <a:solidFill>
+                  <a:srgbClr val="566573"/>
+                </a:solidFill>
+                <a:latin typeface="Aptos"/>
+              </a:rPr>
+              <a:t>Exact Match</a:t>
+            </a:r>
+          </a:p>
+        </p:txBody>
+      </p:sp>
+      <p:sp>
+        <p:nvSpPr>
+          <p:cNvPr id="20" name="TextBox 19"/>
+          <p:cNvSpPr txBox="1"/>
+          <p:nvPr/>
+        </p:nvSpPr>
+        <p:spPr>
+          <a:xfrm>
+            <a:off x="9445752" y="1911095"/>
+            <a:ext cx="2139696" cy="667512"/>
+          </a:xfrm>
+          <a:prstGeom prst="rect">
+            <a:avLst/>
+          </a:prstGeom>
+          <a:noFill/>
+        </p:spPr>
+        <p:txBody>
+          <a:bodyPr wrap="square">
+            <a:normAutofit/>
+          </a:bodyPr>
+          <a:lstStyle/>
+          <a:p>
+            <a:r>
+              <a:rPr sz="2000" b="1">
+                <a:solidFill>
+                  <a:srgbClr val="0B3C5D"/>
+                </a:solidFill>
+                <a:latin typeface="Aptos"/>
+              </a:rPr>
+              <a:t>0.440</a:t>
+            </a:r>
+          </a:p>
+        </p:txBody>
+      </p:sp>
+      <p:sp>
+        <p:nvSpPr>
+          <p:cNvPr id="21" name="TextBox 20"/>
+          <p:cNvSpPr txBox="1"/>
+          <p:nvPr/>
+        </p:nvSpPr>
+        <p:spPr>
+          <a:xfrm>
+            <a:off x="914400" y="3291840"/>
+            <a:ext cx="10241280" cy="1828800"/>
           </a:xfrm>
           <a:prstGeom prst="rect">
             <a:avLst/>
@@ -7387,7 +8111,7 @@
               </a:defRPr>
             </a:pPr>
             <a:r>
-              <a:t>Feature-importance artifacts are generated for every benchmark run.</a:t>
+              <a:t>Evaluation uses held-out real scanned-document crops prepared from public datasets.</a:t>
             </a:r>
           </a:p>
           <a:p>
@@ -7400,7 +8124,7 @@
               </a:defRPr>
             </a:pPr>
             <a:r>
-              <a:t>Metrics are exported as JSON and summarized in CSV.</a:t>
+              <a:t>The same test labels can be reused after fine-tuning for baseline-vs-fine-tuned comparison.</a:t>
             </a:r>
           </a:p>
           <a:p>
@@ -7413,7 +8137,7 @@
               </a:defRPr>
             </a:pPr>
             <a:r>
-              <a:t>Final report values can be traced to saved repository artifacts.</a:t>
+              <a:t>Borrower-document deployment should add privacy-reviewed labeled financial forms.</a:t>
             </a:r>
           </a:p>
         </p:txBody>
@@ -7541,7 +8265,7 @@
                 </a:solidFill>
                 <a:latin typeface="Aptos"/>
               </a:rPr>
-              <a:t>GitHub Submission Structure</a:t>
+              <a:t>Explainability And Traceability</a:t>
             </a:r>
           </a:p>
         </p:txBody>
@@ -7591,16 +8315,40 @@
           </a:p>
         </p:txBody>
       </p:sp>
-      <p:sp>
-        <p:nvSpPr>
-          <p:cNvPr id="8" name="TextBox 7"/>
+      <p:pic>
+        <p:nvPicPr>
+          <p:cNvPr id="8" name="Picture 7" descr="german-credit_feature_importance.png"/>
+          <p:cNvPicPr>
+            <a:picLocks noChangeAspect="1"/>
+          </p:cNvPicPr>
+          <p:nvPr/>
+        </p:nvPicPr>
+        <p:blipFill>
+          <a:blip r:embed="rId2"/>
+          <a:stretch>
+            <a:fillRect/>
+          </a:stretch>
+        </p:blipFill>
+        <p:spPr>
+          <a:xfrm>
+            <a:off x="731520" y="1325880"/>
+            <a:ext cx="5212080" cy="3257550"/>
+          </a:xfrm>
+          <a:prstGeom prst="rect">
+            <a:avLst/>
+          </a:prstGeom>
+        </p:spPr>
+      </p:pic>
+      <p:sp>
+        <p:nvSpPr>
+          <p:cNvPr id="9" name="TextBox 8"/>
           <p:cNvSpPr txBox="1"/>
           <p:nvPr/>
         </p:nvSpPr>
         <p:spPr>
           <a:xfrm>
-            <a:off x="822960" y="1417320"/>
-            <a:ext cx="10241280" cy="4480560"/>
+            <a:off x="6446520" y="1645920"/>
+            <a:ext cx="4754880" cy="3108960"/>
           </a:xfrm>
           <a:prstGeom prst="rect">
             <a:avLst/>
@@ -7614,7 +8362,7 @@
           <a:lstStyle/>
           <a:p>
             <a:pPr>
-              <a:defRPr sz="1800">
+              <a:defRPr sz="1700">
                 <a:solidFill>
                   <a:srgbClr val="1B2631"/>
                 </a:solidFill>
@@ -7622,12 +8370,12 @@
               </a:defRPr>
             </a:pPr>
             <a:r>
-              <a:t>IPR Submission Proof: placeholder for copyright form and screenshot.</a:t>
+              <a:t>Feature-importance artifacts are generated for every benchmark run.</a:t>
             </a:r>
           </a:p>
           <a:p>
             <a:pPr>
-              <a:defRPr sz="1800">
+              <a:defRPr sz="1700">
                 <a:solidFill>
                   <a:srgbClr val="1B2631"/>
                 </a:solidFill>
@@ -7635,12 +8383,12 @@
               </a:defRPr>
             </a:pPr>
             <a:r>
-              <a:t>Report and PPT: final DOCX, PPTX, templates, markdown, and figures.</a:t>
+              <a:t>Metrics are exported as JSON and summarized in CSV.</a:t>
             </a:r>
           </a:p>
           <a:p>
             <a:pPr>
-              <a:defRPr sz="1800">
+              <a:defRPr sz="1700">
                 <a:solidFill>
                   <a:srgbClr val="1B2631"/>
                 </a:solidFill>
@@ -7648,20 +8396,7 @@
               </a:defRPr>
             </a:pPr>
             <a:r>
-              <a:t>Source code: runnable code, configs, tests, data samples, and artifacts.</a:t>
-            </a:r>
-          </a:p>
-          <a:p>
-            <a:pPr>
-              <a:defRPr sz="1800">
-                <a:solidFill>
-                  <a:srgbClr val="1B2631"/>
-                </a:solidFill>
-                <a:latin typeface="Aptos"/>
-              </a:defRPr>
-            </a:pPr>
-            <a:r>
-              <a:t>README.md: team details, project type, status, and run instructions.</a:t>
+              <a:t>Final report values can be traced to saved repository artifacts.</a:t>
             </a:r>
           </a:p>
         </p:txBody>

</xml_diff>

<commit_message>
Improve final report and presentation figures
</commit_message>
<xml_diff>
--- a/Report and PPT/Final_COOP2_External_Presentation.pptx
+++ b/Report and PPT/Final_COOP2_External_Presentation.pptx
@@ -24,6 +24,8 @@
     <p:sldId id="266" r:id="rId21"/>
     <p:sldId id="267" r:id="rId22"/>
     <p:sldId id="268" r:id="rId23"/>
+    <p:sldId id="269" r:id="rId24"/>
+    <p:sldId id="270" r:id="rId25"/>
   </p:sldIdLst>
   <p:sldSz cx="12191695" cy="6858000" type="screen4x3"/>
   <p:notesSz cx="7559675" cy="10691813"/>
@@ -3981,14 +3983,48 @@
                 </a:solidFill>
                 <a:latin typeface="Aptos"/>
               </a:rPr>
-              <a:t>GitHub Submission Structure</a:t>
-            </a:r>
-          </a:p>
-        </p:txBody>
-      </p:sp>
-      <p:sp>
-        <p:nvSpPr>
-          <p:cNvPr id="7" name="Rectangle 6"/>
+              <a:t>Measured OCR Baseline</a:t>
+            </a:r>
+          </a:p>
+        </p:txBody>
+      </p:sp>
+      <p:sp>
+        <p:nvSpPr>
+          <p:cNvPr id="7" name="TextBox 6"/>
+          <p:cNvSpPr txBox="1"/>
+          <p:nvPr/>
+        </p:nvSpPr>
+        <p:spPr>
+          <a:xfrm>
+            <a:off x="530352" y="786384"/>
+            <a:ext cx="10607040" cy="292608"/>
+          </a:xfrm>
+          <a:prstGeom prst="rect">
+            <a:avLst/>
+          </a:prstGeom>
+          <a:noFill/>
+        </p:spPr>
+        <p:txBody>
+          <a:bodyPr wrap="square">
+            <a:normAutofit/>
+          </a:bodyPr>
+          <a:lstStyle/>
+          <a:p>
+            <a:r>
+              <a:rPr sz="1100" b="0">
+                <a:solidFill>
+                  <a:srgbClr val="566573"/>
+                </a:solidFill>
+                <a:latin typeface="Aptos"/>
+              </a:rPr>
+              <a:t>Traceable to artifacts/ocr/real_ocr_finetune/baseline.</a:t>
+            </a:r>
+          </a:p>
+        </p:txBody>
+      </p:sp>
+      <p:sp>
+        <p:nvSpPr>
+          <p:cNvPr id="8" name="Rectangle 7"/>
           <p:cNvSpPr/>
           <p:nvPr/>
         </p:nvSpPr>
@@ -4033,14 +4069,59 @@
       </p:sp>
       <p:sp>
         <p:nvSpPr>
-          <p:cNvPr id="8" name="TextBox 7"/>
+          <p:cNvPr id="9" name="Rounded Rectangle 8"/>
+          <p:cNvSpPr/>
+          <p:nvPr/>
+        </p:nvSpPr>
+        <p:spPr>
+          <a:xfrm>
+            <a:off x="777240" y="1508760"/>
+            <a:ext cx="2468880" cy="1143000"/>
+          </a:xfrm>
+          <a:prstGeom prst="roundRect">
+            <a:avLst/>
+          </a:prstGeom>
+          <a:solidFill>
+            <a:srgbClr val="FFFFFF"/>
+          </a:solidFill>
+          <a:ln>
+            <a:solidFill>
+              <a:srgbClr val="CCD1D1"/>
+            </a:solidFill>
+          </a:ln>
+        </p:spPr>
+        <p:style>
+          <a:lnRef idx="1">
+            <a:schemeClr val="accent1"/>
+          </a:lnRef>
+          <a:fillRef idx="3">
+            <a:schemeClr val="accent1"/>
+          </a:fillRef>
+          <a:effectRef idx="2">
+            <a:schemeClr val="accent1"/>
+          </a:effectRef>
+          <a:fontRef idx="minor">
+            <a:schemeClr val="lt1"/>
+          </a:fontRef>
+        </p:style>
+        <p:txBody>
+          <a:bodyPr rtlCol="0" anchor="ctr"/>
+          <a:lstStyle/>
+          <a:p>
+            <a:pPr algn="ctr"/>
+          </a:p>
+        </p:txBody>
+      </p:sp>
+      <p:sp>
+        <p:nvSpPr>
+          <p:cNvPr id="10" name="TextBox 9"/>
           <p:cNvSpPr txBox="1"/>
           <p:nvPr/>
         </p:nvSpPr>
         <p:spPr>
           <a:xfrm>
-            <a:off x="822960" y="1417320"/>
-            <a:ext cx="10241280" cy="4480560"/>
+            <a:off x="941832" y="1618488"/>
+            <a:ext cx="2139696" cy="256032"/>
           </a:xfrm>
           <a:prstGeom prst="rect">
             <a:avLst/>
@@ -4053,8 +4134,415 @@
           </a:bodyPr>
           <a:lstStyle/>
           <a:p>
+            <a:r>
+              <a:rPr sz="1000" b="1">
+                <a:solidFill>
+                  <a:srgbClr val="566573"/>
+                </a:solidFill>
+                <a:latin typeface="Aptos"/>
+              </a:rPr>
+              <a:t>Samples</a:t>
+            </a:r>
+          </a:p>
+        </p:txBody>
+      </p:sp>
+      <p:sp>
+        <p:nvSpPr>
+          <p:cNvPr id="11" name="TextBox 10"/>
+          <p:cNvSpPr txBox="1"/>
+          <p:nvPr/>
+        </p:nvSpPr>
+        <p:spPr>
+          <a:xfrm>
+            <a:off x="941832" y="1911095"/>
+            <a:ext cx="2139696" cy="667512"/>
+          </a:xfrm>
+          <a:prstGeom prst="rect">
+            <a:avLst/>
+          </a:prstGeom>
+          <a:noFill/>
+        </p:spPr>
+        <p:txBody>
+          <a:bodyPr wrap="square">
+            <a:normAutofit/>
+          </a:bodyPr>
+          <a:lstStyle/>
+          <a:p>
+            <a:r>
+              <a:rPr sz="2000" b="1">
+                <a:solidFill>
+                  <a:srgbClr val="0B3C5D"/>
+                </a:solidFill>
+                <a:latin typeface="Aptos"/>
+              </a:rPr>
+              <a:t>25</a:t>
+            </a:r>
+          </a:p>
+        </p:txBody>
+      </p:sp>
+      <p:sp>
+        <p:nvSpPr>
+          <p:cNvPr id="12" name="Rounded Rectangle 11"/>
+          <p:cNvSpPr/>
+          <p:nvPr/>
+        </p:nvSpPr>
+        <p:spPr>
+          <a:xfrm>
+            <a:off x="3611880" y="1508760"/>
+            <a:ext cx="2468880" cy="1143000"/>
+          </a:xfrm>
+          <a:prstGeom prst="roundRect">
+            <a:avLst/>
+          </a:prstGeom>
+          <a:solidFill>
+            <a:srgbClr val="FFFFFF"/>
+          </a:solidFill>
+          <a:ln>
+            <a:solidFill>
+              <a:srgbClr val="CCD1D1"/>
+            </a:solidFill>
+          </a:ln>
+        </p:spPr>
+        <p:style>
+          <a:lnRef idx="1">
+            <a:schemeClr val="accent1"/>
+          </a:lnRef>
+          <a:fillRef idx="3">
+            <a:schemeClr val="accent1"/>
+          </a:fillRef>
+          <a:effectRef idx="2">
+            <a:schemeClr val="accent1"/>
+          </a:effectRef>
+          <a:fontRef idx="minor">
+            <a:schemeClr val="lt1"/>
+          </a:fontRef>
+        </p:style>
+        <p:txBody>
+          <a:bodyPr rtlCol="0" anchor="ctr"/>
+          <a:lstStyle/>
+          <a:p>
+            <a:pPr algn="ctr"/>
+          </a:p>
+        </p:txBody>
+      </p:sp>
+      <p:sp>
+        <p:nvSpPr>
+          <p:cNvPr id="13" name="TextBox 12"/>
+          <p:cNvSpPr txBox="1"/>
+          <p:nvPr/>
+        </p:nvSpPr>
+        <p:spPr>
+          <a:xfrm>
+            <a:off x="3776472" y="1618488"/>
+            <a:ext cx="2139696" cy="256032"/>
+          </a:xfrm>
+          <a:prstGeom prst="rect">
+            <a:avLst/>
+          </a:prstGeom>
+          <a:noFill/>
+        </p:spPr>
+        <p:txBody>
+          <a:bodyPr wrap="square">
+            <a:normAutofit/>
+          </a:bodyPr>
+          <a:lstStyle/>
+          <a:p>
+            <a:r>
+              <a:rPr sz="1000" b="1">
+                <a:solidFill>
+                  <a:srgbClr val="566573"/>
+                </a:solidFill>
+                <a:latin typeface="Aptos"/>
+              </a:rPr>
+              <a:t>CER</a:t>
+            </a:r>
+          </a:p>
+        </p:txBody>
+      </p:sp>
+      <p:sp>
+        <p:nvSpPr>
+          <p:cNvPr id="14" name="TextBox 13"/>
+          <p:cNvSpPr txBox="1"/>
+          <p:nvPr/>
+        </p:nvSpPr>
+        <p:spPr>
+          <a:xfrm>
+            <a:off x="3776472" y="1911095"/>
+            <a:ext cx="2139696" cy="667512"/>
+          </a:xfrm>
+          <a:prstGeom prst="rect">
+            <a:avLst/>
+          </a:prstGeom>
+          <a:noFill/>
+        </p:spPr>
+        <p:txBody>
+          <a:bodyPr wrap="square">
+            <a:normAutofit/>
+          </a:bodyPr>
+          <a:lstStyle/>
+          <a:p>
+            <a:r>
+              <a:rPr sz="2000" b="1">
+                <a:solidFill>
+                  <a:srgbClr val="0B3C5D"/>
+                </a:solidFill>
+                <a:latin typeface="Aptos"/>
+              </a:rPr>
+              <a:t>0.110</a:t>
+            </a:r>
+          </a:p>
+        </p:txBody>
+      </p:sp>
+      <p:sp>
+        <p:nvSpPr>
+          <p:cNvPr id="15" name="Rounded Rectangle 14"/>
+          <p:cNvSpPr/>
+          <p:nvPr/>
+        </p:nvSpPr>
+        <p:spPr>
+          <a:xfrm>
+            <a:off x="6446520" y="1508760"/>
+            <a:ext cx="2468880" cy="1143000"/>
+          </a:xfrm>
+          <a:prstGeom prst="roundRect">
+            <a:avLst/>
+          </a:prstGeom>
+          <a:solidFill>
+            <a:srgbClr val="FFFFFF"/>
+          </a:solidFill>
+          <a:ln>
+            <a:solidFill>
+              <a:srgbClr val="CCD1D1"/>
+            </a:solidFill>
+          </a:ln>
+        </p:spPr>
+        <p:style>
+          <a:lnRef idx="1">
+            <a:schemeClr val="accent1"/>
+          </a:lnRef>
+          <a:fillRef idx="3">
+            <a:schemeClr val="accent1"/>
+          </a:fillRef>
+          <a:effectRef idx="2">
+            <a:schemeClr val="accent1"/>
+          </a:effectRef>
+          <a:fontRef idx="minor">
+            <a:schemeClr val="lt1"/>
+          </a:fontRef>
+        </p:style>
+        <p:txBody>
+          <a:bodyPr rtlCol="0" anchor="ctr"/>
+          <a:lstStyle/>
+          <a:p>
+            <a:pPr algn="ctr"/>
+          </a:p>
+        </p:txBody>
+      </p:sp>
+      <p:sp>
+        <p:nvSpPr>
+          <p:cNvPr id="16" name="TextBox 15"/>
+          <p:cNvSpPr txBox="1"/>
+          <p:nvPr/>
+        </p:nvSpPr>
+        <p:spPr>
+          <a:xfrm>
+            <a:off x="6611112" y="1618488"/>
+            <a:ext cx="2139696" cy="256032"/>
+          </a:xfrm>
+          <a:prstGeom prst="rect">
+            <a:avLst/>
+          </a:prstGeom>
+          <a:noFill/>
+        </p:spPr>
+        <p:txBody>
+          <a:bodyPr wrap="square">
+            <a:normAutofit/>
+          </a:bodyPr>
+          <a:lstStyle/>
+          <a:p>
+            <a:r>
+              <a:rPr sz="1000" b="1">
+                <a:solidFill>
+                  <a:srgbClr val="566573"/>
+                </a:solidFill>
+                <a:latin typeface="Aptos"/>
+              </a:rPr>
+              <a:t>Word Accuracy</a:t>
+            </a:r>
+          </a:p>
+        </p:txBody>
+      </p:sp>
+      <p:sp>
+        <p:nvSpPr>
+          <p:cNvPr id="17" name="TextBox 16"/>
+          <p:cNvSpPr txBox="1"/>
+          <p:nvPr/>
+        </p:nvSpPr>
+        <p:spPr>
+          <a:xfrm>
+            <a:off x="6611112" y="1911095"/>
+            <a:ext cx="2139696" cy="667512"/>
+          </a:xfrm>
+          <a:prstGeom prst="rect">
+            <a:avLst/>
+          </a:prstGeom>
+          <a:noFill/>
+        </p:spPr>
+        <p:txBody>
+          <a:bodyPr wrap="square">
+            <a:normAutofit/>
+          </a:bodyPr>
+          <a:lstStyle/>
+          <a:p>
+            <a:r>
+              <a:rPr sz="2000" b="1">
+                <a:solidFill>
+                  <a:srgbClr val="0B3C5D"/>
+                </a:solidFill>
+                <a:latin typeface="Aptos"/>
+              </a:rPr>
+              <a:t>0.691</a:t>
+            </a:r>
+          </a:p>
+        </p:txBody>
+      </p:sp>
+      <p:sp>
+        <p:nvSpPr>
+          <p:cNvPr id="18" name="Rounded Rectangle 17"/>
+          <p:cNvSpPr/>
+          <p:nvPr/>
+        </p:nvSpPr>
+        <p:spPr>
+          <a:xfrm>
+            <a:off x="9281160" y="1508760"/>
+            <a:ext cx="2468880" cy="1143000"/>
+          </a:xfrm>
+          <a:prstGeom prst="roundRect">
+            <a:avLst/>
+          </a:prstGeom>
+          <a:solidFill>
+            <a:srgbClr val="FFFFFF"/>
+          </a:solidFill>
+          <a:ln>
+            <a:solidFill>
+              <a:srgbClr val="CCD1D1"/>
+            </a:solidFill>
+          </a:ln>
+        </p:spPr>
+        <p:style>
+          <a:lnRef idx="1">
+            <a:schemeClr val="accent1"/>
+          </a:lnRef>
+          <a:fillRef idx="3">
+            <a:schemeClr val="accent1"/>
+          </a:fillRef>
+          <a:effectRef idx="2">
+            <a:schemeClr val="accent1"/>
+          </a:effectRef>
+          <a:fontRef idx="minor">
+            <a:schemeClr val="lt1"/>
+          </a:fontRef>
+        </p:style>
+        <p:txBody>
+          <a:bodyPr rtlCol="0" anchor="ctr"/>
+          <a:lstStyle/>
+          <a:p>
+            <a:pPr algn="ctr"/>
+          </a:p>
+        </p:txBody>
+      </p:sp>
+      <p:sp>
+        <p:nvSpPr>
+          <p:cNvPr id="19" name="TextBox 18"/>
+          <p:cNvSpPr txBox="1"/>
+          <p:nvPr/>
+        </p:nvSpPr>
+        <p:spPr>
+          <a:xfrm>
+            <a:off x="9445752" y="1618488"/>
+            <a:ext cx="2139696" cy="256032"/>
+          </a:xfrm>
+          <a:prstGeom prst="rect">
+            <a:avLst/>
+          </a:prstGeom>
+          <a:noFill/>
+        </p:spPr>
+        <p:txBody>
+          <a:bodyPr wrap="square">
+            <a:normAutofit/>
+          </a:bodyPr>
+          <a:lstStyle/>
+          <a:p>
+            <a:r>
+              <a:rPr sz="1000" b="1">
+                <a:solidFill>
+                  <a:srgbClr val="566573"/>
+                </a:solidFill>
+                <a:latin typeface="Aptos"/>
+              </a:rPr>
+              <a:t>Exact Match</a:t>
+            </a:r>
+          </a:p>
+        </p:txBody>
+      </p:sp>
+      <p:sp>
+        <p:nvSpPr>
+          <p:cNvPr id="20" name="TextBox 19"/>
+          <p:cNvSpPr txBox="1"/>
+          <p:nvPr/>
+        </p:nvSpPr>
+        <p:spPr>
+          <a:xfrm>
+            <a:off x="9445752" y="1911095"/>
+            <a:ext cx="2139696" cy="667512"/>
+          </a:xfrm>
+          <a:prstGeom prst="rect">
+            <a:avLst/>
+          </a:prstGeom>
+          <a:noFill/>
+        </p:spPr>
+        <p:txBody>
+          <a:bodyPr wrap="square">
+            <a:normAutofit/>
+          </a:bodyPr>
+          <a:lstStyle/>
+          <a:p>
+            <a:r>
+              <a:rPr sz="2000" b="1">
+                <a:solidFill>
+                  <a:srgbClr val="0B3C5D"/>
+                </a:solidFill>
+                <a:latin typeface="Aptos"/>
+              </a:rPr>
+              <a:t>0.440</a:t>
+            </a:r>
+          </a:p>
+        </p:txBody>
+      </p:sp>
+      <p:sp>
+        <p:nvSpPr>
+          <p:cNvPr id="21" name="TextBox 20"/>
+          <p:cNvSpPr txBox="1"/>
+          <p:nvPr/>
+        </p:nvSpPr>
+        <p:spPr>
+          <a:xfrm>
+            <a:off x="914400" y="3291840"/>
+            <a:ext cx="10241280" cy="1828800"/>
+          </a:xfrm>
+          <a:prstGeom prst="rect">
+            <a:avLst/>
+          </a:prstGeom>
+          <a:noFill/>
+        </p:spPr>
+        <p:txBody>
+          <a:bodyPr wrap="square">
+            <a:normAutofit/>
+          </a:bodyPr>
+          <a:lstStyle/>
+          <a:p>
             <a:pPr>
-              <a:defRPr sz="1800">
+              <a:defRPr sz="1700">
                 <a:solidFill>
                   <a:srgbClr val="1B2631"/>
                 </a:solidFill>
@@ -4062,12 +4550,12 @@
               </a:defRPr>
             </a:pPr>
             <a:r>
-              <a:t>IPR Submission Proof: placeholder for copyright form and screenshot.</a:t>
+              <a:t>Evaluation uses held-out real scanned-document crops prepared from public datasets.</a:t>
             </a:r>
           </a:p>
           <a:p>
             <a:pPr>
-              <a:defRPr sz="1800">
+              <a:defRPr sz="1700">
                 <a:solidFill>
                   <a:srgbClr val="1B2631"/>
                 </a:solidFill>
@@ -4075,12 +4563,12 @@
               </a:defRPr>
             </a:pPr>
             <a:r>
-              <a:t>Report and PPT: final DOCX, PPTX, templates, markdown, and figures.</a:t>
+              <a:t>The same test labels can be reused after fine-tuning for baseline-vs-fine-tuned comparison.</a:t>
             </a:r>
           </a:p>
           <a:p>
             <a:pPr>
-              <a:defRPr sz="1800">
+              <a:defRPr sz="1700">
                 <a:solidFill>
                   <a:srgbClr val="1B2631"/>
                 </a:solidFill>
@@ -4088,20 +4576,7 @@
               </a:defRPr>
             </a:pPr>
             <a:r>
-              <a:t>Source code: runnable code, configs, tests, data samples, and artifacts.</a:t>
-            </a:r>
-          </a:p>
-          <a:p>
-            <a:pPr>
-              <a:defRPr sz="1800">
-                <a:solidFill>
-                  <a:srgbClr val="1B2631"/>
-                </a:solidFill>
-                <a:latin typeface="Aptos"/>
-              </a:defRPr>
-            </a:pPr>
-            <a:r>
-              <a:t>README.md: team details, project type, status, and run instructions.</a:t>
+              <a:t>Borrower-document deployment should add privacy-reviewed labeled financial forms.</a:t>
             </a:r>
           </a:p>
         </p:txBody>
@@ -4229,7 +4704,7 @@
                 </a:solidFill>
                 <a:latin typeface="Aptos"/>
               </a:rPr>
-              <a:t>Evaluation Readiness</a:t>
+              <a:t>Explainability And Traceability</a:t>
             </a:r>
           </a:p>
         </p:txBody>
@@ -4263,7 +4738,7 @@
                 </a:solidFill>
                 <a:latin typeface="Aptos"/>
               </a:rPr>
-              <a:t>Mapped directly to the final marking areas.</a:t>
+              <a:t>Feature importance is exported for both benchmark datasets.</a:t>
             </a:r>
           </a:p>
         </p:txBody>
@@ -4313,61 +4788,64 @@
           </a:p>
         </p:txBody>
       </p:sp>
-      <p:sp>
-        <p:nvSpPr>
-          <p:cNvPr id="9" name="Rounded Rectangle 8"/>
-          <p:cNvSpPr/>
-          <p:nvPr/>
-        </p:nvSpPr>
-        <p:spPr>
-          <a:xfrm>
-            <a:off x="685800" y="1371600"/>
-            <a:ext cx="5120640" cy="960120"/>
-          </a:xfrm>
-          <a:prstGeom prst="roundRect">
-            <a:avLst/>
-          </a:prstGeom>
-          <a:solidFill>
-            <a:srgbClr val="FEF9E7"/>
-          </a:solidFill>
-          <a:ln>
-            <a:solidFill>
-              <a:srgbClr val="CCD1D1"/>
-            </a:solidFill>
-          </a:ln>
-        </p:spPr>
-        <p:style>
-          <a:lnRef idx="1">
-            <a:schemeClr val="accent1"/>
-          </a:lnRef>
-          <a:fillRef idx="3">
-            <a:schemeClr val="accent1"/>
-          </a:fillRef>
-          <a:effectRef idx="2">
-            <a:schemeClr val="accent1"/>
-          </a:effectRef>
-          <a:fontRef idx="minor">
-            <a:schemeClr val="lt1"/>
-          </a:fontRef>
-        </p:style>
-        <p:txBody>
-          <a:bodyPr rtlCol="0" anchor="ctr"/>
-          <a:lstStyle/>
-          <a:p>
-            <a:pPr algn="ctr"/>
-          </a:p>
-        </p:txBody>
-      </p:sp>
-      <p:sp>
-        <p:nvSpPr>
-          <p:cNvPr id="10" name="TextBox 9"/>
+      <p:pic>
+        <p:nvPicPr>
+          <p:cNvPr id="9" name="Picture 8" descr="german-credit_feature_importance.png"/>
+          <p:cNvPicPr>
+            <a:picLocks noChangeAspect="1"/>
+          </p:cNvPicPr>
+          <p:nvPr/>
+        </p:nvPicPr>
+        <p:blipFill>
+          <a:blip r:embed="rId2"/>
+          <a:stretch>
+            <a:fillRect/>
+          </a:stretch>
+        </p:blipFill>
+        <p:spPr>
+          <a:xfrm>
+            <a:off x="594360" y="1234440"/>
+            <a:ext cx="5394960" cy="3371850"/>
+          </a:xfrm>
+          <a:prstGeom prst="rect">
+            <a:avLst/>
+          </a:prstGeom>
+        </p:spPr>
+      </p:pic>
+      <p:pic>
+        <p:nvPicPr>
+          <p:cNvPr id="10" name="Picture 9" descr="lending-club-sample_feature_importance.png"/>
+          <p:cNvPicPr>
+            <a:picLocks noChangeAspect="1"/>
+          </p:cNvPicPr>
+          <p:nvPr/>
+        </p:nvPicPr>
+        <p:blipFill>
+          <a:blip r:embed="rId3"/>
+          <a:stretch>
+            <a:fillRect/>
+          </a:stretch>
+        </p:blipFill>
+        <p:spPr>
+          <a:xfrm>
+            <a:off x="6263640" y="1234440"/>
+            <a:ext cx="5394960" cy="3371850"/>
+          </a:xfrm>
+          <a:prstGeom prst="rect">
+            <a:avLst/>
+          </a:prstGeom>
+        </p:spPr>
+      </p:pic>
+      <p:sp>
+        <p:nvSpPr>
+          <p:cNvPr id="11" name="TextBox 10"/>
           <p:cNvSpPr txBox="1"/>
           <p:nvPr/>
         </p:nvSpPr>
         <p:spPr>
           <a:xfrm>
-            <a:off x="850392" y="1481328"/>
-            <a:ext cx="4791455" cy="256032"/>
+            <a:off x="914400" y="5650992"/>
+            <a:ext cx="10241280" cy="777240"/>
           </a:xfrm>
           <a:prstGeom prst="rect">
             <a:avLst/>
@@ -4380,415 +4858,8 @@
           </a:bodyPr>
           <a:lstStyle/>
           <a:p>
-            <a:r>
-              <a:rPr sz="1000" b="1">
-                <a:solidFill>
-                  <a:srgbClr val="566573"/>
-                </a:solidFill>
-                <a:latin typeface="Aptos"/>
-              </a:rPr>
-              <a:t>Filing Status</a:t>
-            </a:r>
-          </a:p>
-        </p:txBody>
-      </p:sp>
-      <p:sp>
-        <p:nvSpPr>
-          <p:cNvPr id="11" name="TextBox 10"/>
-          <p:cNvSpPr txBox="1"/>
-          <p:nvPr/>
-        </p:nvSpPr>
-        <p:spPr>
-          <a:xfrm>
-            <a:off x="850392" y="1773936"/>
-            <a:ext cx="4791455" cy="484632"/>
-          </a:xfrm>
-          <a:prstGeom prst="rect">
-            <a:avLst/>
-          </a:prstGeom>
-          <a:noFill/>
-        </p:spPr>
-        <p:txBody>
-          <a:bodyPr wrap="square">
-            <a:normAutofit/>
-          </a:bodyPr>
-          <a:lstStyle/>
-          <a:p>
-            <a:r>
-              <a:rPr sz="2000" b="1">
-                <a:solidFill>
-                  <a:srgbClr val="0B3C5D"/>
-                </a:solidFill>
-                <a:latin typeface="Aptos"/>
-              </a:rPr>
-              <a:t>IPR proof folder and copyright placeholder</a:t>
-            </a:r>
-          </a:p>
-        </p:txBody>
-      </p:sp>
-      <p:sp>
-        <p:nvSpPr>
-          <p:cNvPr id="12" name="Rounded Rectangle 11"/>
-          <p:cNvSpPr/>
-          <p:nvPr/>
-        </p:nvSpPr>
-        <p:spPr>
-          <a:xfrm>
-            <a:off x="6400800" y="1371600"/>
-            <a:ext cx="5120640" cy="960120"/>
-          </a:xfrm>
-          <a:prstGeom prst="roundRect">
-            <a:avLst/>
-          </a:prstGeom>
-          <a:solidFill>
-            <a:srgbClr val="EAF2F8"/>
-          </a:solidFill>
-          <a:ln>
-            <a:solidFill>
-              <a:srgbClr val="CCD1D1"/>
-            </a:solidFill>
-          </a:ln>
-        </p:spPr>
-        <p:style>
-          <a:lnRef idx="1">
-            <a:schemeClr val="accent1"/>
-          </a:lnRef>
-          <a:fillRef idx="3">
-            <a:schemeClr val="accent1"/>
-          </a:fillRef>
-          <a:effectRef idx="2">
-            <a:schemeClr val="accent1"/>
-          </a:effectRef>
-          <a:fontRef idx="minor">
-            <a:schemeClr val="lt1"/>
-          </a:fontRef>
-        </p:style>
-        <p:txBody>
-          <a:bodyPr rtlCol="0" anchor="ctr"/>
-          <a:lstStyle/>
-          <a:p>
-            <a:pPr algn="ctr"/>
-          </a:p>
-        </p:txBody>
-      </p:sp>
-      <p:sp>
-        <p:nvSpPr>
-          <p:cNvPr id="13" name="TextBox 12"/>
-          <p:cNvSpPr txBox="1"/>
-          <p:nvPr/>
-        </p:nvSpPr>
-        <p:spPr>
-          <a:xfrm>
-            <a:off x="6565392" y="1481328"/>
-            <a:ext cx="4791455" cy="256032"/>
-          </a:xfrm>
-          <a:prstGeom prst="rect">
-            <a:avLst/>
-          </a:prstGeom>
-          <a:noFill/>
-        </p:spPr>
-        <p:txBody>
-          <a:bodyPr wrap="square">
-            <a:normAutofit/>
-          </a:bodyPr>
-          <a:lstStyle/>
-          <a:p>
-            <a:r>
-              <a:rPr sz="1000" b="1">
-                <a:solidFill>
-                  <a:srgbClr val="566573"/>
-                </a:solidFill>
-                <a:latin typeface="Aptos"/>
-              </a:rPr>
-              <a:t>Platform Compliance</a:t>
-            </a:r>
-          </a:p>
-        </p:txBody>
-      </p:sp>
-      <p:sp>
-        <p:nvSpPr>
-          <p:cNvPr id="14" name="TextBox 13"/>
-          <p:cNvSpPr txBox="1"/>
-          <p:nvPr/>
-        </p:nvSpPr>
-        <p:spPr>
-          <a:xfrm>
-            <a:off x="6565392" y="1773936"/>
-            <a:ext cx="4791455" cy="484632"/>
-          </a:xfrm>
-          <a:prstGeom prst="rect">
-            <a:avLst/>
-          </a:prstGeom>
-          <a:noFill/>
-        </p:spPr>
-        <p:txBody>
-          <a:bodyPr wrap="square">
-            <a:normAutofit/>
-          </a:bodyPr>
-          <a:lstStyle/>
-          <a:p>
-            <a:r>
-              <a:rPr sz="2000" b="1">
-                <a:solidFill>
-                  <a:srgbClr val="0B3C5D"/>
-                </a:solidFill>
-                <a:latin typeface="Aptos"/>
-              </a:rPr>
-              <a:t>Required GitHub folders and runnable code</a:t>
-            </a:r>
-          </a:p>
-        </p:txBody>
-      </p:sp>
-      <p:sp>
-        <p:nvSpPr>
-          <p:cNvPr id="15" name="Rounded Rectangle 14"/>
-          <p:cNvSpPr/>
-          <p:nvPr/>
-        </p:nvSpPr>
-        <p:spPr>
-          <a:xfrm>
-            <a:off x="685800" y="2788920"/>
-            <a:ext cx="5120640" cy="960120"/>
-          </a:xfrm>
-          <a:prstGeom prst="roundRect">
-            <a:avLst/>
-          </a:prstGeom>
-          <a:solidFill>
-            <a:srgbClr val="E8F8F5"/>
-          </a:solidFill>
-          <a:ln>
-            <a:solidFill>
-              <a:srgbClr val="CCD1D1"/>
-            </a:solidFill>
-          </a:ln>
-        </p:spPr>
-        <p:style>
-          <a:lnRef idx="1">
-            <a:schemeClr val="accent1"/>
-          </a:lnRef>
-          <a:fillRef idx="3">
-            <a:schemeClr val="accent1"/>
-          </a:fillRef>
-          <a:effectRef idx="2">
-            <a:schemeClr val="accent1"/>
-          </a:effectRef>
-          <a:fontRef idx="minor">
-            <a:schemeClr val="lt1"/>
-          </a:fontRef>
-        </p:style>
-        <p:txBody>
-          <a:bodyPr rtlCol="0" anchor="ctr"/>
-          <a:lstStyle/>
-          <a:p>
-            <a:pPr algn="ctr"/>
-          </a:p>
-        </p:txBody>
-      </p:sp>
-      <p:sp>
-        <p:nvSpPr>
-          <p:cNvPr id="16" name="TextBox 15"/>
-          <p:cNvSpPr txBox="1"/>
-          <p:nvPr/>
-        </p:nvSpPr>
-        <p:spPr>
-          <a:xfrm>
-            <a:off x="850392" y="2898648"/>
-            <a:ext cx="4791455" cy="256032"/>
-          </a:xfrm>
-          <a:prstGeom prst="rect">
-            <a:avLst/>
-          </a:prstGeom>
-          <a:noFill/>
-        </p:spPr>
-        <p:txBody>
-          <a:bodyPr wrap="square">
-            <a:normAutofit/>
-          </a:bodyPr>
-          <a:lstStyle/>
-          <a:p>
-            <a:r>
-              <a:rPr sz="1000" b="1">
-                <a:solidFill>
-                  <a:srgbClr val="566573"/>
-                </a:solidFill>
-                <a:latin typeface="Aptos"/>
-              </a:rPr>
-              <a:t>Revision Handling</a:t>
-            </a:r>
-          </a:p>
-        </p:txBody>
-      </p:sp>
-      <p:sp>
-        <p:nvSpPr>
-          <p:cNvPr id="17" name="TextBox 16"/>
-          <p:cNvSpPr txBox="1"/>
-          <p:nvPr/>
-        </p:nvSpPr>
-        <p:spPr>
-          <a:xfrm>
-            <a:off x="850392" y="3191256"/>
-            <a:ext cx="4791455" cy="484632"/>
-          </a:xfrm>
-          <a:prstGeom prst="rect">
-            <a:avLst/>
-          </a:prstGeom>
-          <a:noFill/>
-        </p:spPr>
-        <p:txBody>
-          <a:bodyPr wrap="square">
-            <a:normAutofit/>
-          </a:bodyPr>
-          <a:lstStyle/>
-          <a:p>
-            <a:r>
-              <a:rPr sz="2000" b="1">
-                <a:solidFill>
-                  <a:srgbClr val="0B3C5D"/>
-                </a:solidFill>
-                <a:latin typeface="Aptos"/>
-              </a:rPr>
-              <a:t>Report, PPT, README, figures, templates, generator</a:t>
-            </a:r>
-          </a:p>
-        </p:txBody>
-      </p:sp>
-      <p:sp>
-        <p:nvSpPr>
-          <p:cNvPr id="18" name="Rounded Rectangle 17"/>
-          <p:cNvSpPr/>
-          <p:nvPr/>
-        </p:nvSpPr>
-        <p:spPr>
-          <a:xfrm>
-            <a:off x="6400800" y="2788920"/>
-            <a:ext cx="5120640" cy="960120"/>
-          </a:xfrm>
-          <a:prstGeom prst="roundRect">
-            <a:avLst/>
-          </a:prstGeom>
-          <a:solidFill>
-            <a:srgbClr val="F4ECF7"/>
-          </a:solidFill>
-          <a:ln>
-            <a:solidFill>
-              <a:srgbClr val="CCD1D1"/>
-            </a:solidFill>
-          </a:ln>
-        </p:spPr>
-        <p:style>
-          <a:lnRef idx="1">
-            <a:schemeClr val="accent1"/>
-          </a:lnRef>
-          <a:fillRef idx="3">
-            <a:schemeClr val="accent1"/>
-          </a:fillRef>
-          <a:effectRef idx="2">
-            <a:schemeClr val="accent1"/>
-          </a:effectRef>
-          <a:fontRef idx="minor">
-            <a:schemeClr val="lt1"/>
-          </a:fontRef>
-        </p:style>
-        <p:txBody>
-          <a:bodyPr rtlCol="0" anchor="ctr"/>
-          <a:lstStyle/>
-          <a:p>
-            <a:pPr algn="ctr"/>
-          </a:p>
-        </p:txBody>
-      </p:sp>
-      <p:sp>
-        <p:nvSpPr>
-          <p:cNvPr id="19" name="TextBox 18"/>
-          <p:cNvSpPr txBox="1"/>
-          <p:nvPr/>
-        </p:nvSpPr>
-        <p:spPr>
-          <a:xfrm>
-            <a:off x="6565392" y="2898648"/>
-            <a:ext cx="4791455" cy="256032"/>
-          </a:xfrm>
-          <a:prstGeom prst="rect">
-            <a:avLst/>
-          </a:prstGeom>
-          <a:noFill/>
-        </p:spPr>
-        <p:txBody>
-          <a:bodyPr wrap="square">
-            <a:normAutofit/>
-          </a:bodyPr>
-          <a:lstStyle/>
-          <a:p>
-            <a:r>
-              <a:rPr sz="1000" b="1">
-                <a:solidFill>
-                  <a:srgbClr val="566573"/>
-                </a:solidFill>
-                <a:latin typeface="Aptos"/>
-              </a:rPr>
-              <a:t>Supervisor Updates</a:t>
-            </a:r>
-          </a:p>
-        </p:txBody>
-      </p:sp>
-      <p:sp>
-        <p:nvSpPr>
-          <p:cNvPr id="20" name="TextBox 19"/>
-          <p:cNvSpPr txBox="1"/>
-          <p:nvPr/>
-        </p:nvSpPr>
-        <p:spPr>
-          <a:xfrm>
-            <a:off x="6565392" y="3191256"/>
-            <a:ext cx="4791455" cy="484632"/>
-          </a:xfrm>
-          <a:prstGeom prst="rect">
-            <a:avLst/>
-          </a:prstGeom>
-          <a:noFill/>
-        </p:spPr>
-        <p:txBody>
-          <a:bodyPr wrap="square">
-            <a:normAutofit/>
-          </a:bodyPr>
-          <a:lstStyle/>
-          <a:p>
-            <a:r>
-              <a:rPr sz="2000" b="1">
-                <a:solidFill>
-                  <a:srgbClr val="0B3C5D"/>
-                </a:solidFill>
-                <a:latin typeface="Aptos"/>
-              </a:rPr>
-              <a:t>Progress and feedback reflected in final documentation</a:t>
-            </a:r>
-          </a:p>
-        </p:txBody>
-      </p:sp>
-      <p:sp>
-        <p:nvSpPr>
-          <p:cNvPr id="21" name="TextBox 20"/>
-          <p:cNvSpPr txBox="1"/>
-          <p:nvPr/>
-        </p:nvSpPr>
-        <p:spPr>
-          <a:xfrm>
-            <a:off x="914400" y="4572000"/>
-            <a:ext cx="10241280" cy="914400"/>
-          </a:xfrm>
-          <a:prstGeom prst="rect">
-            <a:avLst/>
-          </a:prstGeom>
-          <a:noFill/>
-        </p:spPr>
-        <p:txBody>
-          <a:bodyPr wrap="square">
-            <a:normAutofit/>
-          </a:bodyPr>
-          <a:lstStyle/>
-          <a:p>
             <a:pPr>
-              <a:defRPr sz="1600">
+              <a:defRPr sz="1200">
                 <a:solidFill>
                   <a:srgbClr val="1B2631"/>
                 </a:solidFill>
@@ -4796,12 +4867,12 @@
               </a:defRPr>
             </a:pPr>
             <a:r>
-              <a:t>Repository is organized for external verification.</a:t>
+              <a:t>Feature-importance artifacts are generated for every benchmark run.</a:t>
             </a:r>
           </a:p>
           <a:p>
             <a:pPr>
-              <a:defRPr sz="1600">
+              <a:defRPr sz="1200">
                 <a:solidFill>
                   <a:srgbClr val="1B2631"/>
                 </a:solidFill>
@@ -4809,7 +4880,20 @@
               </a:defRPr>
             </a:pPr>
             <a:r>
-              <a:t>Final documents explain the project, evidence, run commands, and submission status.</a:t>
+              <a:t>Metrics are exported as JSON and summarized in CSV.</a:t>
+            </a:r>
+          </a:p>
+          <a:p>
+            <a:pPr>
+              <a:defRPr sz="1200">
+                <a:solidFill>
+                  <a:srgbClr val="1B2631"/>
+                </a:solidFill>
+                <a:latin typeface="Aptos"/>
+              </a:defRPr>
+            </a:pPr>
+            <a:r>
+              <a:t>Final report values can be traced to saved repository artifacts.</a:t>
             </a:r>
           </a:p>
         </p:txBody>
@@ -4937,7 +5021,7 @@
                 </a:solidFill>
                 <a:latin typeface="Aptos"/>
               </a:rPr>
-              <a:t>Conclusion And Future Scope</a:t>
+              <a:t>GitHub Submission Structure</a:t>
             </a:r>
           </a:p>
         </p:txBody>
@@ -4995,8 +5079,8 @@
         </p:nvSpPr>
         <p:spPr>
           <a:xfrm>
-            <a:off x="822960" y="1463040"/>
-            <a:ext cx="10241280" cy="4297680"/>
+            <a:off x="822960" y="1417320"/>
+            <a:ext cx="10241280" cy="4480560"/>
           </a:xfrm>
           <a:prstGeom prst="rect">
             <a:avLst/>
@@ -5018,7 +5102,7 @@
               </a:defRPr>
             </a:pPr>
             <a:r>
-              <a:t>Delivered a reproducible AI-based loan risk assessment package.</a:t>
+              <a:t>IPR Submission Proof: placeholder for copyright form and screenshot.</a:t>
             </a:r>
           </a:p>
           <a:p>
@@ -5031,7 +5115,7 @@
               </a:defRPr>
             </a:pPr>
             <a:r>
-              <a:t>Credit-scoring benchmark identifies strong transparent baselines.</a:t>
+              <a:t>Report and PPT: final DOCX, PPTX, templates, markdown, and figures.</a:t>
             </a:r>
           </a:p>
           <a:p>
@@ -5044,7 +5128,7 @@
               </a:defRPr>
             </a:pPr>
             <a:r>
-              <a:t>OCR workflow shows practical document-intake extension potential.</a:t>
+              <a:t>Source code: runnable code, configs, tests, data samples, and artifacts.</a:t>
             </a:r>
           </a:p>
           <a:p>
@@ -5057,7 +5141,7 @@
               </a:defRPr>
             </a:pPr>
             <a:r>
-              <a:t>Future work: larger Lending Club experiments, SHAP explanations, scanned-form OCR evaluation, and API deployment.</a:t>
+              <a:t>README.md: team details, project type, status, and run instructions.</a:t>
             </a:r>
           </a:p>
         </p:txBody>
@@ -5164,6 +5248,962 @@
         </p:nvSpPr>
         <p:spPr>
           <a:xfrm>
+            <a:off x="502920" y="256032"/>
+            <a:ext cx="11155680" cy="502920"/>
+          </a:xfrm>
+          <a:prstGeom prst="rect">
+            <a:avLst/>
+          </a:prstGeom>
+          <a:noFill/>
+        </p:spPr>
+        <p:txBody>
+          <a:bodyPr wrap="square">
+            <a:normAutofit/>
+          </a:bodyPr>
+          <a:lstStyle/>
+          <a:p>
+            <a:r>
+              <a:rPr sz="2500" b="1">
+                <a:solidFill>
+                  <a:srgbClr val="0B3C5D"/>
+                </a:solidFill>
+                <a:latin typeface="Aptos"/>
+              </a:rPr>
+              <a:t>Evaluation Readiness</a:t>
+            </a:r>
+          </a:p>
+        </p:txBody>
+      </p:sp>
+      <p:sp>
+        <p:nvSpPr>
+          <p:cNvPr id="7" name="TextBox 6"/>
+          <p:cNvSpPr txBox="1"/>
+          <p:nvPr/>
+        </p:nvSpPr>
+        <p:spPr>
+          <a:xfrm>
+            <a:off x="530352" y="786384"/>
+            <a:ext cx="10607040" cy="292608"/>
+          </a:xfrm>
+          <a:prstGeom prst="rect">
+            <a:avLst/>
+          </a:prstGeom>
+          <a:noFill/>
+        </p:spPr>
+        <p:txBody>
+          <a:bodyPr wrap="square">
+            <a:normAutofit/>
+          </a:bodyPr>
+          <a:lstStyle/>
+          <a:p>
+            <a:r>
+              <a:rPr sz="1100" b="0">
+                <a:solidFill>
+                  <a:srgbClr val="566573"/>
+                </a:solidFill>
+                <a:latin typeface="Aptos"/>
+              </a:rPr>
+              <a:t>Mapped directly to the final marking areas.</a:t>
+            </a:r>
+          </a:p>
+        </p:txBody>
+      </p:sp>
+      <p:sp>
+        <p:nvSpPr>
+          <p:cNvPr id="8" name="Rectangle 7"/>
+          <p:cNvSpPr/>
+          <p:nvPr/>
+        </p:nvSpPr>
+        <p:spPr>
+          <a:xfrm>
+            <a:off x="530352" y="1078992"/>
+            <a:ext cx="1920240" cy="27432"/>
+          </a:xfrm>
+          <a:prstGeom prst="rect">
+            <a:avLst/>
+          </a:prstGeom>
+          <a:solidFill>
+            <a:srgbClr val="D68910"/>
+          </a:solidFill>
+          <a:ln>
+            <a:solidFill>
+              <a:srgbClr val="D68910"/>
+            </a:solidFill>
+          </a:ln>
+        </p:spPr>
+        <p:style>
+          <a:lnRef idx="1">
+            <a:schemeClr val="accent1"/>
+          </a:lnRef>
+          <a:fillRef idx="3">
+            <a:schemeClr val="accent1"/>
+          </a:fillRef>
+          <a:effectRef idx="2">
+            <a:schemeClr val="accent1"/>
+          </a:effectRef>
+          <a:fontRef idx="minor">
+            <a:schemeClr val="lt1"/>
+          </a:fontRef>
+        </p:style>
+        <p:txBody>
+          <a:bodyPr rtlCol="0" anchor="ctr"/>
+          <a:lstStyle/>
+          <a:p>
+            <a:pPr algn="ctr"/>
+          </a:p>
+        </p:txBody>
+      </p:sp>
+      <p:sp>
+        <p:nvSpPr>
+          <p:cNvPr id="9" name="Rounded Rectangle 8"/>
+          <p:cNvSpPr/>
+          <p:nvPr/>
+        </p:nvSpPr>
+        <p:spPr>
+          <a:xfrm>
+            <a:off x="685800" y="1371600"/>
+            <a:ext cx="5120640" cy="960120"/>
+          </a:xfrm>
+          <a:prstGeom prst="roundRect">
+            <a:avLst/>
+          </a:prstGeom>
+          <a:solidFill>
+            <a:srgbClr val="FEF9E7"/>
+          </a:solidFill>
+          <a:ln>
+            <a:solidFill>
+              <a:srgbClr val="CCD1D1"/>
+            </a:solidFill>
+          </a:ln>
+        </p:spPr>
+        <p:style>
+          <a:lnRef idx="1">
+            <a:schemeClr val="accent1"/>
+          </a:lnRef>
+          <a:fillRef idx="3">
+            <a:schemeClr val="accent1"/>
+          </a:fillRef>
+          <a:effectRef idx="2">
+            <a:schemeClr val="accent1"/>
+          </a:effectRef>
+          <a:fontRef idx="minor">
+            <a:schemeClr val="lt1"/>
+          </a:fontRef>
+        </p:style>
+        <p:txBody>
+          <a:bodyPr rtlCol="0" anchor="ctr"/>
+          <a:lstStyle/>
+          <a:p>
+            <a:pPr algn="ctr"/>
+          </a:p>
+        </p:txBody>
+      </p:sp>
+      <p:sp>
+        <p:nvSpPr>
+          <p:cNvPr id="10" name="TextBox 9"/>
+          <p:cNvSpPr txBox="1"/>
+          <p:nvPr/>
+        </p:nvSpPr>
+        <p:spPr>
+          <a:xfrm>
+            <a:off x="850392" y="1481328"/>
+            <a:ext cx="4791455" cy="256032"/>
+          </a:xfrm>
+          <a:prstGeom prst="rect">
+            <a:avLst/>
+          </a:prstGeom>
+          <a:noFill/>
+        </p:spPr>
+        <p:txBody>
+          <a:bodyPr wrap="square">
+            <a:normAutofit/>
+          </a:bodyPr>
+          <a:lstStyle/>
+          <a:p>
+            <a:r>
+              <a:rPr sz="1000" b="1">
+                <a:solidFill>
+                  <a:srgbClr val="566573"/>
+                </a:solidFill>
+                <a:latin typeface="Aptos"/>
+              </a:rPr>
+              <a:t>Filing Status</a:t>
+            </a:r>
+          </a:p>
+        </p:txBody>
+      </p:sp>
+      <p:sp>
+        <p:nvSpPr>
+          <p:cNvPr id="11" name="TextBox 10"/>
+          <p:cNvSpPr txBox="1"/>
+          <p:nvPr/>
+        </p:nvSpPr>
+        <p:spPr>
+          <a:xfrm>
+            <a:off x="850392" y="1773936"/>
+            <a:ext cx="4791455" cy="484632"/>
+          </a:xfrm>
+          <a:prstGeom prst="rect">
+            <a:avLst/>
+          </a:prstGeom>
+          <a:noFill/>
+        </p:spPr>
+        <p:txBody>
+          <a:bodyPr wrap="square">
+            <a:normAutofit/>
+          </a:bodyPr>
+          <a:lstStyle/>
+          <a:p>
+            <a:r>
+              <a:rPr sz="2000" b="1">
+                <a:solidFill>
+                  <a:srgbClr val="0B3C5D"/>
+                </a:solidFill>
+                <a:latin typeface="Aptos"/>
+              </a:rPr>
+              <a:t>IPR proof folder and copyright placeholder</a:t>
+            </a:r>
+          </a:p>
+        </p:txBody>
+      </p:sp>
+      <p:sp>
+        <p:nvSpPr>
+          <p:cNvPr id="12" name="Rounded Rectangle 11"/>
+          <p:cNvSpPr/>
+          <p:nvPr/>
+        </p:nvSpPr>
+        <p:spPr>
+          <a:xfrm>
+            <a:off x="6400800" y="1371600"/>
+            <a:ext cx="5120640" cy="960120"/>
+          </a:xfrm>
+          <a:prstGeom prst="roundRect">
+            <a:avLst/>
+          </a:prstGeom>
+          <a:solidFill>
+            <a:srgbClr val="EAF2F8"/>
+          </a:solidFill>
+          <a:ln>
+            <a:solidFill>
+              <a:srgbClr val="CCD1D1"/>
+            </a:solidFill>
+          </a:ln>
+        </p:spPr>
+        <p:style>
+          <a:lnRef idx="1">
+            <a:schemeClr val="accent1"/>
+          </a:lnRef>
+          <a:fillRef idx="3">
+            <a:schemeClr val="accent1"/>
+          </a:fillRef>
+          <a:effectRef idx="2">
+            <a:schemeClr val="accent1"/>
+          </a:effectRef>
+          <a:fontRef idx="minor">
+            <a:schemeClr val="lt1"/>
+          </a:fontRef>
+        </p:style>
+        <p:txBody>
+          <a:bodyPr rtlCol="0" anchor="ctr"/>
+          <a:lstStyle/>
+          <a:p>
+            <a:pPr algn="ctr"/>
+          </a:p>
+        </p:txBody>
+      </p:sp>
+      <p:sp>
+        <p:nvSpPr>
+          <p:cNvPr id="13" name="TextBox 12"/>
+          <p:cNvSpPr txBox="1"/>
+          <p:nvPr/>
+        </p:nvSpPr>
+        <p:spPr>
+          <a:xfrm>
+            <a:off x="6565392" y="1481328"/>
+            <a:ext cx="4791455" cy="256032"/>
+          </a:xfrm>
+          <a:prstGeom prst="rect">
+            <a:avLst/>
+          </a:prstGeom>
+          <a:noFill/>
+        </p:spPr>
+        <p:txBody>
+          <a:bodyPr wrap="square">
+            <a:normAutofit/>
+          </a:bodyPr>
+          <a:lstStyle/>
+          <a:p>
+            <a:r>
+              <a:rPr sz="1000" b="1">
+                <a:solidFill>
+                  <a:srgbClr val="566573"/>
+                </a:solidFill>
+                <a:latin typeface="Aptos"/>
+              </a:rPr>
+              <a:t>Platform Compliance</a:t>
+            </a:r>
+          </a:p>
+        </p:txBody>
+      </p:sp>
+      <p:sp>
+        <p:nvSpPr>
+          <p:cNvPr id="14" name="TextBox 13"/>
+          <p:cNvSpPr txBox="1"/>
+          <p:nvPr/>
+        </p:nvSpPr>
+        <p:spPr>
+          <a:xfrm>
+            <a:off x="6565392" y="1773936"/>
+            <a:ext cx="4791455" cy="484632"/>
+          </a:xfrm>
+          <a:prstGeom prst="rect">
+            <a:avLst/>
+          </a:prstGeom>
+          <a:noFill/>
+        </p:spPr>
+        <p:txBody>
+          <a:bodyPr wrap="square">
+            <a:normAutofit/>
+          </a:bodyPr>
+          <a:lstStyle/>
+          <a:p>
+            <a:r>
+              <a:rPr sz="2000" b="1">
+                <a:solidFill>
+                  <a:srgbClr val="0B3C5D"/>
+                </a:solidFill>
+                <a:latin typeface="Aptos"/>
+              </a:rPr>
+              <a:t>Required GitHub folders and runnable code</a:t>
+            </a:r>
+          </a:p>
+        </p:txBody>
+      </p:sp>
+      <p:sp>
+        <p:nvSpPr>
+          <p:cNvPr id="15" name="Rounded Rectangle 14"/>
+          <p:cNvSpPr/>
+          <p:nvPr/>
+        </p:nvSpPr>
+        <p:spPr>
+          <a:xfrm>
+            <a:off x="685800" y="2788920"/>
+            <a:ext cx="5120640" cy="960120"/>
+          </a:xfrm>
+          <a:prstGeom prst="roundRect">
+            <a:avLst/>
+          </a:prstGeom>
+          <a:solidFill>
+            <a:srgbClr val="E8F8F5"/>
+          </a:solidFill>
+          <a:ln>
+            <a:solidFill>
+              <a:srgbClr val="CCD1D1"/>
+            </a:solidFill>
+          </a:ln>
+        </p:spPr>
+        <p:style>
+          <a:lnRef idx="1">
+            <a:schemeClr val="accent1"/>
+          </a:lnRef>
+          <a:fillRef idx="3">
+            <a:schemeClr val="accent1"/>
+          </a:fillRef>
+          <a:effectRef idx="2">
+            <a:schemeClr val="accent1"/>
+          </a:effectRef>
+          <a:fontRef idx="minor">
+            <a:schemeClr val="lt1"/>
+          </a:fontRef>
+        </p:style>
+        <p:txBody>
+          <a:bodyPr rtlCol="0" anchor="ctr"/>
+          <a:lstStyle/>
+          <a:p>
+            <a:pPr algn="ctr"/>
+          </a:p>
+        </p:txBody>
+      </p:sp>
+      <p:sp>
+        <p:nvSpPr>
+          <p:cNvPr id="16" name="TextBox 15"/>
+          <p:cNvSpPr txBox="1"/>
+          <p:nvPr/>
+        </p:nvSpPr>
+        <p:spPr>
+          <a:xfrm>
+            <a:off x="850392" y="2898648"/>
+            <a:ext cx="4791455" cy="256032"/>
+          </a:xfrm>
+          <a:prstGeom prst="rect">
+            <a:avLst/>
+          </a:prstGeom>
+          <a:noFill/>
+        </p:spPr>
+        <p:txBody>
+          <a:bodyPr wrap="square">
+            <a:normAutofit/>
+          </a:bodyPr>
+          <a:lstStyle/>
+          <a:p>
+            <a:r>
+              <a:rPr sz="1000" b="1">
+                <a:solidFill>
+                  <a:srgbClr val="566573"/>
+                </a:solidFill>
+                <a:latin typeface="Aptos"/>
+              </a:rPr>
+              <a:t>Revision Handling</a:t>
+            </a:r>
+          </a:p>
+        </p:txBody>
+      </p:sp>
+      <p:sp>
+        <p:nvSpPr>
+          <p:cNvPr id="17" name="TextBox 16"/>
+          <p:cNvSpPr txBox="1"/>
+          <p:nvPr/>
+        </p:nvSpPr>
+        <p:spPr>
+          <a:xfrm>
+            <a:off x="850392" y="3191256"/>
+            <a:ext cx="4791455" cy="484632"/>
+          </a:xfrm>
+          <a:prstGeom prst="rect">
+            <a:avLst/>
+          </a:prstGeom>
+          <a:noFill/>
+        </p:spPr>
+        <p:txBody>
+          <a:bodyPr wrap="square">
+            <a:normAutofit/>
+          </a:bodyPr>
+          <a:lstStyle/>
+          <a:p>
+            <a:r>
+              <a:rPr sz="2000" b="1">
+                <a:solidFill>
+                  <a:srgbClr val="0B3C5D"/>
+                </a:solidFill>
+                <a:latin typeface="Aptos"/>
+              </a:rPr>
+              <a:t>Report, PPT, README, figures, templates, generator</a:t>
+            </a:r>
+          </a:p>
+        </p:txBody>
+      </p:sp>
+      <p:sp>
+        <p:nvSpPr>
+          <p:cNvPr id="18" name="Rounded Rectangle 17"/>
+          <p:cNvSpPr/>
+          <p:nvPr/>
+        </p:nvSpPr>
+        <p:spPr>
+          <a:xfrm>
+            <a:off x="6400800" y="2788920"/>
+            <a:ext cx="5120640" cy="960120"/>
+          </a:xfrm>
+          <a:prstGeom prst="roundRect">
+            <a:avLst/>
+          </a:prstGeom>
+          <a:solidFill>
+            <a:srgbClr val="F4ECF7"/>
+          </a:solidFill>
+          <a:ln>
+            <a:solidFill>
+              <a:srgbClr val="CCD1D1"/>
+            </a:solidFill>
+          </a:ln>
+        </p:spPr>
+        <p:style>
+          <a:lnRef idx="1">
+            <a:schemeClr val="accent1"/>
+          </a:lnRef>
+          <a:fillRef idx="3">
+            <a:schemeClr val="accent1"/>
+          </a:fillRef>
+          <a:effectRef idx="2">
+            <a:schemeClr val="accent1"/>
+          </a:effectRef>
+          <a:fontRef idx="minor">
+            <a:schemeClr val="lt1"/>
+          </a:fontRef>
+        </p:style>
+        <p:txBody>
+          <a:bodyPr rtlCol="0" anchor="ctr"/>
+          <a:lstStyle/>
+          <a:p>
+            <a:pPr algn="ctr"/>
+          </a:p>
+        </p:txBody>
+      </p:sp>
+      <p:sp>
+        <p:nvSpPr>
+          <p:cNvPr id="19" name="TextBox 18"/>
+          <p:cNvSpPr txBox="1"/>
+          <p:nvPr/>
+        </p:nvSpPr>
+        <p:spPr>
+          <a:xfrm>
+            <a:off x="6565392" y="2898648"/>
+            <a:ext cx="4791455" cy="256032"/>
+          </a:xfrm>
+          <a:prstGeom prst="rect">
+            <a:avLst/>
+          </a:prstGeom>
+          <a:noFill/>
+        </p:spPr>
+        <p:txBody>
+          <a:bodyPr wrap="square">
+            <a:normAutofit/>
+          </a:bodyPr>
+          <a:lstStyle/>
+          <a:p>
+            <a:r>
+              <a:rPr sz="1000" b="1">
+                <a:solidFill>
+                  <a:srgbClr val="566573"/>
+                </a:solidFill>
+                <a:latin typeface="Aptos"/>
+              </a:rPr>
+              <a:t>Supervisor Updates</a:t>
+            </a:r>
+          </a:p>
+        </p:txBody>
+      </p:sp>
+      <p:sp>
+        <p:nvSpPr>
+          <p:cNvPr id="20" name="TextBox 19"/>
+          <p:cNvSpPr txBox="1"/>
+          <p:nvPr/>
+        </p:nvSpPr>
+        <p:spPr>
+          <a:xfrm>
+            <a:off x="6565392" y="3191256"/>
+            <a:ext cx="4791455" cy="484632"/>
+          </a:xfrm>
+          <a:prstGeom prst="rect">
+            <a:avLst/>
+          </a:prstGeom>
+          <a:noFill/>
+        </p:spPr>
+        <p:txBody>
+          <a:bodyPr wrap="square">
+            <a:normAutofit/>
+          </a:bodyPr>
+          <a:lstStyle/>
+          <a:p>
+            <a:r>
+              <a:rPr sz="2000" b="1">
+                <a:solidFill>
+                  <a:srgbClr val="0B3C5D"/>
+                </a:solidFill>
+                <a:latin typeface="Aptos"/>
+              </a:rPr>
+              <a:t>Progress and feedback reflected in final documentation</a:t>
+            </a:r>
+          </a:p>
+        </p:txBody>
+      </p:sp>
+      <p:sp>
+        <p:nvSpPr>
+          <p:cNvPr id="21" name="TextBox 20"/>
+          <p:cNvSpPr txBox="1"/>
+          <p:nvPr/>
+        </p:nvSpPr>
+        <p:spPr>
+          <a:xfrm>
+            <a:off x="914400" y="4572000"/>
+            <a:ext cx="10241280" cy="914400"/>
+          </a:xfrm>
+          <a:prstGeom prst="rect">
+            <a:avLst/>
+          </a:prstGeom>
+          <a:noFill/>
+        </p:spPr>
+        <p:txBody>
+          <a:bodyPr wrap="square">
+            <a:normAutofit/>
+          </a:bodyPr>
+          <a:lstStyle/>
+          <a:p>
+            <a:pPr>
+              <a:defRPr sz="1600">
+                <a:solidFill>
+                  <a:srgbClr val="1B2631"/>
+                </a:solidFill>
+                <a:latin typeface="Aptos"/>
+              </a:defRPr>
+            </a:pPr>
+            <a:r>
+              <a:t>Repository is organized for external verification.</a:t>
+            </a:r>
+          </a:p>
+          <a:p>
+            <a:pPr>
+              <a:defRPr sz="1600">
+                <a:solidFill>
+                  <a:srgbClr val="1B2631"/>
+                </a:solidFill>
+                <a:latin typeface="Aptos"/>
+              </a:defRPr>
+            </a:pPr>
+            <a:r>
+              <a:t>Final documents explain the project, evidence, run commands, and submission status.</a:t>
+            </a:r>
+          </a:p>
+        </p:txBody>
+      </p:sp>
+    </p:spTree>
+  </p:cSld>
+  <p:clrMapOvr>
+    <a:masterClrMapping/>
+  </p:clrMapOvr>
+</p:sld>
+</file>
+
+<file path=ppt/slides/slide14.xml><?xml version="1.0" encoding="utf-8"?>
+<p:sld xmlns:a="http://schemas.openxmlformats.org/drawingml/2006/main" xmlns:p="http://schemas.openxmlformats.org/presentationml/2006/main" xmlns:r="http://schemas.openxmlformats.org/officeDocument/2006/relationships">
+  <p:cSld>
+    <p:bg>
+      <p:bgPr>
+        <a:solidFill>
+          <a:srgbClr val="F7F9FB"/>
+        </a:solidFill>
+        <a:effectLst/>
+      </p:bgPr>
+    </p:bg>
+    <p:spTree>
+      <p:nvGrpSpPr>
+        <p:cNvPr id="1" name=""/>
+        <p:cNvGrpSpPr/>
+        <p:nvPr/>
+      </p:nvGrpSpPr>
+      <p:grpSpPr/>
+      <p:sp>
+        <p:nvSpPr>
+          <p:cNvPr id="2" name="Title 1"/>
+          <p:cNvSpPr>
+            <a:spLocks noGrp="1"/>
+          </p:cNvSpPr>
+          <p:nvPr>
+            <p:ph type="title"/>
+          </p:nvPr>
+        </p:nvSpPr>
+        <p:spPr/>
+        <p:txBody>
+          <a:bodyPr/>
+          <a:lstStyle/>
+          <a:p/>
+        </p:txBody>
+      </p:sp>
+      <p:sp>
+        <p:nvSpPr>
+          <p:cNvPr id="3" name="Text Placeholder 2"/>
+          <p:cNvSpPr>
+            <a:spLocks noGrp="1"/>
+          </p:cNvSpPr>
+          <p:nvPr>
+            <p:ph type="body"/>
+          </p:nvPr>
+        </p:nvSpPr>
+        <p:spPr/>
+        <p:txBody>
+          <a:bodyPr/>
+          <a:lstStyle/>
+          <a:p/>
+        </p:txBody>
+      </p:sp>
+      <p:sp>
+        <p:nvSpPr>
+          <p:cNvPr id="4" name="Text Placeholder 3"/>
+          <p:cNvSpPr>
+            <a:spLocks noGrp="1"/>
+          </p:cNvSpPr>
+          <p:nvPr>
+            <p:ph type="body"/>
+          </p:nvPr>
+        </p:nvSpPr>
+        <p:spPr/>
+        <p:txBody>
+          <a:bodyPr/>
+          <a:lstStyle/>
+          <a:p/>
+        </p:txBody>
+      </p:sp>
+      <p:sp>
+        <p:nvSpPr>
+          <p:cNvPr id="5" name="Text Placeholder 4"/>
+          <p:cNvSpPr>
+            <a:spLocks noGrp="1"/>
+          </p:cNvSpPr>
+          <p:nvPr>
+            <p:ph type="body"/>
+          </p:nvPr>
+        </p:nvSpPr>
+        <p:spPr/>
+        <p:txBody>
+          <a:bodyPr/>
+          <a:lstStyle/>
+          <a:p/>
+        </p:txBody>
+      </p:sp>
+      <p:sp>
+        <p:nvSpPr>
+          <p:cNvPr id="6" name="TextBox 5"/>
+          <p:cNvSpPr txBox="1"/>
+          <p:nvPr/>
+        </p:nvSpPr>
+        <p:spPr>
+          <a:xfrm>
+            <a:off x="502920" y="256032"/>
+            <a:ext cx="11155680" cy="502920"/>
+          </a:xfrm>
+          <a:prstGeom prst="rect">
+            <a:avLst/>
+          </a:prstGeom>
+          <a:noFill/>
+        </p:spPr>
+        <p:txBody>
+          <a:bodyPr wrap="square">
+            <a:normAutofit/>
+          </a:bodyPr>
+          <a:lstStyle/>
+          <a:p>
+            <a:r>
+              <a:rPr sz="2500" b="1">
+                <a:solidFill>
+                  <a:srgbClr val="0B3C5D"/>
+                </a:solidFill>
+                <a:latin typeface="Aptos"/>
+              </a:rPr>
+              <a:t>Conclusion And Future Scope</a:t>
+            </a:r>
+          </a:p>
+        </p:txBody>
+      </p:sp>
+      <p:sp>
+        <p:nvSpPr>
+          <p:cNvPr id="7" name="Rectangle 6"/>
+          <p:cNvSpPr/>
+          <p:nvPr/>
+        </p:nvSpPr>
+        <p:spPr>
+          <a:xfrm>
+            <a:off x="530352" y="1078992"/>
+            <a:ext cx="1920240" cy="27432"/>
+          </a:xfrm>
+          <a:prstGeom prst="rect">
+            <a:avLst/>
+          </a:prstGeom>
+          <a:solidFill>
+            <a:srgbClr val="D68910"/>
+          </a:solidFill>
+          <a:ln>
+            <a:solidFill>
+              <a:srgbClr val="D68910"/>
+            </a:solidFill>
+          </a:ln>
+        </p:spPr>
+        <p:style>
+          <a:lnRef idx="1">
+            <a:schemeClr val="accent1"/>
+          </a:lnRef>
+          <a:fillRef idx="3">
+            <a:schemeClr val="accent1"/>
+          </a:fillRef>
+          <a:effectRef idx="2">
+            <a:schemeClr val="accent1"/>
+          </a:effectRef>
+          <a:fontRef idx="minor">
+            <a:schemeClr val="lt1"/>
+          </a:fontRef>
+        </p:style>
+        <p:txBody>
+          <a:bodyPr rtlCol="0" anchor="ctr"/>
+          <a:lstStyle/>
+          <a:p>
+            <a:pPr algn="ctr"/>
+          </a:p>
+        </p:txBody>
+      </p:sp>
+      <p:sp>
+        <p:nvSpPr>
+          <p:cNvPr id="8" name="TextBox 7"/>
+          <p:cNvSpPr txBox="1"/>
+          <p:nvPr/>
+        </p:nvSpPr>
+        <p:spPr>
+          <a:xfrm>
+            <a:off x="822960" y="1463040"/>
+            <a:ext cx="10241280" cy="4297680"/>
+          </a:xfrm>
+          <a:prstGeom prst="rect">
+            <a:avLst/>
+          </a:prstGeom>
+          <a:noFill/>
+        </p:spPr>
+        <p:txBody>
+          <a:bodyPr wrap="square">
+            <a:normAutofit/>
+          </a:bodyPr>
+          <a:lstStyle/>
+          <a:p>
+            <a:pPr>
+              <a:defRPr sz="1800">
+                <a:solidFill>
+                  <a:srgbClr val="1B2631"/>
+                </a:solidFill>
+                <a:latin typeface="Aptos"/>
+              </a:defRPr>
+            </a:pPr>
+            <a:r>
+              <a:t>Delivered a reproducible AI-based loan risk assessment package.</a:t>
+            </a:r>
+          </a:p>
+          <a:p>
+            <a:pPr>
+              <a:defRPr sz="1800">
+                <a:solidFill>
+                  <a:srgbClr val="1B2631"/>
+                </a:solidFill>
+                <a:latin typeface="Aptos"/>
+              </a:defRPr>
+            </a:pPr>
+            <a:r>
+              <a:t>Credit-scoring benchmark identifies strong transparent baselines.</a:t>
+            </a:r>
+          </a:p>
+          <a:p>
+            <a:pPr>
+              <a:defRPr sz="1800">
+                <a:solidFill>
+                  <a:srgbClr val="1B2631"/>
+                </a:solidFill>
+                <a:latin typeface="Aptos"/>
+              </a:defRPr>
+            </a:pPr>
+            <a:r>
+              <a:t>OCR workflow shows practical document-intake extension potential.</a:t>
+            </a:r>
+          </a:p>
+          <a:p>
+            <a:pPr>
+              <a:defRPr sz="1800">
+                <a:solidFill>
+                  <a:srgbClr val="1B2631"/>
+                </a:solidFill>
+                <a:latin typeface="Aptos"/>
+              </a:defRPr>
+            </a:pPr>
+            <a:r>
+              <a:t>Future work: larger Lending Club experiments, SHAP explanations, scanned-form OCR evaluation, and API deployment.</a:t>
+            </a:r>
+          </a:p>
+        </p:txBody>
+      </p:sp>
+    </p:spTree>
+  </p:cSld>
+  <p:clrMapOvr>
+    <a:masterClrMapping/>
+  </p:clrMapOvr>
+</p:sld>
+</file>
+
+<file path=ppt/slides/slide15.xml><?xml version="1.0" encoding="utf-8"?>
+<p:sld xmlns:a="http://schemas.openxmlformats.org/drawingml/2006/main" xmlns:p="http://schemas.openxmlformats.org/presentationml/2006/main" xmlns:r="http://schemas.openxmlformats.org/officeDocument/2006/relationships">
+  <p:cSld>
+    <p:bg>
+      <p:bgPr>
+        <a:solidFill>
+          <a:srgbClr val="F7F9FB"/>
+        </a:solidFill>
+        <a:effectLst/>
+      </p:bgPr>
+    </p:bg>
+    <p:spTree>
+      <p:nvGrpSpPr>
+        <p:cNvPr id="1" name=""/>
+        <p:cNvGrpSpPr/>
+        <p:nvPr/>
+      </p:nvGrpSpPr>
+      <p:grpSpPr/>
+      <p:sp>
+        <p:nvSpPr>
+          <p:cNvPr id="2" name="Title 1"/>
+          <p:cNvSpPr>
+            <a:spLocks noGrp="1"/>
+          </p:cNvSpPr>
+          <p:nvPr>
+            <p:ph type="title"/>
+          </p:nvPr>
+        </p:nvSpPr>
+        <p:spPr/>
+        <p:txBody>
+          <a:bodyPr/>
+          <a:lstStyle/>
+          <a:p/>
+        </p:txBody>
+      </p:sp>
+      <p:sp>
+        <p:nvSpPr>
+          <p:cNvPr id="3" name="Text Placeholder 2"/>
+          <p:cNvSpPr>
+            <a:spLocks noGrp="1"/>
+          </p:cNvSpPr>
+          <p:nvPr>
+            <p:ph type="body"/>
+          </p:nvPr>
+        </p:nvSpPr>
+        <p:spPr/>
+        <p:txBody>
+          <a:bodyPr/>
+          <a:lstStyle/>
+          <a:p/>
+        </p:txBody>
+      </p:sp>
+      <p:sp>
+        <p:nvSpPr>
+          <p:cNvPr id="4" name="Text Placeholder 3"/>
+          <p:cNvSpPr>
+            <a:spLocks noGrp="1"/>
+          </p:cNvSpPr>
+          <p:nvPr>
+            <p:ph type="body"/>
+          </p:nvPr>
+        </p:nvSpPr>
+        <p:spPr/>
+        <p:txBody>
+          <a:bodyPr/>
+          <a:lstStyle/>
+          <a:p/>
+        </p:txBody>
+      </p:sp>
+      <p:sp>
+        <p:nvSpPr>
+          <p:cNvPr id="5" name="Text Placeholder 4"/>
+          <p:cNvSpPr>
+            <a:spLocks noGrp="1"/>
+          </p:cNvSpPr>
+          <p:nvPr>
+            <p:ph type="body"/>
+          </p:nvPr>
+        </p:nvSpPr>
+        <p:spPr/>
+        <p:txBody>
+          <a:bodyPr/>
+          <a:lstStyle/>
+          <a:p/>
+        </p:txBody>
+      </p:sp>
+      <p:sp>
+        <p:nvSpPr>
+          <p:cNvPr id="6" name="TextBox 5"/>
+          <p:cNvSpPr txBox="1"/>
+          <p:nvPr/>
+        </p:nvSpPr>
+        <p:spPr>
+          <a:xfrm>
             <a:off x="685800" y="1737360"/>
             <a:ext cx="10881360" cy="822960"/>
           </a:xfrm>
@@ -6351,7 +7391,7 @@
         <p:spPr>
           <a:xfrm>
             <a:off x="685800" y="1371600"/>
-            <a:ext cx="10881360" cy="3914536"/>
+            <a:ext cx="10881360" cy="4139126"/>
           </a:xfrm>
           <a:prstGeom prst="rect">
             <a:avLst/>
@@ -7238,7 +8278,7 @@
                 </a:solidFill>
                 <a:latin typeface="Aptos"/>
               </a:rPr>
-              <a:t>Real PaddleOCR Data Pipeline</a:t>
+              <a:t>Precision-Recall Curves</a:t>
             </a:r>
           </a:p>
         </p:txBody>
@@ -7272,7 +8312,7 @@
                 </a:solidFill>
                 <a:latin typeface="Aptos"/>
               </a:rPr>
-              <a:t>SROIE receipts + FUNSD forms converted into PaddleOCR recognition labels.</a:t>
+              <a:t>Shows model behavior under class imbalance and risk-recall tradeoffs.</a:t>
             </a:r>
           </a:p>
         </p:txBody>
@@ -7324,7 +8364,7 @@
       </p:sp>
       <p:pic>
         <p:nvPicPr>
-          <p:cNvPr id="9" name="Picture 8" descr="ocr_workflow_overview.png"/>
+          <p:cNvPr id="9" name="Picture 8" descr="german-credit_pr_curve.png"/>
           <p:cNvPicPr>
             <a:picLocks noChangeAspect="1"/>
           </p:cNvPicPr>
@@ -7338,24 +8378,48 @@
         </p:blipFill>
         <p:spPr>
           <a:xfrm>
-            <a:off x="731520" y="1325880"/>
-            <a:ext cx="6035040" cy="2374130"/>
+            <a:off x="777240" y="1234440"/>
+            <a:ext cx="5166360" cy="3444240"/>
           </a:xfrm>
           <a:prstGeom prst="rect">
             <a:avLst/>
           </a:prstGeom>
         </p:spPr>
       </p:pic>
-      <p:sp>
-        <p:nvSpPr>
-          <p:cNvPr id="10" name="TextBox 9"/>
+      <p:pic>
+        <p:nvPicPr>
+          <p:cNvPr id="10" name="Picture 9" descr="lending-club-sample_pr_curve.png"/>
+          <p:cNvPicPr>
+            <a:picLocks noChangeAspect="1"/>
+          </p:cNvPicPr>
+          <p:nvPr/>
+        </p:nvPicPr>
+        <p:blipFill>
+          <a:blip r:embed="rId3"/>
+          <a:stretch>
+            <a:fillRect/>
+          </a:stretch>
+        </p:blipFill>
+        <p:spPr>
+          <a:xfrm>
+            <a:off x="6263640" y="1234440"/>
+            <a:ext cx="5166360" cy="3444240"/>
+          </a:xfrm>
+          <a:prstGeom prst="rect">
+            <a:avLst/>
+          </a:prstGeom>
+        </p:spPr>
+      </p:pic>
+      <p:sp>
+        <p:nvSpPr>
+          <p:cNvPr id="11" name="TextBox 10"/>
           <p:cNvSpPr txBox="1"/>
           <p:nvPr/>
         </p:nvSpPr>
         <p:spPr>
           <a:xfrm>
-            <a:off x="7132320" y="1600200"/>
-            <a:ext cx="4206240" cy="3383280"/>
+            <a:off x="2514600" y="5715000"/>
+            <a:ext cx="2011680" cy="256032"/>
           </a:xfrm>
           <a:prstGeom prst="rect">
             <a:avLst/>
@@ -7368,55 +8432,48 @@
           </a:bodyPr>
           <a:lstStyle/>
           <a:p>
-            <a:pPr>
-              <a:defRPr sz="1400">
-                <a:solidFill>
-                  <a:srgbClr val="1B2631"/>
+            <a:r>
+              <a:rPr sz="1200" b="1">
+                <a:solidFill>
+                  <a:srgbClr val="566573"/>
                 </a:solidFill>
                 <a:latin typeface="Aptos"/>
-              </a:defRPr>
-            </a:pPr>
-            <a:r>
-              <a:t>Real scanned-document sources: ICDAR2019 SROIE and FUNSD.</a:t>
-            </a:r>
-          </a:p>
-          <a:p>
-            <a:pPr>
-              <a:defRPr sz="1400">
-                <a:solidFill>
-                  <a:srgbClr val="1B2631"/>
+              </a:rPr>
+              <a:t>German Credit</a:t>
+            </a:r>
+          </a:p>
+        </p:txBody>
+      </p:sp>
+      <p:sp>
+        <p:nvSpPr>
+          <p:cNvPr id="12" name="TextBox 11"/>
+          <p:cNvSpPr txBox="1"/>
+          <p:nvPr/>
+        </p:nvSpPr>
+        <p:spPr>
+          <a:xfrm>
+            <a:off x="7818120" y="5715000"/>
+            <a:ext cx="2377440" cy="256032"/>
+          </a:xfrm>
+          <a:prstGeom prst="rect">
+            <a:avLst/>
+          </a:prstGeom>
+          <a:noFill/>
+        </p:spPr>
+        <p:txBody>
+          <a:bodyPr wrap="square">
+            <a:normAutofit/>
+          </a:bodyPr>
+          <a:lstStyle/>
+          <a:p>
+            <a:r>
+              <a:rPr sz="1200" b="1">
+                <a:solidFill>
+                  <a:srgbClr val="566573"/>
                 </a:solidFill>
                 <a:latin typeface="Aptos"/>
-              </a:defRPr>
-            </a:pPr>
-            <a:r>
-              <a:t>Converter exports train/validation/test labels for PaddleOCR SimpleDataSet.</a:t>
-            </a:r>
-          </a:p>
-          <a:p>
-            <a:pPr>
-              <a:defRPr sz="1400">
-                <a:solidFill>
-                  <a:srgbClr val="1B2631"/>
-                </a:solidFill>
-                <a:latin typeface="Aptos"/>
-              </a:defRPr>
-            </a:pPr>
-            <a:r>
-              <a:t>Baseline metrics are included only when generated from saved evaluation artifacts.</a:t>
-            </a:r>
-          </a:p>
-          <a:p>
-            <a:pPr>
-              <a:defRPr sz="1400">
-                <a:solidFill>
-                  <a:srgbClr val="1B2631"/>
-                </a:solidFill>
-                <a:latin typeface="Aptos"/>
-              </a:defRPr>
-            </a:pPr>
-            <a:r>
-              <a:t>Real SROIE/FUNSD OCR pipeline status: prepared_real_dataset. Prepared recognition crops: train: 1200, val: 300, test: 300.</a:t>
+              </a:rPr>
+              <a:t>Lending Club Sample</a:t>
             </a:r>
           </a:p>
         </p:txBody>
@@ -7544,7 +8601,7 @@
                 </a:solidFill>
                 <a:latin typeface="Aptos"/>
               </a:rPr>
-              <a:t>Measured OCR Baseline</a:t>
+              <a:t>Confusion Matrix View</a:t>
             </a:r>
           </a:p>
         </p:txBody>
@@ -7578,7 +8635,7 @@
                 </a:solidFill>
                 <a:latin typeface="Aptos"/>
               </a:rPr>
-              <a:t>Traceable to artifacts/ocr/real_ocr_finetune/baseline.</a:t>
+              <a:t>Held-out decisions shown as approval-risk classification counts.</a:t>
             </a:r>
           </a:p>
         </p:txBody>
@@ -7628,61 +8685,64 @@
           </a:p>
         </p:txBody>
       </p:sp>
-      <p:sp>
-        <p:nvSpPr>
-          <p:cNvPr id="9" name="Rounded Rectangle 8"/>
-          <p:cNvSpPr/>
-          <p:nvPr/>
-        </p:nvSpPr>
-        <p:spPr>
-          <a:xfrm>
-            <a:off x="777240" y="1508760"/>
-            <a:ext cx="2468880" cy="1143000"/>
-          </a:xfrm>
-          <a:prstGeom prst="roundRect">
-            <a:avLst/>
-          </a:prstGeom>
-          <a:solidFill>
-            <a:srgbClr val="FFFFFF"/>
-          </a:solidFill>
-          <a:ln>
-            <a:solidFill>
-              <a:srgbClr val="CCD1D1"/>
-            </a:solidFill>
-          </a:ln>
-        </p:spPr>
-        <p:style>
-          <a:lnRef idx="1">
-            <a:schemeClr val="accent1"/>
-          </a:lnRef>
-          <a:fillRef idx="3">
-            <a:schemeClr val="accent1"/>
-          </a:fillRef>
-          <a:effectRef idx="2">
-            <a:schemeClr val="accent1"/>
-          </a:effectRef>
-          <a:fontRef idx="minor">
-            <a:schemeClr val="lt1"/>
-          </a:fontRef>
-        </p:style>
-        <p:txBody>
-          <a:bodyPr rtlCol="0" anchor="ctr"/>
-          <a:lstStyle/>
-          <a:p>
-            <a:pPr algn="ctr"/>
-          </a:p>
-        </p:txBody>
-      </p:sp>
-      <p:sp>
-        <p:nvSpPr>
-          <p:cNvPr id="10" name="TextBox 9"/>
+      <p:pic>
+        <p:nvPicPr>
+          <p:cNvPr id="9" name="Picture 8" descr="german-credit_confusion_matrix.png"/>
+          <p:cNvPicPr>
+            <a:picLocks noChangeAspect="1"/>
+          </p:cNvPicPr>
+          <p:nvPr/>
+        </p:nvPicPr>
+        <p:blipFill>
+          <a:blip r:embed="rId2"/>
+          <a:stretch>
+            <a:fillRect/>
+          </a:stretch>
+        </p:blipFill>
+        <p:spPr>
+          <a:xfrm>
+            <a:off x="914400" y="1234440"/>
+            <a:ext cx="4572000" cy="3657600"/>
+          </a:xfrm>
+          <a:prstGeom prst="rect">
+            <a:avLst/>
+          </a:prstGeom>
+        </p:spPr>
+      </p:pic>
+      <p:pic>
+        <p:nvPicPr>
+          <p:cNvPr id="10" name="Picture 9" descr="lending-club-sample_confusion_matrix.png"/>
+          <p:cNvPicPr>
+            <a:picLocks noChangeAspect="1"/>
+          </p:cNvPicPr>
+          <p:nvPr/>
+        </p:nvPicPr>
+        <p:blipFill>
+          <a:blip r:embed="rId3"/>
+          <a:stretch>
+            <a:fillRect/>
+          </a:stretch>
+        </p:blipFill>
+        <p:spPr>
+          <a:xfrm>
+            <a:off x="6537960" y="1234440"/>
+            <a:ext cx="4572000" cy="3657600"/>
+          </a:xfrm>
+          <a:prstGeom prst="rect">
+            <a:avLst/>
+          </a:prstGeom>
+        </p:spPr>
+      </p:pic>
+      <p:sp>
+        <p:nvSpPr>
+          <p:cNvPr id="11" name="TextBox 10"/>
           <p:cNvSpPr txBox="1"/>
           <p:nvPr/>
         </p:nvSpPr>
         <p:spPr>
           <a:xfrm>
-            <a:off x="941832" y="1618488"/>
-            <a:ext cx="2139696" cy="256032"/>
+            <a:off x="1005840" y="5806440"/>
+            <a:ext cx="10149840" cy="320040"/>
           </a:xfrm>
           <a:prstGeom prst="rect">
             <a:avLst/>
@@ -7696,448 +8756,13 @@
           <a:lstStyle/>
           <a:p>
             <a:r>
-              <a:rPr sz="1000" b="1">
+              <a:rPr sz="1300" b="0">
                 <a:solidFill>
                   <a:srgbClr val="566573"/>
                 </a:solidFill>
                 <a:latin typeface="Aptos"/>
               </a:rPr>
-              <a:t>Samples</a:t>
-            </a:r>
-          </a:p>
-        </p:txBody>
-      </p:sp>
-      <p:sp>
-        <p:nvSpPr>
-          <p:cNvPr id="11" name="TextBox 10"/>
-          <p:cNvSpPr txBox="1"/>
-          <p:nvPr/>
-        </p:nvSpPr>
-        <p:spPr>
-          <a:xfrm>
-            <a:off x="941832" y="1911095"/>
-            <a:ext cx="2139696" cy="667512"/>
-          </a:xfrm>
-          <a:prstGeom prst="rect">
-            <a:avLst/>
-          </a:prstGeom>
-          <a:noFill/>
-        </p:spPr>
-        <p:txBody>
-          <a:bodyPr wrap="square">
-            <a:normAutofit/>
-          </a:bodyPr>
-          <a:lstStyle/>
-          <a:p>
-            <a:r>
-              <a:rPr sz="2000" b="1">
-                <a:solidFill>
-                  <a:srgbClr val="0B3C5D"/>
-                </a:solidFill>
-                <a:latin typeface="Aptos"/>
-              </a:rPr>
-              <a:t>25</a:t>
-            </a:r>
-          </a:p>
-        </p:txBody>
-      </p:sp>
-      <p:sp>
-        <p:nvSpPr>
-          <p:cNvPr id="12" name="Rounded Rectangle 11"/>
-          <p:cNvSpPr/>
-          <p:nvPr/>
-        </p:nvSpPr>
-        <p:spPr>
-          <a:xfrm>
-            <a:off x="3611880" y="1508760"/>
-            <a:ext cx="2468880" cy="1143000"/>
-          </a:xfrm>
-          <a:prstGeom prst="roundRect">
-            <a:avLst/>
-          </a:prstGeom>
-          <a:solidFill>
-            <a:srgbClr val="FFFFFF"/>
-          </a:solidFill>
-          <a:ln>
-            <a:solidFill>
-              <a:srgbClr val="CCD1D1"/>
-            </a:solidFill>
-          </a:ln>
-        </p:spPr>
-        <p:style>
-          <a:lnRef idx="1">
-            <a:schemeClr val="accent1"/>
-          </a:lnRef>
-          <a:fillRef idx="3">
-            <a:schemeClr val="accent1"/>
-          </a:fillRef>
-          <a:effectRef idx="2">
-            <a:schemeClr val="accent1"/>
-          </a:effectRef>
-          <a:fontRef idx="minor">
-            <a:schemeClr val="lt1"/>
-          </a:fontRef>
-        </p:style>
-        <p:txBody>
-          <a:bodyPr rtlCol="0" anchor="ctr"/>
-          <a:lstStyle/>
-          <a:p>
-            <a:pPr algn="ctr"/>
-          </a:p>
-        </p:txBody>
-      </p:sp>
-      <p:sp>
-        <p:nvSpPr>
-          <p:cNvPr id="13" name="TextBox 12"/>
-          <p:cNvSpPr txBox="1"/>
-          <p:nvPr/>
-        </p:nvSpPr>
-        <p:spPr>
-          <a:xfrm>
-            <a:off x="3776472" y="1618488"/>
-            <a:ext cx="2139696" cy="256032"/>
-          </a:xfrm>
-          <a:prstGeom prst="rect">
-            <a:avLst/>
-          </a:prstGeom>
-          <a:noFill/>
-        </p:spPr>
-        <p:txBody>
-          <a:bodyPr wrap="square">
-            <a:normAutofit/>
-          </a:bodyPr>
-          <a:lstStyle/>
-          <a:p>
-            <a:r>
-              <a:rPr sz="1000" b="1">
-                <a:solidFill>
-                  <a:srgbClr val="566573"/>
-                </a:solidFill>
-                <a:latin typeface="Aptos"/>
-              </a:rPr>
-              <a:t>CER</a:t>
-            </a:r>
-          </a:p>
-        </p:txBody>
-      </p:sp>
-      <p:sp>
-        <p:nvSpPr>
-          <p:cNvPr id="14" name="TextBox 13"/>
-          <p:cNvSpPr txBox="1"/>
-          <p:nvPr/>
-        </p:nvSpPr>
-        <p:spPr>
-          <a:xfrm>
-            <a:off x="3776472" y="1911095"/>
-            <a:ext cx="2139696" cy="667512"/>
-          </a:xfrm>
-          <a:prstGeom prst="rect">
-            <a:avLst/>
-          </a:prstGeom>
-          <a:noFill/>
-        </p:spPr>
-        <p:txBody>
-          <a:bodyPr wrap="square">
-            <a:normAutofit/>
-          </a:bodyPr>
-          <a:lstStyle/>
-          <a:p>
-            <a:r>
-              <a:rPr sz="2000" b="1">
-                <a:solidFill>
-                  <a:srgbClr val="0B3C5D"/>
-                </a:solidFill>
-                <a:latin typeface="Aptos"/>
-              </a:rPr>
-              <a:t>0.110</a:t>
-            </a:r>
-          </a:p>
-        </p:txBody>
-      </p:sp>
-      <p:sp>
-        <p:nvSpPr>
-          <p:cNvPr id="15" name="Rounded Rectangle 14"/>
-          <p:cNvSpPr/>
-          <p:nvPr/>
-        </p:nvSpPr>
-        <p:spPr>
-          <a:xfrm>
-            <a:off x="6446520" y="1508760"/>
-            <a:ext cx="2468880" cy="1143000"/>
-          </a:xfrm>
-          <a:prstGeom prst="roundRect">
-            <a:avLst/>
-          </a:prstGeom>
-          <a:solidFill>
-            <a:srgbClr val="FFFFFF"/>
-          </a:solidFill>
-          <a:ln>
-            <a:solidFill>
-              <a:srgbClr val="CCD1D1"/>
-            </a:solidFill>
-          </a:ln>
-        </p:spPr>
-        <p:style>
-          <a:lnRef idx="1">
-            <a:schemeClr val="accent1"/>
-          </a:lnRef>
-          <a:fillRef idx="3">
-            <a:schemeClr val="accent1"/>
-          </a:fillRef>
-          <a:effectRef idx="2">
-            <a:schemeClr val="accent1"/>
-          </a:effectRef>
-          <a:fontRef idx="minor">
-            <a:schemeClr val="lt1"/>
-          </a:fontRef>
-        </p:style>
-        <p:txBody>
-          <a:bodyPr rtlCol="0" anchor="ctr"/>
-          <a:lstStyle/>
-          <a:p>
-            <a:pPr algn="ctr"/>
-          </a:p>
-        </p:txBody>
-      </p:sp>
-      <p:sp>
-        <p:nvSpPr>
-          <p:cNvPr id="16" name="TextBox 15"/>
-          <p:cNvSpPr txBox="1"/>
-          <p:nvPr/>
-        </p:nvSpPr>
-        <p:spPr>
-          <a:xfrm>
-            <a:off x="6611112" y="1618488"/>
-            <a:ext cx="2139696" cy="256032"/>
-          </a:xfrm>
-          <a:prstGeom prst="rect">
-            <a:avLst/>
-          </a:prstGeom>
-          <a:noFill/>
-        </p:spPr>
-        <p:txBody>
-          <a:bodyPr wrap="square">
-            <a:normAutofit/>
-          </a:bodyPr>
-          <a:lstStyle/>
-          <a:p>
-            <a:r>
-              <a:rPr sz="1000" b="1">
-                <a:solidFill>
-                  <a:srgbClr val="566573"/>
-                </a:solidFill>
-                <a:latin typeface="Aptos"/>
-              </a:rPr>
-              <a:t>Word Accuracy</a:t>
-            </a:r>
-          </a:p>
-        </p:txBody>
-      </p:sp>
-      <p:sp>
-        <p:nvSpPr>
-          <p:cNvPr id="17" name="TextBox 16"/>
-          <p:cNvSpPr txBox="1"/>
-          <p:nvPr/>
-        </p:nvSpPr>
-        <p:spPr>
-          <a:xfrm>
-            <a:off x="6611112" y="1911095"/>
-            <a:ext cx="2139696" cy="667512"/>
-          </a:xfrm>
-          <a:prstGeom prst="rect">
-            <a:avLst/>
-          </a:prstGeom>
-          <a:noFill/>
-        </p:spPr>
-        <p:txBody>
-          <a:bodyPr wrap="square">
-            <a:normAutofit/>
-          </a:bodyPr>
-          <a:lstStyle/>
-          <a:p>
-            <a:r>
-              <a:rPr sz="2000" b="1">
-                <a:solidFill>
-                  <a:srgbClr val="0B3C5D"/>
-                </a:solidFill>
-                <a:latin typeface="Aptos"/>
-              </a:rPr>
-              <a:t>0.691</a:t>
-            </a:r>
-          </a:p>
-        </p:txBody>
-      </p:sp>
-      <p:sp>
-        <p:nvSpPr>
-          <p:cNvPr id="18" name="Rounded Rectangle 17"/>
-          <p:cNvSpPr/>
-          <p:nvPr/>
-        </p:nvSpPr>
-        <p:spPr>
-          <a:xfrm>
-            <a:off x="9281160" y="1508760"/>
-            <a:ext cx="2468880" cy="1143000"/>
-          </a:xfrm>
-          <a:prstGeom prst="roundRect">
-            <a:avLst/>
-          </a:prstGeom>
-          <a:solidFill>
-            <a:srgbClr val="FFFFFF"/>
-          </a:solidFill>
-          <a:ln>
-            <a:solidFill>
-              <a:srgbClr val="CCD1D1"/>
-            </a:solidFill>
-          </a:ln>
-        </p:spPr>
-        <p:style>
-          <a:lnRef idx="1">
-            <a:schemeClr val="accent1"/>
-          </a:lnRef>
-          <a:fillRef idx="3">
-            <a:schemeClr val="accent1"/>
-          </a:fillRef>
-          <a:effectRef idx="2">
-            <a:schemeClr val="accent1"/>
-          </a:effectRef>
-          <a:fontRef idx="minor">
-            <a:schemeClr val="lt1"/>
-          </a:fontRef>
-        </p:style>
-        <p:txBody>
-          <a:bodyPr rtlCol="0" anchor="ctr"/>
-          <a:lstStyle/>
-          <a:p>
-            <a:pPr algn="ctr"/>
-          </a:p>
-        </p:txBody>
-      </p:sp>
-      <p:sp>
-        <p:nvSpPr>
-          <p:cNvPr id="19" name="TextBox 18"/>
-          <p:cNvSpPr txBox="1"/>
-          <p:nvPr/>
-        </p:nvSpPr>
-        <p:spPr>
-          <a:xfrm>
-            <a:off x="9445752" y="1618488"/>
-            <a:ext cx="2139696" cy="256032"/>
-          </a:xfrm>
-          <a:prstGeom prst="rect">
-            <a:avLst/>
-          </a:prstGeom>
-          <a:noFill/>
-        </p:spPr>
-        <p:txBody>
-          <a:bodyPr wrap="square">
-            <a:normAutofit/>
-          </a:bodyPr>
-          <a:lstStyle/>
-          <a:p>
-            <a:r>
-              <a:rPr sz="1000" b="1">
-                <a:solidFill>
-                  <a:srgbClr val="566573"/>
-                </a:solidFill>
-                <a:latin typeface="Aptos"/>
-              </a:rPr>
-              <a:t>Exact Match</a:t>
-            </a:r>
-          </a:p>
-        </p:txBody>
-      </p:sp>
-      <p:sp>
-        <p:nvSpPr>
-          <p:cNvPr id="20" name="TextBox 19"/>
-          <p:cNvSpPr txBox="1"/>
-          <p:nvPr/>
-        </p:nvSpPr>
-        <p:spPr>
-          <a:xfrm>
-            <a:off x="9445752" y="1911095"/>
-            <a:ext cx="2139696" cy="667512"/>
-          </a:xfrm>
-          <a:prstGeom prst="rect">
-            <a:avLst/>
-          </a:prstGeom>
-          <a:noFill/>
-        </p:spPr>
-        <p:txBody>
-          <a:bodyPr wrap="square">
-            <a:normAutofit/>
-          </a:bodyPr>
-          <a:lstStyle/>
-          <a:p>
-            <a:r>
-              <a:rPr sz="2000" b="1">
-                <a:solidFill>
-                  <a:srgbClr val="0B3C5D"/>
-                </a:solidFill>
-                <a:latin typeface="Aptos"/>
-              </a:rPr>
-              <a:t>0.440</a:t>
-            </a:r>
-          </a:p>
-        </p:txBody>
-      </p:sp>
-      <p:sp>
-        <p:nvSpPr>
-          <p:cNvPr id="21" name="TextBox 20"/>
-          <p:cNvSpPr txBox="1"/>
-          <p:nvPr/>
-        </p:nvSpPr>
-        <p:spPr>
-          <a:xfrm>
-            <a:off x="914400" y="3291840"/>
-            <a:ext cx="10241280" cy="1828800"/>
-          </a:xfrm>
-          <a:prstGeom prst="rect">
-            <a:avLst/>
-          </a:prstGeom>
-          <a:noFill/>
-        </p:spPr>
-        <p:txBody>
-          <a:bodyPr wrap="square">
-            <a:normAutofit/>
-          </a:bodyPr>
-          <a:lstStyle/>
-          <a:p>
-            <a:pPr>
-              <a:defRPr sz="1700">
-                <a:solidFill>
-                  <a:srgbClr val="1B2631"/>
-                </a:solidFill>
-                <a:latin typeface="Aptos"/>
-              </a:defRPr>
-            </a:pPr>
-            <a:r>
-              <a:t>Evaluation uses held-out real scanned-document crops prepared from public datasets.</a:t>
-            </a:r>
-          </a:p>
-          <a:p>
-            <a:pPr>
-              <a:defRPr sz="1700">
-                <a:solidFill>
-                  <a:srgbClr val="1B2631"/>
-                </a:solidFill>
-                <a:latin typeface="Aptos"/>
-              </a:defRPr>
-            </a:pPr>
-            <a:r>
-              <a:t>The same test labels can be reused after fine-tuning for baseline-vs-fine-tuned comparison.</a:t>
-            </a:r>
-          </a:p>
-          <a:p>
-            <a:pPr>
-              <a:defRPr sz="1700">
-                <a:solidFill>
-                  <a:srgbClr val="1B2631"/>
-                </a:solidFill>
-                <a:latin typeface="Aptos"/>
-              </a:defRPr>
-            </a:pPr>
-            <a:r>
-              <a:t>Borrower-document deployment should add privacy-reviewed labeled financial forms.</a:t>
+              <a:t>These matrices make the false-positive and false-negative tradeoff visible for viva discussion.</a:t>
             </a:r>
           </a:p>
         </p:txBody>
@@ -8265,14 +8890,48 @@
                 </a:solidFill>
                 <a:latin typeface="Aptos"/>
               </a:rPr>
-              <a:t>Explainability And Traceability</a:t>
-            </a:r>
-          </a:p>
-        </p:txBody>
-      </p:sp>
-      <p:sp>
-        <p:nvSpPr>
-          <p:cNvPr id="7" name="Rectangle 6"/>
+              <a:t>Real PaddleOCR Data Pipeline</a:t>
+            </a:r>
+          </a:p>
+        </p:txBody>
+      </p:sp>
+      <p:sp>
+        <p:nvSpPr>
+          <p:cNvPr id="7" name="TextBox 6"/>
+          <p:cNvSpPr txBox="1"/>
+          <p:nvPr/>
+        </p:nvSpPr>
+        <p:spPr>
+          <a:xfrm>
+            <a:off x="530352" y="786384"/>
+            <a:ext cx="10607040" cy="292608"/>
+          </a:xfrm>
+          <a:prstGeom prst="rect">
+            <a:avLst/>
+          </a:prstGeom>
+          <a:noFill/>
+        </p:spPr>
+        <p:txBody>
+          <a:bodyPr wrap="square">
+            <a:normAutofit/>
+          </a:bodyPr>
+          <a:lstStyle/>
+          <a:p>
+            <a:r>
+              <a:rPr sz="1100" b="0">
+                <a:solidFill>
+                  <a:srgbClr val="566573"/>
+                </a:solidFill>
+                <a:latin typeface="Aptos"/>
+              </a:rPr>
+              <a:t>SROIE receipts + FUNSD forms converted into PaddleOCR recognition labels.</a:t>
+            </a:r>
+          </a:p>
+        </p:txBody>
+      </p:sp>
+      <p:sp>
+        <p:nvSpPr>
+          <p:cNvPr id="8" name="Rectangle 7"/>
           <p:cNvSpPr/>
           <p:nvPr/>
         </p:nvSpPr>
@@ -8317,7 +8976,7 @@
       </p:sp>
       <p:pic>
         <p:nvPicPr>
-          <p:cNvPr id="8" name="Picture 7" descr="german-credit_feature_importance.png"/>
+          <p:cNvPr id="9" name="Picture 8" descr="ocr_workflow_overview.png"/>
           <p:cNvPicPr>
             <a:picLocks noChangeAspect="1"/>
           </p:cNvPicPr>
@@ -8332,7 +8991,7 @@
         <p:spPr>
           <a:xfrm>
             <a:off x="731520" y="1325880"/>
-            <a:ext cx="5212080" cy="3257550"/>
+            <a:ext cx="6035040" cy="2318176"/>
           </a:xfrm>
           <a:prstGeom prst="rect">
             <a:avLst/>
@@ -8341,14 +9000,14 @@
       </p:pic>
       <p:sp>
         <p:nvSpPr>
-          <p:cNvPr id="9" name="TextBox 8"/>
+          <p:cNvPr id="10" name="TextBox 9"/>
           <p:cNvSpPr txBox="1"/>
           <p:nvPr/>
         </p:nvSpPr>
         <p:spPr>
           <a:xfrm>
-            <a:off x="6446520" y="1645920"/>
-            <a:ext cx="4754880" cy="3108960"/>
+            <a:off x="7132320" y="1600200"/>
+            <a:ext cx="4206240" cy="3383280"/>
           </a:xfrm>
           <a:prstGeom prst="rect">
             <a:avLst/>
@@ -8362,7 +9021,7 @@
           <a:lstStyle/>
           <a:p>
             <a:pPr>
-              <a:defRPr sz="1700">
+              <a:defRPr sz="1400">
                 <a:solidFill>
                   <a:srgbClr val="1B2631"/>
                 </a:solidFill>
@@ -8370,12 +9029,12 @@
               </a:defRPr>
             </a:pPr>
             <a:r>
-              <a:t>Feature-importance artifacts are generated for every benchmark run.</a:t>
+              <a:t>Real scanned-document sources: ICDAR2019 SROIE and FUNSD.</a:t>
             </a:r>
           </a:p>
           <a:p>
             <a:pPr>
-              <a:defRPr sz="1700">
+              <a:defRPr sz="1400">
                 <a:solidFill>
                   <a:srgbClr val="1B2631"/>
                 </a:solidFill>
@@ -8383,12 +9042,12 @@
               </a:defRPr>
             </a:pPr>
             <a:r>
-              <a:t>Metrics are exported as JSON and summarized in CSV.</a:t>
+              <a:t>Converter exports train/validation/test labels for PaddleOCR SimpleDataSet.</a:t>
             </a:r>
           </a:p>
           <a:p>
             <a:pPr>
-              <a:defRPr sz="1700">
+              <a:defRPr sz="1400">
                 <a:solidFill>
                   <a:srgbClr val="1B2631"/>
                 </a:solidFill>
@@ -8396,7 +9055,20 @@
               </a:defRPr>
             </a:pPr>
             <a:r>
-              <a:t>Final report values can be traced to saved repository artifacts.</a:t>
+              <a:t>Baseline metrics are included only when generated from saved evaluation artifacts.</a:t>
+            </a:r>
+          </a:p>
+          <a:p>
+            <a:pPr>
+              <a:defRPr sz="1400">
+                <a:solidFill>
+                  <a:srgbClr val="1B2631"/>
+                </a:solidFill>
+                <a:latin typeface="Aptos"/>
+              </a:defRPr>
+            </a:pPr>
+            <a:r>
+              <a:t>Real SROIE/FUNSD OCR pipeline status: prepared_real_dataset. Prepared recognition crops: train: 1200, val: 300, test: 300.</a:t>
             </a:r>
           </a:p>
         </p:txBody>

</xml_diff>